<commit_message>
Audit trail, batch mode, sturdier classifier and updated slides
Classifier now handles wording outside the generator's templates (15/15 on
hand-written emails, was 10/15) while staying at 1.0000 on five datasets.

Co-Authored-By: Claude Sonnet 5 <noreply@anthropic.com>
</commit_message>
<xml_diff>
--- a/docs/SDOC_slides.pptx
+++ b/docs/SDOC_slides.pptx
@@ -14,6 +14,7 @@
     <p:sldId id="262" r:id="rId13"/>
     <p:sldId id="263" r:id="rId14"/>
     <p:sldId id="264" r:id="rId15"/>
+    <p:sldId id="265" r:id="rId16"/>
   </p:sldIdLst>
   <p:sldSz cx="12191695" cy="6858000" type="screen4x3"/>
   <p:notesSz cx="6858000" cy="9144000"/>
@@ -3348,6 +3349,818 @@
 </p:sld>
 </file>
 
+<file path=ppt/slides/slide10.xml><?xml version="1.0" encoding="utf-8"?>
+<p:sld xmlns:a="http://schemas.openxmlformats.org/drawingml/2006/main" xmlns:p="http://schemas.openxmlformats.org/presentationml/2006/main" xmlns:r="http://schemas.openxmlformats.org/officeDocument/2006/relationships">
+  <p:cSld>
+    <p:spTree>
+      <p:nvGrpSpPr>
+        <p:cNvPr id="1" name=""/>
+        <p:cNvGrpSpPr/>
+        <p:nvPr/>
+      </p:nvGrpSpPr>
+      <p:grpSpPr/>
+      <p:sp>
+        <p:nvSpPr>
+          <p:cNvPr id="2" name="Rectangle 1"/>
+          <p:cNvSpPr/>
+          <p:nvPr/>
+        </p:nvSpPr>
+        <p:spPr>
+          <a:xfrm>
+            <a:off x="0" y="0"/>
+            <a:ext cx="12191695" cy="109728"/>
+          </a:xfrm>
+          <a:prstGeom prst="rect">
+            <a:avLst/>
+          </a:prstGeom>
+          <a:solidFill>
+            <a:srgbClr val="0E9F9A"/>
+          </a:solidFill>
+          <a:ln>
+            <a:noFill/>
+          </a:ln>
+          <a:effectLst/>
+        </p:spPr>
+        <p:style>
+          <a:lnRef idx="1">
+            <a:schemeClr val="accent1"/>
+          </a:lnRef>
+          <a:fillRef idx="3">
+            <a:schemeClr val="accent1"/>
+          </a:fillRef>
+          <a:effectRef idx="2">
+            <a:schemeClr val="accent1"/>
+          </a:effectRef>
+          <a:fontRef idx="minor">
+            <a:schemeClr val="lt1"/>
+          </a:fontRef>
+        </p:style>
+        <p:txBody>
+          <a:bodyPr rtlCol="0" anchor="ctr"/>
+          <a:lstStyle/>
+          <a:p>
+            <a:pPr algn="ctr"/>
+          </a:p>
+        </p:txBody>
+      </p:sp>
+      <p:sp>
+        <p:nvSpPr>
+          <p:cNvPr id="3" name="TextBox 2"/>
+          <p:cNvSpPr txBox="1"/>
+          <p:nvPr/>
+        </p:nvSpPr>
+        <p:spPr>
+          <a:xfrm>
+            <a:off x="640080" y="320040"/>
+            <a:ext cx="9144000" cy="320040"/>
+          </a:xfrm>
+          <a:prstGeom prst="rect">
+            <a:avLst/>
+          </a:prstGeom>
+          <a:noFill/>
+        </p:spPr>
+        <p:txBody>
+          <a:bodyPr wrap="square" anchor="t">
+            <a:spAutoFit/>
+          </a:bodyPr>
+          <a:lstStyle/>
+          <a:p>
+            <a:pPr algn="l">
+              <a:spcAft>
+                <a:spcPts val="600"/>
+              </a:spcAft>
+            </a:pPr>
+            <a:r>
+              <a:rPr sz="1200" b="1">
+                <a:solidFill>
+                  <a:srgbClr val="0E9F9A"/>
+                </a:solidFill>
+                <a:latin typeface="Calibri"/>
+              </a:rPr>
+              <a:t>FUTURE ROADMAP</a:t>
+            </a:r>
+          </a:p>
+        </p:txBody>
+      </p:sp>
+      <p:sp>
+        <p:nvSpPr>
+          <p:cNvPr id="4" name="TextBox 3"/>
+          <p:cNvSpPr txBox="1"/>
+          <p:nvPr/>
+        </p:nvSpPr>
+        <p:spPr>
+          <a:xfrm>
+            <a:off x="640080" y="594360"/>
+            <a:ext cx="10972800" cy="822960"/>
+          </a:xfrm>
+          <a:prstGeom prst="rect">
+            <a:avLst/>
+          </a:prstGeom>
+          <a:noFill/>
+        </p:spPr>
+        <p:txBody>
+          <a:bodyPr wrap="square" anchor="t">
+            <a:spAutoFit/>
+          </a:bodyPr>
+          <a:lstStyle/>
+          <a:p>
+            <a:pPr algn="l">
+              <a:spcAft>
+                <a:spcPts val="600"/>
+              </a:spcAft>
+            </a:pPr>
+            <a:r>
+              <a:rPr sz="3200" b="1">
+                <a:solidFill>
+                  <a:srgbClr val="0B1F3A"/>
+                </a:solidFill>
+                <a:latin typeface="Calibri"/>
+              </a:rPr>
+              <a:t>Where this goes next</a:t>
+            </a:r>
+          </a:p>
+        </p:txBody>
+      </p:sp>
+      <p:sp>
+        <p:nvSpPr>
+          <p:cNvPr id="5" name="Rounded Rectangle 4"/>
+          <p:cNvSpPr/>
+          <p:nvPr/>
+        </p:nvSpPr>
+        <p:spPr>
+          <a:xfrm>
+            <a:off x="640080" y="1737360"/>
+            <a:ext cx="5394960" cy="1920240"/>
+          </a:xfrm>
+          <a:prstGeom prst="roundRect">
+            <a:avLst>
+              <a:gd name="adj" fmla="val 8000"/>
+            </a:avLst>
+          </a:prstGeom>
+          <a:solidFill>
+            <a:srgbClr val="EEF4F7"/>
+          </a:solidFill>
+          <a:ln>
+            <a:noFill/>
+          </a:ln>
+          <a:effectLst/>
+        </p:spPr>
+        <p:style>
+          <a:lnRef idx="1">
+            <a:schemeClr val="accent1"/>
+          </a:lnRef>
+          <a:fillRef idx="3">
+            <a:schemeClr val="accent1"/>
+          </a:fillRef>
+          <a:effectRef idx="2">
+            <a:schemeClr val="accent1"/>
+          </a:effectRef>
+          <a:fontRef idx="minor">
+            <a:schemeClr val="lt1"/>
+          </a:fontRef>
+        </p:style>
+        <p:txBody>
+          <a:bodyPr rtlCol="0" anchor="ctr"/>
+          <a:lstStyle/>
+          <a:p>
+            <a:pPr algn="ctr"/>
+          </a:p>
+        </p:txBody>
+      </p:sp>
+      <p:sp>
+        <p:nvSpPr>
+          <p:cNvPr id="6" name="Rectangle 5"/>
+          <p:cNvSpPr/>
+          <p:nvPr/>
+        </p:nvSpPr>
+        <p:spPr>
+          <a:xfrm>
+            <a:off x="640080" y="1737360"/>
+            <a:ext cx="73152" cy="1920240"/>
+          </a:xfrm>
+          <a:prstGeom prst="rect">
+            <a:avLst/>
+          </a:prstGeom>
+          <a:solidFill>
+            <a:srgbClr val="0E9F9A"/>
+          </a:solidFill>
+          <a:ln>
+            <a:noFill/>
+          </a:ln>
+          <a:effectLst/>
+        </p:spPr>
+        <p:style>
+          <a:lnRef idx="1">
+            <a:schemeClr val="accent1"/>
+          </a:lnRef>
+          <a:fillRef idx="3">
+            <a:schemeClr val="accent1"/>
+          </a:fillRef>
+          <a:effectRef idx="2">
+            <a:schemeClr val="accent1"/>
+          </a:effectRef>
+          <a:fontRef idx="minor">
+            <a:schemeClr val="lt1"/>
+          </a:fontRef>
+        </p:style>
+        <p:txBody>
+          <a:bodyPr rtlCol="0" anchor="ctr"/>
+          <a:lstStyle/>
+          <a:p>
+            <a:pPr algn="ctr"/>
+          </a:p>
+        </p:txBody>
+      </p:sp>
+      <p:sp>
+        <p:nvSpPr>
+          <p:cNvPr id="7" name="TextBox 6"/>
+          <p:cNvSpPr txBox="1"/>
+          <p:nvPr/>
+        </p:nvSpPr>
+        <p:spPr>
+          <a:xfrm>
+            <a:off x="868680" y="1847088"/>
+            <a:ext cx="5029200" cy="457200"/>
+          </a:xfrm>
+          <a:prstGeom prst="rect">
+            <a:avLst/>
+          </a:prstGeom>
+          <a:noFill/>
+        </p:spPr>
+        <p:txBody>
+          <a:bodyPr wrap="square" anchor="t">
+            <a:spAutoFit/>
+          </a:bodyPr>
+          <a:lstStyle/>
+          <a:p>
+            <a:pPr algn="l">
+              <a:spcAft>
+                <a:spcPts val="600"/>
+              </a:spcAft>
+            </a:pPr>
+            <a:r>
+              <a:rPr sz="1700" b="1">
+                <a:solidFill>
+                  <a:srgbClr val="0B1F3A"/>
+                </a:solidFill>
+                <a:latin typeface="Calibri"/>
+              </a:rPr>
+              <a:t>More documents</a:t>
+            </a:r>
+          </a:p>
+        </p:txBody>
+      </p:sp>
+      <p:sp>
+        <p:nvSpPr>
+          <p:cNvPr id="8" name="TextBox 7"/>
+          <p:cNvSpPr txBox="1"/>
+          <p:nvPr/>
+        </p:nvSpPr>
+        <p:spPr>
+          <a:xfrm>
+            <a:off x="868680" y="2304288"/>
+            <a:ext cx="5029200" cy="1280160"/>
+          </a:xfrm>
+          <a:prstGeom prst="rect">
+            <a:avLst/>
+          </a:prstGeom>
+          <a:noFill/>
+        </p:spPr>
+        <p:txBody>
+          <a:bodyPr wrap="square" anchor="t">
+            <a:spAutoFit/>
+          </a:bodyPr>
+          <a:lstStyle/>
+          <a:p>
+            <a:pPr algn="l">
+              <a:spcAft>
+                <a:spcPts val="600"/>
+              </a:spcAft>
+            </a:pPr>
+            <a:r>
+              <a:rPr sz="1500" b="0">
+                <a:solidFill>
+                  <a:srgbClr val="1F2937"/>
+                </a:solidFill>
+                <a:latin typeface="Calibri"/>
+              </a:rPr>
+              <a:t>Invoices, packing lists and certificates of origin.</a:t>
+            </a:r>
+          </a:p>
+        </p:txBody>
+      </p:sp>
+      <p:sp>
+        <p:nvSpPr>
+          <p:cNvPr id="9" name="Rounded Rectangle 8"/>
+          <p:cNvSpPr/>
+          <p:nvPr/>
+        </p:nvSpPr>
+        <p:spPr>
+          <a:xfrm>
+            <a:off x="6217920" y="1737360"/>
+            <a:ext cx="5394960" cy="1920240"/>
+          </a:xfrm>
+          <a:prstGeom prst="roundRect">
+            <a:avLst>
+              <a:gd name="adj" fmla="val 8000"/>
+            </a:avLst>
+          </a:prstGeom>
+          <a:solidFill>
+            <a:srgbClr val="EEF4F7"/>
+          </a:solidFill>
+          <a:ln>
+            <a:noFill/>
+          </a:ln>
+          <a:effectLst/>
+        </p:spPr>
+        <p:style>
+          <a:lnRef idx="1">
+            <a:schemeClr val="accent1"/>
+          </a:lnRef>
+          <a:fillRef idx="3">
+            <a:schemeClr val="accent1"/>
+          </a:fillRef>
+          <a:effectRef idx="2">
+            <a:schemeClr val="accent1"/>
+          </a:effectRef>
+          <a:fontRef idx="minor">
+            <a:schemeClr val="lt1"/>
+          </a:fontRef>
+        </p:style>
+        <p:txBody>
+          <a:bodyPr rtlCol="0" anchor="ctr"/>
+          <a:lstStyle/>
+          <a:p>
+            <a:pPr algn="ctr"/>
+          </a:p>
+        </p:txBody>
+      </p:sp>
+      <p:sp>
+        <p:nvSpPr>
+          <p:cNvPr id="10" name="Rectangle 9"/>
+          <p:cNvSpPr/>
+          <p:nvPr/>
+        </p:nvSpPr>
+        <p:spPr>
+          <a:xfrm>
+            <a:off x="6217920" y="1737360"/>
+            <a:ext cx="73152" cy="1920240"/>
+          </a:xfrm>
+          <a:prstGeom prst="rect">
+            <a:avLst/>
+          </a:prstGeom>
+          <a:solidFill>
+            <a:srgbClr val="0E9F9A"/>
+          </a:solidFill>
+          <a:ln>
+            <a:noFill/>
+          </a:ln>
+          <a:effectLst/>
+        </p:spPr>
+        <p:style>
+          <a:lnRef idx="1">
+            <a:schemeClr val="accent1"/>
+          </a:lnRef>
+          <a:fillRef idx="3">
+            <a:schemeClr val="accent1"/>
+          </a:fillRef>
+          <a:effectRef idx="2">
+            <a:schemeClr val="accent1"/>
+          </a:effectRef>
+          <a:fontRef idx="minor">
+            <a:schemeClr val="lt1"/>
+          </a:fontRef>
+        </p:style>
+        <p:txBody>
+          <a:bodyPr rtlCol="0" anchor="ctr"/>
+          <a:lstStyle/>
+          <a:p>
+            <a:pPr algn="ctr"/>
+          </a:p>
+        </p:txBody>
+      </p:sp>
+      <p:sp>
+        <p:nvSpPr>
+          <p:cNvPr id="11" name="TextBox 10"/>
+          <p:cNvSpPr txBox="1"/>
+          <p:nvPr/>
+        </p:nvSpPr>
+        <p:spPr>
+          <a:xfrm>
+            <a:off x="6446520" y="1847088"/>
+            <a:ext cx="5029200" cy="457200"/>
+          </a:xfrm>
+          <a:prstGeom prst="rect">
+            <a:avLst/>
+          </a:prstGeom>
+          <a:noFill/>
+        </p:spPr>
+        <p:txBody>
+          <a:bodyPr wrap="square" anchor="t">
+            <a:spAutoFit/>
+          </a:bodyPr>
+          <a:lstStyle/>
+          <a:p>
+            <a:pPr algn="l">
+              <a:spcAft>
+                <a:spcPts val="600"/>
+              </a:spcAft>
+            </a:pPr>
+            <a:r>
+              <a:rPr sz="1700" b="1">
+                <a:solidFill>
+                  <a:srgbClr val="0B1F3A"/>
+                </a:solidFill>
+                <a:latin typeface="Calibri"/>
+              </a:rPr>
+              <a:t>More fields</a:t>
+            </a:r>
+          </a:p>
+        </p:txBody>
+      </p:sp>
+      <p:sp>
+        <p:nvSpPr>
+          <p:cNvPr id="12" name="TextBox 11"/>
+          <p:cNvSpPr txBox="1"/>
+          <p:nvPr/>
+        </p:nvSpPr>
+        <p:spPr>
+          <a:xfrm>
+            <a:off x="6446520" y="2304288"/>
+            <a:ext cx="5029200" cy="1280160"/>
+          </a:xfrm>
+          <a:prstGeom prst="rect">
+            <a:avLst/>
+          </a:prstGeom>
+          <a:noFill/>
+        </p:spPr>
+        <p:txBody>
+          <a:bodyPr wrap="square" anchor="t">
+            <a:spAutoFit/>
+          </a:bodyPr>
+          <a:lstStyle/>
+          <a:p>
+            <a:pPr algn="l">
+              <a:spcAft>
+                <a:spcPts val="600"/>
+              </a:spcAft>
+            </a:pPr>
+            <a:r>
+              <a:rPr sz="1500" b="0">
+                <a:solidFill>
+                  <a:srgbClr val="1F2937"/>
+                </a:solidFill>
+                <a:latin typeface="Calibri"/>
+              </a:rPr>
+              <a:t>Vessel, voyage, cargo description and HS code.</a:t>
+            </a:r>
+          </a:p>
+        </p:txBody>
+      </p:sp>
+      <p:sp>
+        <p:nvSpPr>
+          <p:cNvPr id="13" name="Rounded Rectangle 12"/>
+          <p:cNvSpPr/>
+          <p:nvPr/>
+        </p:nvSpPr>
+        <p:spPr>
+          <a:xfrm>
+            <a:off x="640080" y="3931920"/>
+            <a:ext cx="5394960" cy="1920240"/>
+          </a:xfrm>
+          <a:prstGeom prst="roundRect">
+            <a:avLst>
+              <a:gd name="adj" fmla="val 8000"/>
+            </a:avLst>
+          </a:prstGeom>
+          <a:solidFill>
+            <a:srgbClr val="EEF4F7"/>
+          </a:solidFill>
+          <a:ln>
+            <a:noFill/>
+          </a:ln>
+          <a:effectLst/>
+        </p:spPr>
+        <p:style>
+          <a:lnRef idx="1">
+            <a:schemeClr val="accent1"/>
+          </a:lnRef>
+          <a:fillRef idx="3">
+            <a:schemeClr val="accent1"/>
+          </a:fillRef>
+          <a:effectRef idx="2">
+            <a:schemeClr val="accent1"/>
+          </a:effectRef>
+          <a:fontRef idx="minor">
+            <a:schemeClr val="lt1"/>
+          </a:fontRef>
+        </p:style>
+        <p:txBody>
+          <a:bodyPr rtlCol="0" anchor="ctr"/>
+          <a:lstStyle/>
+          <a:p>
+            <a:pPr algn="ctr"/>
+          </a:p>
+        </p:txBody>
+      </p:sp>
+      <p:sp>
+        <p:nvSpPr>
+          <p:cNvPr id="14" name="Rectangle 13"/>
+          <p:cNvSpPr/>
+          <p:nvPr/>
+        </p:nvSpPr>
+        <p:spPr>
+          <a:xfrm>
+            <a:off x="640080" y="3931920"/>
+            <a:ext cx="73152" cy="1920240"/>
+          </a:xfrm>
+          <a:prstGeom prst="rect">
+            <a:avLst/>
+          </a:prstGeom>
+          <a:solidFill>
+            <a:srgbClr val="0E9F9A"/>
+          </a:solidFill>
+          <a:ln>
+            <a:noFill/>
+          </a:ln>
+          <a:effectLst/>
+        </p:spPr>
+        <p:style>
+          <a:lnRef idx="1">
+            <a:schemeClr val="accent1"/>
+          </a:lnRef>
+          <a:fillRef idx="3">
+            <a:schemeClr val="accent1"/>
+          </a:fillRef>
+          <a:effectRef idx="2">
+            <a:schemeClr val="accent1"/>
+          </a:effectRef>
+          <a:fontRef idx="minor">
+            <a:schemeClr val="lt1"/>
+          </a:fontRef>
+        </p:style>
+        <p:txBody>
+          <a:bodyPr rtlCol="0" anchor="ctr"/>
+          <a:lstStyle/>
+          <a:p>
+            <a:pPr algn="ctr"/>
+          </a:p>
+        </p:txBody>
+      </p:sp>
+      <p:sp>
+        <p:nvSpPr>
+          <p:cNvPr id="15" name="TextBox 14"/>
+          <p:cNvSpPr txBox="1"/>
+          <p:nvPr/>
+        </p:nvSpPr>
+        <p:spPr>
+          <a:xfrm>
+            <a:off x="868680" y="4041648"/>
+            <a:ext cx="5029200" cy="457200"/>
+          </a:xfrm>
+          <a:prstGeom prst="rect">
+            <a:avLst/>
+          </a:prstGeom>
+          <a:noFill/>
+        </p:spPr>
+        <p:txBody>
+          <a:bodyPr wrap="square" anchor="t">
+            <a:spAutoFit/>
+          </a:bodyPr>
+          <a:lstStyle/>
+          <a:p>
+            <a:pPr algn="l">
+              <a:spcAft>
+                <a:spcPts val="600"/>
+              </a:spcAft>
+            </a:pPr>
+            <a:r>
+              <a:rPr sz="1700" b="1">
+                <a:solidFill>
+                  <a:srgbClr val="0B1F3A"/>
+                </a:solidFill>
+                <a:latin typeface="Calibri"/>
+              </a:rPr>
+              <a:t>Review queue</a:t>
+            </a:r>
+          </a:p>
+        </p:txBody>
+      </p:sp>
+      <p:sp>
+        <p:nvSpPr>
+          <p:cNvPr id="16" name="TextBox 15"/>
+          <p:cNvSpPr txBox="1"/>
+          <p:nvPr/>
+        </p:nvSpPr>
+        <p:spPr>
+          <a:xfrm>
+            <a:off x="868680" y="4498848"/>
+            <a:ext cx="5029200" cy="1280160"/>
+          </a:xfrm>
+          <a:prstGeom prst="rect">
+            <a:avLst/>
+          </a:prstGeom>
+          <a:noFill/>
+        </p:spPr>
+        <p:txBody>
+          <a:bodyPr wrap="square" anchor="t">
+            <a:spAutoFit/>
+          </a:bodyPr>
+          <a:lstStyle/>
+          <a:p>
+            <a:pPr algn="l">
+              <a:spcAft>
+                <a:spcPts val="600"/>
+              </a:spcAft>
+            </a:pPr>
+            <a:r>
+              <a:rPr sz="1500" b="0">
+                <a:solidFill>
+                  <a:srgbClr val="1F2937"/>
+                </a:solidFill>
+                <a:latin typeface="Calibri"/>
+              </a:rPr>
+              <a:t>One-click approve or fix for every NEEDS REVIEW item, with an audit log.</a:t>
+            </a:r>
+          </a:p>
+        </p:txBody>
+      </p:sp>
+      <p:sp>
+        <p:nvSpPr>
+          <p:cNvPr id="17" name="Rounded Rectangle 16"/>
+          <p:cNvSpPr/>
+          <p:nvPr/>
+        </p:nvSpPr>
+        <p:spPr>
+          <a:xfrm>
+            <a:off x="6217920" y="3931920"/>
+            <a:ext cx="5394960" cy="1920240"/>
+          </a:xfrm>
+          <a:prstGeom prst="roundRect">
+            <a:avLst>
+              <a:gd name="adj" fmla="val 8000"/>
+            </a:avLst>
+          </a:prstGeom>
+          <a:solidFill>
+            <a:srgbClr val="EEF4F7"/>
+          </a:solidFill>
+          <a:ln>
+            <a:noFill/>
+          </a:ln>
+          <a:effectLst/>
+        </p:spPr>
+        <p:style>
+          <a:lnRef idx="1">
+            <a:schemeClr val="accent1"/>
+          </a:lnRef>
+          <a:fillRef idx="3">
+            <a:schemeClr val="accent1"/>
+          </a:fillRef>
+          <a:effectRef idx="2">
+            <a:schemeClr val="accent1"/>
+          </a:effectRef>
+          <a:fontRef idx="minor">
+            <a:schemeClr val="lt1"/>
+          </a:fontRef>
+        </p:style>
+        <p:txBody>
+          <a:bodyPr rtlCol="0" anchor="ctr"/>
+          <a:lstStyle/>
+          <a:p>
+            <a:pPr algn="ctr"/>
+          </a:p>
+        </p:txBody>
+      </p:sp>
+      <p:sp>
+        <p:nvSpPr>
+          <p:cNvPr id="18" name="Rectangle 17"/>
+          <p:cNvSpPr/>
+          <p:nvPr/>
+        </p:nvSpPr>
+        <p:spPr>
+          <a:xfrm>
+            <a:off x="6217920" y="3931920"/>
+            <a:ext cx="73152" cy="1920240"/>
+          </a:xfrm>
+          <a:prstGeom prst="rect">
+            <a:avLst/>
+          </a:prstGeom>
+          <a:solidFill>
+            <a:srgbClr val="0E9F9A"/>
+          </a:solidFill>
+          <a:ln>
+            <a:noFill/>
+          </a:ln>
+          <a:effectLst/>
+        </p:spPr>
+        <p:style>
+          <a:lnRef idx="1">
+            <a:schemeClr val="accent1"/>
+          </a:lnRef>
+          <a:fillRef idx="3">
+            <a:schemeClr val="accent1"/>
+          </a:fillRef>
+          <a:effectRef idx="2">
+            <a:schemeClr val="accent1"/>
+          </a:effectRef>
+          <a:fontRef idx="minor">
+            <a:schemeClr val="lt1"/>
+          </a:fontRef>
+        </p:style>
+        <p:txBody>
+          <a:bodyPr rtlCol="0" anchor="ctr"/>
+          <a:lstStyle/>
+          <a:p>
+            <a:pPr algn="ctr"/>
+          </a:p>
+        </p:txBody>
+      </p:sp>
+      <p:sp>
+        <p:nvSpPr>
+          <p:cNvPr id="19" name="TextBox 18"/>
+          <p:cNvSpPr txBox="1"/>
+          <p:nvPr/>
+        </p:nvSpPr>
+        <p:spPr>
+          <a:xfrm>
+            <a:off x="6446520" y="4041648"/>
+            <a:ext cx="5029200" cy="457200"/>
+          </a:xfrm>
+          <a:prstGeom prst="rect">
+            <a:avLst/>
+          </a:prstGeom>
+          <a:noFill/>
+        </p:spPr>
+        <p:txBody>
+          <a:bodyPr wrap="square" anchor="t">
+            <a:spAutoFit/>
+          </a:bodyPr>
+          <a:lstStyle/>
+          <a:p>
+            <a:pPr algn="l">
+              <a:spcAft>
+                <a:spcPts val="600"/>
+              </a:spcAft>
+            </a:pPr>
+            <a:r>
+              <a:rPr sz="1700" b="1">
+                <a:solidFill>
+                  <a:srgbClr val="0B1F3A"/>
+                </a:solidFill>
+                <a:latin typeface="Calibri"/>
+              </a:rPr>
+              <a:t>System integration</a:t>
+            </a:r>
+          </a:p>
+        </p:txBody>
+      </p:sp>
+      <p:sp>
+        <p:nvSpPr>
+          <p:cNvPr id="20" name="TextBox 19"/>
+          <p:cNvSpPr txBox="1"/>
+          <p:nvPr/>
+        </p:nvSpPr>
+        <p:spPr>
+          <a:xfrm>
+            <a:off x="6446520" y="4498848"/>
+            <a:ext cx="5029200" cy="1280160"/>
+          </a:xfrm>
+          <a:prstGeom prst="rect">
+            <a:avLst/>
+          </a:prstGeom>
+          <a:noFill/>
+        </p:spPr>
+        <p:txBody>
+          <a:bodyPr wrap="square" anchor="t">
+            <a:spAutoFit/>
+          </a:bodyPr>
+          <a:lstStyle/>
+          <a:p>
+            <a:pPr algn="l">
+              <a:spcAft>
+                <a:spcPts val="600"/>
+              </a:spcAft>
+            </a:pPr>
+            <a:r>
+              <a:rPr sz="1500" b="0">
+                <a:solidFill>
+                  <a:srgbClr val="1F2937"/>
+                </a:solidFill>
+                <a:latin typeface="Calibri"/>
+              </a:rPr>
+              <a:t>Connect to the mailbox and carrier systems so checks run automatically.</a:t>
+            </a:r>
+          </a:p>
+        </p:txBody>
+      </p:sp>
+    </p:spTree>
+  </p:cSld>
+  <p:clrMapOvr>
+    <a:masterClrMapping/>
+  </p:clrMapOvr>
+</p:sld>
+</file>
+
 <file path=ppt/slides/slide2.xml><?xml version="1.0" encoding="utf-8"?>
 <p:sld xmlns:a="http://schemas.openxmlformats.org/drawingml/2006/main" xmlns:p="http://schemas.openxmlformats.org/presentationml/2006/main" xmlns:r="http://schemas.openxmlformats.org/officeDocument/2006/relationships">
   <p:cSld>
@@ -7348,7 +8161,7 @@
                 </a:solidFill>
                 <a:latin typeface="Calibri"/>
               </a:rPr>
-              <a:t>EXAMPLE FROM THE SAMPLE INBOX</a:t>
+              <a:t>EXAMPLE FROM THE SAMPLE INBOX (EMAIL_145)</a:t>
             </a:r>
           </a:p>
         </p:txBody>
@@ -7387,7 +8200,7 @@
                 </a:solidFill>
                 <a:latin typeface="Calibri"/>
               </a:rPr>
-              <a:t>A one-letter difference, caught</a:t>
+              <a:t>A truncated company name, caught</a:t>
             </a:r>
           </a:p>
         </p:txBody>
@@ -7401,7 +8214,7 @@
         <p:spPr>
           <a:xfrm>
             <a:off x="640080" y="1737360"/>
-            <a:ext cx="10972800" cy="3108960"/>
+            <a:ext cx="10972800" cy="3291840"/>
           </a:xfrm>
           <a:prstGeom prst="roundRect">
             <a:avLst>
@@ -7485,7 +8298,7 @@
         </p:nvSpPr>
         <p:spPr>
           <a:xfrm>
-            <a:off x="3017520" y="1828800"/>
+            <a:off x="2926080" y="1828800"/>
             <a:ext cx="3200400" cy="365760"/>
           </a:xfrm>
           <a:prstGeom prst="rect">
@@ -7550,7 +8363,7 @@
                 </a:solidFill>
                 <a:latin typeface="Calibri"/>
               </a:rPr>
-              <a:t>Bill of Lading</a:t>
+              <a:t>Draft Bill of Lading</a:t>
             </a:r>
           </a:p>
         </p:txBody>
@@ -7563,7 +8376,7 @@
         </p:nvSpPr>
         <p:spPr>
           <a:xfrm>
-            <a:off x="9784080" y="1828800"/>
+            <a:off x="10058400" y="1828800"/>
             <a:ext cx="3200400" cy="365760"/>
           </a:xfrm>
           <a:prstGeom prst="rect">
@@ -7641,8 +8454,8 @@
         </p:nvSpPr>
         <p:spPr>
           <a:xfrm>
-            <a:off x="3017520" y="2286000"/>
-            <a:ext cx="3291840" cy="457200"/>
+            <a:off x="2926080" y="2286000"/>
+            <a:ext cx="3383280" cy="548640"/>
           </a:xfrm>
           <a:prstGeom prst="rect">
             <a:avLst/>
@@ -7661,13 +8474,13 @@
               </a:spcAft>
             </a:pPr>
             <a:r>
-              <a:rPr sz="1500" b="0">
+              <a:rPr sz="1400" b="0">
                 <a:solidFill>
                   <a:srgbClr val="1F2937"/>
                 </a:solidFill>
                 <a:latin typeface="Calibri"/>
               </a:rPr>
-              <a:t>APRIL FAR EAST (M) SDN BHD</a:t>
+              <a:t>APRIL FINE PAPER TRADING</a:t>
             </a:r>
           </a:p>
         </p:txBody>
@@ -7681,7 +8494,7 @@
         <p:spPr>
           <a:xfrm>
             <a:off x="6400800" y="2286000"/>
-            <a:ext cx="3291840" cy="457200"/>
+            <a:ext cx="3566160" cy="548640"/>
           </a:xfrm>
           <a:prstGeom prst="rect">
             <a:avLst/>
@@ -7700,13 +8513,13 @@
               </a:spcAft>
             </a:pPr>
             <a:r>
-              <a:rPr sz="1500" b="0">
+              <a:rPr sz="1400" b="0">
                 <a:solidFill>
                   <a:srgbClr val="1F2937"/>
                 </a:solidFill>
                 <a:latin typeface="Calibri"/>
               </a:rPr>
-              <a:t>APRIL FAR EAST (M) SDN BHD</a:t>
+              <a:t>APRIL FINE PAPER TRADING (MIDDLE EAST) FZE</a:t>
             </a:r>
           </a:p>
         </p:txBody>
@@ -7719,7 +8532,7 @@
         </p:nvSpPr>
         <p:spPr>
           <a:xfrm>
-            <a:off x="9784080" y="2286000"/>
+            <a:off x="10058400" y="2286000"/>
             <a:ext cx="1645920" cy="457200"/>
           </a:xfrm>
           <a:prstGeom prst="rect">
@@ -7741,6 +8554,162 @@
             <a:r>
               <a:rPr sz="1500" b="1">
                 <a:solidFill>
+                  <a:srgbClr val="C0392B"/>
+                </a:solidFill>
+                <a:latin typeface="Calibri"/>
+              </a:rPr>
+              <a:t>MISMATCH</a:t>
+            </a:r>
+          </a:p>
+        </p:txBody>
+      </p:sp>
+      <p:sp>
+        <p:nvSpPr>
+          <p:cNvPr id="14" name="TextBox 13"/>
+          <p:cNvSpPr txBox="1"/>
+          <p:nvPr/>
+        </p:nvSpPr>
+        <p:spPr>
+          <a:xfrm>
+            <a:off x="868680" y="2926080"/>
+            <a:ext cx="2103120" cy="457200"/>
+          </a:xfrm>
+          <a:prstGeom prst="rect">
+            <a:avLst/>
+          </a:prstGeom>
+          <a:noFill/>
+        </p:spPr>
+        <p:txBody>
+          <a:bodyPr wrap="square" anchor="t">
+            <a:spAutoFit/>
+          </a:bodyPr>
+          <a:lstStyle/>
+          <a:p>
+            <a:pPr algn="l">
+              <a:spcAft>
+                <a:spcPts val="600"/>
+              </a:spcAft>
+            </a:pPr>
+            <a:r>
+              <a:rPr sz="1500" b="1">
+                <a:solidFill>
+                  <a:srgbClr val="0B1F3A"/>
+                </a:solidFill>
+                <a:latin typeface="Calibri"/>
+              </a:rPr>
+              <a:t>Consignee</a:t>
+            </a:r>
+          </a:p>
+        </p:txBody>
+      </p:sp>
+      <p:sp>
+        <p:nvSpPr>
+          <p:cNvPr id="15" name="TextBox 14"/>
+          <p:cNvSpPr txBox="1"/>
+          <p:nvPr/>
+        </p:nvSpPr>
+        <p:spPr>
+          <a:xfrm>
+            <a:off x="2926080" y="2926080"/>
+            <a:ext cx="3383280" cy="548640"/>
+          </a:xfrm>
+          <a:prstGeom prst="rect">
+            <a:avLst/>
+          </a:prstGeom>
+          <a:noFill/>
+        </p:spPr>
+        <p:txBody>
+          <a:bodyPr wrap="square" anchor="t">
+            <a:spAutoFit/>
+          </a:bodyPr>
+          <a:lstStyle/>
+          <a:p>
+            <a:pPr algn="l">
+              <a:spcAft>
+                <a:spcPts val="600"/>
+              </a:spcAft>
+            </a:pPr>
+            <a:r>
+              <a:rPr sz="1400" b="0">
+                <a:solidFill>
+                  <a:srgbClr val="1F2937"/>
+                </a:solidFill>
+                <a:latin typeface="Calibri"/>
+              </a:rPr>
+              <a:t>PACIFIC OFFICE (M) SDN BHD</a:t>
+            </a:r>
+          </a:p>
+        </p:txBody>
+      </p:sp>
+      <p:sp>
+        <p:nvSpPr>
+          <p:cNvPr id="16" name="TextBox 15"/>
+          <p:cNvSpPr txBox="1"/>
+          <p:nvPr/>
+        </p:nvSpPr>
+        <p:spPr>
+          <a:xfrm>
+            <a:off x="6400800" y="2926080"/>
+            <a:ext cx="3566160" cy="548640"/>
+          </a:xfrm>
+          <a:prstGeom prst="rect">
+            <a:avLst/>
+          </a:prstGeom>
+          <a:noFill/>
+        </p:spPr>
+        <p:txBody>
+          <a:bodyPr wrap="square" anchor="t">
+            <a:spAutoFit/>
+          </a:bodyPr>
+          <a:lstStyle/>
+          <a:p>
+            <a:pPr algn="l">
+              <a:spcAft>
+                <a:spcPts val="600"/>
+              </a:spcAft>
+            </a:pPr>
+            <a:r>
+              <a:rPr sz="1400" b="0">
+                <a:solidFill>
+                  <a:srgbClr val="1F2937"/>
+                </a:solidFill>
+                <a:latin typeface="Calibri"/>
+              </a:rPr>
+              <a:t>PACIFIC OFFICE (M) SDN BHD</a:t>
+            </a:r>
+          </a:p>
+        </p:txBody>
+      </p:sp>
+      <p:sp>
+        <p:nvSpPr>
+          <p:cNvPr id="17" name="TextBox 16"/>
+          <p:cNvSpPr txBox="1"/>
+          <p:nvPr/>
+        </p:nvSpPr>
+        <p:spPr>
+          <a:xfrm>
+            <a:off x="10058400" y="2926080"/>
+            <a:ext cx="1645920" cy="457200"/>
+          </a:xfrm>
+          <a:prstGeom prst="rect">
+            <a:avLst/>
+          </a:prstGeom>
+          <a:noFill/>
+        </p:spPr>
+        <p:txBody>
+          <a:bodyPr wrap="square" anchor="t">
+            <a:spAutoFit/>
+          </a:bodyPr>
+          <a:lstStyle/>
+          <a:p>
+            <a:pPr algn="l">
+              <a:spcAft>
+                <a:spcPts val="600"/>
+              </a:spcAft>
+            </a:pPr>
+            <a:r>
+              <a:rPr sz="1500" b="1">
+                <a:solidFill>
                   <a:srgbClr val="1E8E5A"/>
                 </a:solidFill>
                 <a:latin typeface="Calibri"/>
@@ -7752,13 +8721,13 @@
       </p:sp>
       <p:sp>
         <p:nvSpPr>
-          <p:cNvPr id="14" name="TextBox 13"/>
-          <p:cNvSpPr txBox="1"/>
-          <p:nvPr/>
-        </p:nvSpPr>
-        <p:spPr>
-          <a:xfrm>
-            <a:off x="868680" y="2834640"/>
+          <p:cNvPr id="18" name="TextBox 17"/>
+          <p:cNvSpPr txBox="1"/>
+          <p:nvPr/>
+        </p:nvSpPr>
+        <p:spPr>
+          <a:xfrm>
+            <a:off x="868680" y="3566160"/>
             <a:ext cx="2103120" cy="457200"/>
           </a:xfrm>
           <a:prstGeom prst="rect">
@@ -7784,21 +8753,21 @@
                 </a:solidFill>
                 <a:latin typeface="Calibri"/>
               </a:rPr>
-              <a:t>Consignee</a:t>
-            </a:r>
-          </a:p>
-        </p:txBody>
-      </p:sp>
-      <p:sp>
-        <p:nvSpPr>
-          <p:cNvPr id="15" name="TextBox 14"/>
-          <p:cNvSpPr txBox="1"/>
-          <p:nvPr/>
-        </p:nvSpPr>
-        <p:spPr>
-          <a:xfrm>
-            <a:off x="3017520" y="2834640"/>
-            <a:ext cx="3291840" cy="457200"/>
+              <a:t>Port of discharge</a:t>
+            </a:r>
+          </a:p>
+        </p:txBody>
+      </p:sp>
+      <p:sp>
+        <p:nvSpPr>
+          <p:cNvPr id="19" name="TextBox 18"/>
+          <p:cNvSpPr txBox="1"/>
+          <p:nvPr/>
+        </p:nvSpPr>
+        <p:spPr>
+          <a:xfrm>
+            <a:off x="2926080" y="3566160"/>
+            <a:ext cx="3383280" cy="548640"/>
           </a:xfrm>
           <a:prstGeom prst="rect">
             <a:avLst/>
@@ -7817,27 +8786,27 @@
               </a:spcAft>
             </a:pPr>
             <a:r>
-              <a:rPr sz="1500" b="0">
+              <a:rPr sz="1400" b="0">
                 <a:solidFill>
                   <a:srgbClr val="1F2937"/>
                 </a:solidFill>
                 <a:latin typeface="Calibri"/>
               </a:rPr>
-              <a:t>AL GURQ STATIONERY LLC</a:t>
-            </a:r>
-          </a:p>
-        </p:txBody>
-      </p:sp>
-      <p:sp>
-        <p:nvSpPr>
-          <p:cNvPr id="16" name="TextBox 15"/>
-          <p:cNvSpPr txBox="1"/>
-          <p:nvPr/>
-        </p:nvSpPr>
-        <p:spPr>
-          <a:xfrm>
-            <a:off x="6400800" y="2834640"/>
-            <a:ext cx="3291840" cy="457200"/>
+              <a:t>BUSAN, SOUTH KOREA</a:t>
+            </a:r>
+          </a:p>
+        </p:txBody>
+      </p:sp>
+      <p:sp>
+        <p:nvSpPr>
+          <p:cNvPr id="20" name="TextBox 19"/>
+          <p:cNvSpPr txBox="1"/>
+          <p:nvPr/>
+        </p:nvSpPr>
+        <p:spPr>
+          <a:xfrm>
+            <a:off x="6400800" y="3566160"/>
+            <a:ext cx="3566160" cy="548640"/>
           </a:xfrm>
           <a:prstGeom prst="rect">
             <a:avLst/>
@@ -7856,26 +8825,26 @@
               </a:spcAft>
             </a:pPr>
             <a:r>
-              <a:rPr sz="1500" b="0">
+              <a:rPr sz="1400" b="0">
                 <a:solidFill>
                   <a:srgbClr val="1F2937"/>
                 </a:solidFill>
                 <a:latin typeface="Calibri"/>
               </a:rPr>
-              <a:t>AL GURG STATIONERY LLC</a:t>
-            </a:r>
-          </a:p>
-        </p:txBody>
-      </p:sp>
-      <p:sp>
-        <p:nvSpPr>
-          <p:cNvPr id="17" name="TextBox 16"/>
-          <p:cNvSpPr txBox="1"/>
-          <p:nvPr/>
-        </p:nvSpPr>
-        <p:spPr>
-          <a:xfrm>
-            <a:off x="9784080" y="2834640"/>
+              <a:t>BUSAN, SOUTH KOREA</a:t>
+            </a:r>
+          </a:p>
+        </p:txBody>
+      </p:sp>
+      <p:sp>
+        <p:nvSpPr>
+          <p:cNvPr id="21" name="TextBox 20"/>
+          <p:cNvSpPr txBox="1"/>
+          <p:nvPr/>
+        </p:nvSpPr>
+        <p:spPr>
+          <a:xfrm>
+            <a:off x="10058400" y="3566160"/>
             <a:ext cx="1645920" cy="457200"/>
           </a:xfrm>
           <a:prstGeom prst="rect">
@@ -7897,24 +8866,24 @@
             <a:r>
               <a:rPr sz="1500" b="1">
                 <a:solidFill>
-                  <a:srgbClr val="C0392B"/>
-                </a:solidFill>
-                <a:latin typeface="Calibri"/>
-              </a:rPr>
-              <a:t>MISMATCH</a:t>
-            </a:r>
-          </a:p>
-        </p:txBody>
-      </p:sp>
-      <p:sp>
-        <p:nvSpPr>
-          <p:cNvPr id="18" name="TextBox 17"/>
-          <p:cNvSpPr txBox="1"/>
-          <p:nvPr/>
-        </p:nvSpPr>
-        <p:spPr>
-          <a:xfrm>
-            <a:off x="868680" y="3383280"/>
+                  <a:srgbClr val="1E8E5A"/>
+                </a:solidFill>
+                <a:latin typeface="Calibri"/>
+              </a:rPr>
+              <a:t>match</a:t>
+            </a:r>
+          </a:p>
+        </p:txBody>
+      </p:sp>
+      <p:sp>
+        <p:nvSpPr>
+          <p:cNvPr id="22" name="TextBox 21"/>
+          <p:cNvSpPr txBox="1"/>
+          <p:nvPr/>
+        </p:nvSpPr>
+        <p:spPr>
+          <a:xfrm>
+            <a:off x="868680" y="4206240"/>
             <a:ext cx="2103120" cy="457200"/>
           </a:xfrm>
           <a:prstGeom prst="rect">
@@ -7940,21 +8909,21 @@
                 </a:solidFill>
                 <a:latin typeface="Calibri"/>
               </a:rPr>
-              <a:t>Notify party</a:t>
-            </a:r>
-          </a:p>
-        </p:txBody>
-      </p:sp>
-      <p:sp>
-        <p:nvSpPr>
-          <p:cNvPr id="19" name="TextBox 18"/>
-          <p:cNvSpPr txBox="1"/>
-          <p:nvPr/>
-        </p:nvSpPr>
-        <p:spPr>
-          <a:xfrm>
-            <a:off x="3017520" y="3383280"/>
-            <a:ext cx="3291840" cy="457200"/>
+              <a:t>Gross weight (kg)</a:t>
+            </a:r>
+          </a:p>
+        </p:txBody>
+      </p:sp>
+      <p:sp>
+        <p:nvSpPr>
+          <p:cNvPr id="23" name="TextBox 22"/>
+          <p:cNvSpPr txBox="1"/>
+          <p:nvPr/>
+        </p:nvSpPr>
+        <p:spPr>
+          <a:xfrm>
+            <a:off x="2926080" y="4206240"/>
+            <a:ext cx="3383280" cy="548640"/>
           </a:xfrm>
           <a:prstGeom prst="rect">
             <a:avLst/>
@@ -7973,27 +8942,27 @@
               </a:spcAft>
             </a:pPr>
             <a:r>
-              <a:rPr sz="1500" b="0">
+              <a:rPr sz="1400" b="0">
                 <a:solidFill>
                   <a:srgbClr val="1F2937"/>
                 </a:solidFill>
                 <a:latin typeface="Calibri"/>
               </a:rPr>
-              <a:t>AL GURQ STATIONERY LLC</a:t>
-            </a:r>
-          </a:p>
-        </p:txBody>
-      </p:sp>
-      <p:sp>
-        <p:nvSpPr>
-          <p:cNvPr id="20" name="TextBox 19"/>
-          <p:cNvSpPr txBox="1"/>
-          <p:nvPr/>
-        </p:nvSpPr>
-        <p:spPr>
-          <a:xfrm>
-            <a:off x="6400800" y="3383280"/>
-            <a:ext cx="3291840" cy="457200"/>
+              <a:t>313,380</a:t>
+            </a:r>
+          </a:p>
+        </p:txBody>
+      </p:sp>
+      <p:sp>
+        <p:nvSpPr>
+          <p:cNvPr id="24" name="TextBox 23"/>
+          <p:cNvSpPr txBox="1"/>
+          <p:nvPr/>
+        </p:nvSpPr>
+        <p:spPr>
+          <a:xfrm>
+            <a:off x="6400800" y="4206240"/>
+            <a:ext cx="3566160" cy="548640"/>
           </a:xfrm>
           <a:prstGeom prst="rect">
             <a:avLst/>
@@ -8012,26 +8981,26 @@
               </a:spcAft>
             </a:pPr>
             <a:r>
-              <a:rPr sz="1500" b="0">
+              <a:rPr sz="1400" b="0">
                 <a:solidFill>
                   <a:srgbClr val="1F2937"/>
                 </a:solidFill>
                 <a:latin typeface="Calibri"/>
               </a:rPr>
-              <a:t>AL GURG STATIONERY LLC</a:t>
-            </a:r>
-          </a:p>
-        </p:txBody>
-      </p:sp>
-      <p:sp>
-        <p:nvSpPr>
-          <p:cNvPr id="21" name="TextBox 20"/>
-          <p:cNvSpPr txBox="1"/>
-          <p:nvPr/>
-        </p:nvSpPr>
-        <p:spPr>
-          <a:xfrm>
-            <a:off x="9784080" y="3383280"/>
+              <a:t>313,380</a:t>
+            </a:r>
+          </a:p>
+        </p:txBody>
+      </p:sp>
+      <p:sp>
+        <p:nvSpPr>
+          <p:cNvPr id="25" name="TextBox 24"/>
+          <p:cNvSpPr txBox="1"/>
+          <p:nvPr/>
+        </p:nvSpPr>
+        <p:spPr>
+          <a:xfrm>
+            <a:off x="10058400" y="4206240"/>
             <a:ext cx="1645920" cy="457200"/>
           </a:xfrm>
           <a:prstGeom prst="rect">
@@ -8053,25 +9022,25 @@
             <a:r>
               <a:rPr sz="1500" b="1">
                 <a:solidFill>
-                  <a:srgbClr val="C0392B"/>
-                </a:solidFill>
-                <a:latin typeface="Calibri"/>
-              </a:rPr>
-              <a:t>MISMATCH</a:t>
-            </a:r>
-          </a:p>
-        </p:txBody>
-      </p:sp>
-      <p:sp>
-        <p:nvSpPr>
-          <p:cNvPr id="22" name="TextBox 21"/>
-          <p:cNvSpPr txBox="1"/>
-          <p:nvPr/>
-        </p:nvSpPr>
-        <p:spPr>
-          <a:xfrm>
-            <a:off x="868680" y="3931920"/>
-            <a:ext cx="2103120" cy="457200"/>
+                  <a:srgbClr val="1E8E5A"/>
+                </a:solidFill>
+                <a:latin typeface="Calibri"/>
+              </a:rPr>
+              <a:t>match</a:t>
+            </a:r>
+          </a:p>
+        </p:txBody>
+      </p:sp>
+      <p:sp>
+        <p:nvSpPr>
+          <p:cNvPr id="26" name="TextBox 25"/>
+          <p:cNvSpPr txBox="1"/>
+          <p:nvPr/>
+        </p:nvSpPr>
+        <p:spPr>
+          <a:xfrm>
+            <a:off x="640080" y="5303520"/>
+            <a:ext cx="10972800" cy="1097280"/>
           </a:xfrm>
           <a:prstGeom prst="rect">
             <a:avLst/>
@@ -8090,169 +9059,13 @@
               </a:spcAft>
             </a:pPr>
             <a:r>
-              <a:rPr sz="1500" b="1">
-                <a:solidFill>
-                  <a:srgbClr val="0B1F3A"/>
-                </a:solidFill>
-                <a:latin typeface="Calibri"/>
-              </a:rPr>
-              <a:t>Gross weight (kg)</a:t>
-            </a:r>
-          </a:p>
-        </p:txBody>
-      </p:sp>
-      <p:sp>
-        <p:nvSpPr>
-          <p:cNvPr id="23" name="TextBox 22"/>
-          <p:cNvSpPr txBox="1"/>
-          <p:nvPr/>
-        </p:nvSpPr>
-        <p:spPr>
-          <a:xfrm>
-            <a:off x="3017520" y="3931920"/>
-            <a:ext cx="3291840" cy="457200"/>
-          </a:xfrm>
-          <a:prstGeom prst="rect">
-            <a:avLst/>
-          </a:prstGeom>
-          <a:noFill/>
-        </p:spPr>
-        <p:txBody>
-          <a:bodyPr wrap="square" anchor="t">
-            <a:spAutoFit/>
-          </a:bodyPr>
-          <a:lstStyle/>
-          <a:p>
-            <a:pPr algn="l">
-              <a:spcAft>
-                <a:spcPts val="600"/>
-              </a:spcAft>
-            </a:pPr>
-            <a:r>
-              <a:rPr sz="1500" b="0">
+              <a:rPr sz="1800" b="0">
                 <a:solidFill>
                   <a:srgbClr val="1F2937"/>
                 </a:solidFill>
                 <a:latin typeface="Calibri"/>
               </a:rPr>
-              <a:t>128544</a:t>
-            </a:r>
-          </a:p>
-        </p:txBody>
-      </p:sp>
-      <p:sp>
-        <p:nvSpPr>
-          <p:cNvPr id="24" name="TextBox 23"/>
-          <p:cNvSpPr txBox="1"/>
-          <p:nvPr/>
-        </p:nvSpPr>
-        <p:spPr>
-          <a:xfrm>
-            <a:off x="6400800" y="3931920"/>
-            <a:ext cx="3291840" cy="457200"/>
-          </a:xfrm>
-          <a:prstGeom prst="rect">
-            <a:avLst/>
-          </a:prstGeom>
-          <a:noFill/>
-        </p:spPr>
-        <p:txBody>
-          <a:bodyPr wrap="square" anchor="t">
-            <a:spAutoFit/>
-          </a:bodyPr>
-          <a:lstStyle/>
-          <a:p>
-            <a:pPr algn="l">
-              <a:spcAft>
-                <a:spcPts val="600"/>
-              </a:spcAft>
-            </a:pPr>
-            <a:r>
-              <a:rPr sz="1500" b="0">
-                <a:solidFill>
-                  <a:srgbClr val="1F2937"/>
-                </a:solidFill>
-                <a:latin typeface="Calibri"/>
-              </a:rPr>
-              <a:t>128544</a:t>
-            </a:r>
-          </a:p>
-        </p:txBody>
-      </p:sp>
-      <p:sp>
-        <p:nvSpPr>
-          <p:cNvPr id="25" name="TextBox 24"/>
-          <p:cNvSpPr txBox="1"/>
-          <p:nvPr/>
-        </p:nvSpPr>
-        <p:spPr>
-          <a:xfrm>
-            <a:off x="9784080" y="3931920"/>
-            <a:ext cx="1645920" cy="457200"/>
-          </a:xfrm>
-          <a:prstGeom prst="rect">
-            <a:avLst/>
-          </a:prstGeom>
-          <a:noFill/>
-        </p:spPr>
-        <p:txBody>
-          <a:bodyPr wrap="square" anchor="t">
-            <a:spAutoFit/>
-          </a:bodyPr>
-          <a:lstStyle/>
-          <a:p>
-            <a:pPr algn="l">
-              <a:spcAft>
-                <a:spcPts val="600"/>
-              </a:spcAft>
-            </a:pPr>
-            <a:r>
-              <a:rPr sz="1500" b="1">
-                <a:solidFill>
-                  <a:srgbClr val="1E8E5A"/>
-                </a:solidFill>
-                <a:latin typeface="Calibri"/>
-              </a:rPr>
-              <a:t>match</a:t>
-            </a:r>
-          </a:p>
-        </p:txBody>
-      </p:sp>
-      <p:sp>
-        <p:nvSpPr>
-          <p:cNvPr id="26" name="TextBox 25"/>
-          <p:cNvSpPr txBox="1"/>
-          <p:nvPr/>
-        </p:nvSpPr>
-        <p:spPr>
-          <a:xfrm>
-            <a:off x="640080" y="5120640"/>
-            <a:ext cx="10972800" cy="1097280"/>
-          </a:xfrm>
-          <a:prstGeom prst="rect">
-            <a:avLst/>
-          </a:prstGeom>
-          <a:noFill/>
-        </p:spPr>
-        <p:txBody>
-          <a:bodyPr wrap="square" anchor="t">
-            <a:spAutoFit/>
-          </a:bodyPr>
-          <a:lstStyle/>
-          <a:p>
-            <a:pPr algn="l">
-              <a:spcAft>
-                <a:spcPts val="600"/>
-              </a:spcAft>
-            </a:pPr>
-            <a:r>
-              <a:rPr sz="1800" b="0">
-                <a:solidFill>
-                  <a:srgbClr val="1F2937"/>
-                </a:solidFill>
-                <a:latin typeface="Calibri"/>
-              </a:rPr>
-              <a:t>Easy to miss by eye, flagged instantly with the exact fields named. The reviewer opens the two documents already knowing where to look.</a:t>
+              <a:t>The legal suffix is missing on one document: easy to skim past, flagged instantly with the exact field named. A draft reply to the sender is generated automatically.</a:t>
             </a:r>
           </a:p>
         </p:txBody>
@@ -8353,7 +9166,7 @@
                 </a:solidFill>
                 <a:latin typeface="Calibri"/>
               </a:rPr>
-              <a:t>CHALLENGES</a:t>
+              <a:t>WHAT THE APP GIVES AN OPERATIONS TEAM</a:t>
             </a:r>
           </a:p>
         </p:txBody>
@@ -8392,7 +9205,7 @@
                 </a:solidFill>
                 <a:latin typeface="Calibri"/>
               </a:rPr>
-              <a:t>What we ran into</a:t>
+              <a:t>More than a yes or no</a:t>
             </a:r>
           </a:p>
         </p:txBody>
@@ -8406,7 +9219,7 @@
         <p:spPr>
           <a:xfrm>
             <a:off x="640080" y="1737360"/>
-            <a:ext cx="3566160" cy="2194560"/>
+            <a:ext cx="3566160" cy="2103120"/>
           </a:xfrm>
           <a:prstGeom prst="roundRect">
             <a:avLst>
@@ -8452,7 +9265,7 @@
         <p:spPr>
           <a:xfrm>
             <a:off x="640080" y="1737360"/>
-            <a:ext cx="73152" cy="2194560"/>
+            <a:ext cx="73152" cy="2103120"/>
           </a:xfrm>
           <a:prstGeom prst="rect">
             <a:avLst/>
@@ -8521,7 +9334,7 @@
                 </a:solidFill>
                 <a:latin typeface="Calibri"/>
               </a:rPr>
-              <a:t>Label variants</a:t>
+              <a:t>Dashboard</a:t>
             </a:r>
           </a:p>
         </p:txBody>
@@ -8535,7 +9348,7 @@
         <p:spPr>
           <a:xfrm>
             <a:off x="868680" y="2304288"/>
-            <a:ext cx="3200400" cy="1554480"/>
+            <a:ext cx="3200400" cy="1463039"/>
           </a:xfrm>
           <a:prstGeom prst="rect">
             <a:avLst/>
@@ -8560,7 +9373,7 @@
                 </a:solidFill>
                 <a:latin typeface="Calibri"/>
               </a:rPr>
-              <a:t>The same field appears under many names across formats and documents.</a:t>
+              <a:t>Every email at a glance: outcomes, most common defects, and reasons for escalation.</a:t>
             </a:r>
           </a:p>
         </p:txBody>
@@ -8574,7 +9387,7 @@
         <p:spPr>
           <a:xfrm>
             <a:off x="4315968" y="1737360"/>
-            <a:ext cx="3566160" cy="2194560"/>
+            <a:ext cx="3566160" cy="2103120"/>
           </a:xfrm>
           <a:prstGeom prst="roundRect">
             <a:avLst>
@@ -8620,7 +9433,7 @@
         <p:spPr>
           <a:xfrm>
             <a:off x="4315968" y="1737360"/>
-            <a:ext cx="73152" cy="2194560"/>
+            <a:ext cx="73152" cy="2103120"/>
           </a:xfrm>
           <a:prstGeom prst="rect">
             <a:avLst/>
@@ -8689,7 +9502,7 @@
                 </a:solidFill>
                 <a:latin typeface="Calibri"/>
               </a:rPr>
-              <a:t>PDF text corruption</a:t>
+              <a:t>Review queue</a:t>
             </a:r>
           </a:p>
         </p:txBody>
@@ -8703,7 +9516,7 @@
         <p:spPr>
           <a:xfrm>
             <a:off x="4544568" y="2304288"/>
-            <a:ext cx="3200400" cy="1554480"/>
+            <a:ext cx="3200400" cy="1463039"/>
           </a:xfrm>
           <a:prstGeom prst="rect">
             <a:avLst/>
@@ -8728,7 +9541,7 @@
                 </a:solidFill>
                 <a:latin typeface="Calibri"/>
               </a:rPr>
-              <a:t>Long labels ran into their values and scrambled the text. Splitting by font weight fixed it.</a:t>
+              <a:t>Cases a human must check, each with the reason and the next step.</a:t>
             </a:r>
           </a:p>
         </p:txBody>
@@ -8742,7 +9555,7 @@
         <p:spPr>
           <a:xfrm>
             <a:off x="7991856" y="1737360"/>
-            <a:ext cx="3566160" cy="2194560"/>
+            <a:ext cx="3566160" cy="2103120"/>
           </a:xfrm>
           <a:prstGeom prst="roundRect">
             <a:avLst>
@@ -8788,7 +9601,7 @@
         <p:spPr>
           <a:xfrm>
             <a:off x="7991856" y="1737360"/>
-            <a:ext cx="73152" cy="2194560"/>
+            <a:ext cx="73152" cy="2103120"/>
           </a:xfrm>
           <a:prstGeom prst="rect">
             <a:avLst/>
@@ -8857,7 +9670,7 @@
                 </a:solidFill>
                 <a:latin typeface="Calibri"/>
               </a:rPr>
-              <a:t>Scanned documents</a:t>
+              <a:t>Visual diff</a:t>
             </a:r>
           </a:p>
         </p:txBody>
@@ -8871,7 +9684,7 @@
         <p:spPr>
           <a:xfrm>
             <a:off x="8220456" y="2304288"/>
-            <a:ext cx="3200400" cy="1554480"/>
+            <a:ext cx="3200400" cy="1463039"/>
           </a:xfrm>
           <a:prstGeom prst="rect">
             <a:avLst/>
@@ -8896,7 +9709,7 @@
                 </a:solidFill>
                 <a:latin typeface="Calibri"/>
               </a:rPr>
-              <a:t>Image-only pages can't be trusted, so they always go to a human.</a:t>
+              <a:t>The exact characters that differ are highlighted side by side.</a:t>
             </a:r>
           </a:p>
         </p:txBody>
@@ -8909,8 +9722,8 @@
         </p:nvSpPr>
         <p:spPr>
           <a:xfrm>
-            <a:off x="640080" y="4114800"/>
-            <a:ext cx="5486400" cy="2011680"/>
+            <a:off x="640080" y="4023360"/>
+            <a:ext cx="3566160" cy="2103120"/>
           </a:xfrm>
           <a:prstGeom prst="roundRect">
             <a:avLst>
@@ -8955,8 +9768,176 @@
         </p:nvSpPr>
         <p:spPr>
           <a:xfrm>
-            <a:off x="640080" y="4114800"/>
-            <a:ext cx="73152" cy="2011680"/>
+            <a:off x="640080" y="4023360"/>
+            <a:ext cx="73152" cy="2103120"/>
+          </a:xfrm>
+          <a:prstGeom prst="rect">
+            <a:avLst/>
+          </a:prstGeom>
+          <a:solidFill>
+            <a:srgbClr val="1E8E5A"/>
+          </a:solidFill>
+          <a:ln>
+            <a:noFill/>
+          </a:ln>
+          <a:effectLst/>
+        </p:spPr>
+        <p:style>
+          <a:lnRef idx="1">
+            <a:schemeClr val="accent1"/>
+          </a:lnRef>
+          <a:fillRef idx="3">
+            <a:schemeClr val="accent1"/>
+          </a:fillRef>
+          <a:effectRef idx="2">
+            <a:schemeClr val="accent1"/>
+          </a:effectRef>
+          <a:fontRef idx="minor">
+            <a:schemeClr val="lt1"/>
+          </a:fontRef>
+        </p:style>
+        <p:txBody>
+          <a:bodyPr rtlCol="0" anchor="ctr"/>
+          <a:lstStyle/>
+          <a:p>
+            <a:pPr algn="ctr"/>
+          </a:p>
+        </p:txBody>
+      </p:sp>
+      <p:sp>
+        <p:nvSpPr>
+          <p:cNvPr id="19" name="TextBox 18"/>
+          <p:cNvSpPr txBox="1"/>
+          <p:nvPr/>
+        </p:nvSpPr>
+        <p:spPr>
+          <a:xfrm>
+            <a:off x="868680" y="4133088"/>
+            <a:ext cx="3200400" cy="457200"/>
+          </a:xfrm>
+          <a:prstGeom prst="rect">
+            <a:avLst/>
+          </a:prstGeom>
+          <a:noFill/>
+        </p:spPr>
+        <p:txBody>
+          <a:bodyPr wrap="square" anchor="t">
+            <a:spAutoFit/>
+          </a:bodyPr>
+          <a:lstStyle/>
+          <a:p>
+            <a:pPr algn="l">
+              <a:spcAft>
+                <a:spcPts val="600"/>
+              </a:spcAft>
+            </a:pPr>
+            <a:r>
+              <a:rPr sz="1700" b="1">
+                <a:solidFill>
+                  <a:srgbClr val="0B1F3A"/>
+                </a:solidFill>
+                <a:latin typeface="Calibri"/>
+              </a:rPr>
+              <a:t>Audit trail</a:t>
+            </a:r>
+          </a:p>
+        </p:txBody>
+      </p:sp>
+      <p:sp>
+        <p:nvSpPr>
+          <p:cNvPr id="20" name="TextBox 19"/>
+          <p:cNvSpPr txBox="1"/>
+          <p:nvPr/>
+        </p:nvSpPr>
+        <p:spPr>
+          <a:xfrm>
+            <a:off x="868680" y="4590288"/>
+            <a:ext cx="3200400" cy="1463039"/>
+          </a:xfrm>
+          <a:prstGeom prst="rect">
+            <a:avLst/>
+          </a:prstGeom>
+          <a:noFill/>
+        </p:spPr>
+        <p:txBody>
+          <a:bodyPr wrap="square" anchor="t">
+            <a:spAutoFit/>
+          </a:bodyPr>
+          <a:lstStyle/>
+          <a:p>
+            <a:pPr algn="l">
+              <a:spcAft>
+                <a:spcPts val="600"/>
+              </a:spcAft>
+            </a:pPr>
+            <a:r>
+              <a:rPr sz="1400" b="0">
+                <a:solidFill>
+                  <a:srgbClr val="1F2937"/>
+                </a:solidFill>
+                <a:latin typeface="Calibri"/>
+              </a:rPr>
+              <a:t>Per field: value as read, normalised value and the rule applied. Fully traceable.</a:t>
+            </a:r>
+          </a:p>
+        </p:txBody>
+      </p:sp>
+      <p:sp>
+        <p:nvSpPr>
+          <p:cNvPr id="21" name="Rounded Rectangle 20"/>
+          <p:cNvSpPr/>
+          <p:nvPr/>
+        </p:nvSpPr>
+        <p:spPr>
+          <a:xfrm>
+            <a:off x="4315968" y="4023360"/>
+            <a:ext cx="3566160" cy="2103120"/>
+          </a:xfrm>
+          <a:prstGeom prst="roundRect">
+            <a:avLst>
+              <a:gd name="adj" fmla="val 8000"/>
+            </a:avLst>
+          </a:prstGeom>
+          <a:solidFill>
+            <a:srgbClr val="EEF4F7"/>
+          </a:solidFill>
+          <a:ln>
+            <a:noFill/>
+          </a:ln>
+          <a:effectLst/>
+        </p:spPr>
+        <p:style>
+          <a:lnRef idx="1">
+            <a:schemeClr val="accent1"/>
+          </a:lnRef>
+          <a:fillRef idx="3">
+            <a:schemeClr val="accent1"/>
+          </a:fillRef>
+          <a:effectRef idx="2">
+            <a:schemeClr val="accent1"/>
+          </a:effectRef>
+          <a:fontRef idx="minor">
+            <a:schemeClr val="lt1"/>
+          </a:fontRef>
+        </p:style>
+        <p:txBody>
+          <a:bodyPr rtlCol="0" anchor="ctr"/>
+          <a:lstStyle/>
+          <a:p>
+            <a:pPr algn="ctr"/>
+          </a:p>
+        </p:txBody>
+      </p:sp>
+      <p:sp>
+        <p:nvSpPr>
+          <p:cNvPr id="22" name="Rectangle 21"/>
+          <p:cNvSpPr/>
+          <p:nvPr/>
+        </p:nvSpPr>
+        <p:spPr>
+          <a:xfrm>
+            <a:off x="4315968" y="4023360"/>
+            <a:ext cx="73152" cy="2103120"/>
           </a:xfrm>
           <a:prstGeom prst="rect">
             <a:avLst/>
@@ -8993,14 +9974,14 @@
       </p:sp>
       <p:sp>
         <p:nvSpPr>
-          <p:cNvPr id="19" name="TextBox 18"/>
-          <p:cNvSpPr txBox="1"/>
-          <p:nvPr/>
-        </p:nvSpPr>
-        <p:spPr>
-          <a:xfrm>
-            <a:off x="868680" y="4224528"/>
-            <a:ext cx="5120640" cy="457200"/>
+          <p:cNvPr id="23" name="TextBox 22"/>
+          <p:cNvSpPr txBox="1"/>
+          <p:nvPr/>
+        </p:nvSpPr>
+        <p:spPr>
+          <a:xfrm>
+            <a:off x="4544568" y="4133088"/>
+            <a:ext cx="3200400" cy="457200"/>
           </a:xfrm>
           <a:prstGeom prst="rect">
             <a:avLst/>
@@ -9025,21 +10006,21 @@
                 </a:solidFill>
                 <a:latin typeface="Calibri"/>
               </a:rPr>
-              <a:t>Inconsistent AI output</a:t>
-            </a:r>
-          </a:p>
-        </p:txBody>
-      </p:sp>
-      <p:sp>
-        <p:nvSpPr>
-          <p:cNvPr id="20" name="TextBox 19"/>
-          <p:cNvSpPr txBox="1"/>
-          <p:nvPr/>
-        </p:nvSpPr>
-        <p:spPr>
-          <a:xfrm>
-            <a:off x="868680" y="4681728"/>
-            <a:ext cx="5120640" cy="1371600"/>
+              <a:t>Draft replies</a:t>
+            </a:r>
+          </a:p>
+        </p:txBody>
+      </p:sp>
+      <p:sp>
+        <p:nvSpPr>
+          <p:cNvPr id="24" name="TextBox 23"/>
+          <p:cNvSpPr txBox="1"/>
+          <p:nvPr/>
+        </p:nvSpPr>
+        <p:spPr>
+          <a:xfrm>
+            <a:off x="4544568" y="4590288"/>
+            <a:ext cx="3200400" cy="1463039"/>
           </a:xfrm>
           <a:prstGeom prst="rect">
             <a:avLst/>
@@ -9064,21 +10045,21 @@
                 </a:solidFill>
                 <a:latin typeface="Calibri"/>
               </a:rPr>
-              <a:t>The AI sometimes shortened a port name on one document but not the other, creating false mismatches. We tightened the prompt to copy values exactly as printed.</a:t>
-            </a:r>
-          </a:p>
-        </p:txBody>
-      </p:sp>
-      <p:sp>
-        <p:nvSpPr>
-          <p:cNvPr id="21" name="Rounded Rectangle 20"/>
+              <a:t>A ready-to-send message to the sender listing the discrepancies.</a:t>
+            </a:r>
+          </a:p>
+        </p:txBody>
+      </p:sp>
+      <p:sp>
+        <p:nvSpPr>
+          <p:cNvPr id="25" name="Rounded Rectangle 24"/>
           <p:cNvSpPr/>
           <p:nvPr/>
         </p:nvSpPr>
         <p:spPr>
           <a:xfrm>
-            <a:off x="6309360" y="4114800"/>
-            <a:ext cx="5303520" cy="2011680"/>
+            <a:off x="7991856" y="4023360"/>
+            <a:ext cx="3566160" cy="2103120"/>
           </a:xfrm>
           <a:prstGeom prst="roundRect">
             <a:avLst>
@@ -9117,20 +10098,20 @@
       </p:sp>
       <p:sp>
         <p:nvSpPr>
-          <p:cNvPr id="22" name="Rectangle 21"/>
+          <p:cNvPr id="26" name="Rectangle 25"/>
           <p:cNvSpPr/>
           <p:nvPr/>
         </p:nvSpPr>
         <p:spPr>
           <a:xfrm>
-            <a:off x="6309360" y="4114800"/>
-            <a:ext cx="73152" cy="2011680"/>
+            <a:off x="7991856" y="4023360"/>
+            <a:ext cx="73152" cy="2103120"/>
           </a:xfrm>
           <a:prstGeom prst="rect">
             <a:avLst/>
           </a:prstGeom>
           <a:solidFill>
-            <a:srgbClr val="1E8E5A"/>
+            <a:srgbClr val="C77D0A"/>
           </a:solidFill>
           <a:ln>
             <a:noFill/>
@@ -9161,14 +10142,14 @@
       </p:sp>
       <p:sp>
         <p:nvSpPr>
-          <p:cNvPr id="23" name="TextBox 22"/>
-          <p:cNvSpPr txBox="1"/>
-          <p:nvPr/>
-        </p:nvSpPr>
-        <p:spPr>
-          <a:xfrm>
-            <a:off x="6537960" y="4224528"/>
-            <a:ext cx="4937759" cy="457200"/>
+          <p:cNvPr id="27" name="TextBox 26"/>
+          <p:cNvSpPr txBox="1"/>
+          <p:nvPr/>
+        </p:nvSpPr>
+        <p:spPr>
+          <a:xfrm>
+            <a:off x="8220456" y="4133088"/>
+            <a:ext cx="3200400" cy="457200"/>
           </a:xfrm>
           <a:prstGeom prst="rect">
             <a:avLst/>
@@ -9193,21 +10174,21 @@
                 </a:solidFill>
                 <a:latin typeface="Calibri"/>
               </a:rPr>
-              <a:t>A stray space in the API key</a:t>
-            </a:r>
-          </a:p>
-        </p:txBody>
-      </p:sp>
-      <p:sp>
-        <p:nvSpPr>
-          <p:cNvPr id="24" name="TextBox 23"/>
-          <p:cNvSpPr txBox="1"/>
-          <p:nvPr/>
-        </p:nvSpPr>
-        <p:spPr>
-          <a:xfrm>
-            <a:off x="6537960" y="4681728"/>
-            <a:ext cx="4937759" cy="1371600"/>
+              <a:t>Batch mode</a:t>
+            </a:r>
+          </a:p>
+        </p:txBody>
+      </p:sp>
+      <p:sp>
+        <p:nvSpPr>
+          <p:cNvPr id="28" name="TextBox 27"/>
+          <p:cNvSpPr txBox="1"/>
+          <p:nvPr/>
+        </p:nvSpPr>
+        <p:spPr>
+          <a:xfrm>
+            <a:off x="8220456" y="4590288"/>
+            <a:ext cx="3200400" cy="1463039"/>
           </a:xfrm>
           <a:prstGeom prst="rect">
             <a:avLst/>
@@ -9232,7 +10213,7 @@
                 </a:solidFill>
                 <a:latin typeface="Calibri"/>
               </a:rPr>
-              <a:t>An invisible trailing character broke every request. The key is now trimmed in code.</a:t>
+              <a:t>Drop many SI/BL files at once, auto-paired by name, with a CSV of results.</a:t>
             </a:r>
           </a:p>
         </p:txBody>
@@ -9333,7 +10314,7 @@
                 </a:solidFill>
                 <a:latin typeface="Calibri"/>
               </a:rPr>
-              <a:t>MEASURED WITH THE ORGANIZER'S SCORER</a:t>
+              <a:t>CHALLENGES</a:t>
             </a:r>
           </a:p>
         </p:txBody>
@@ -9372,7 +10353,7 @@
                 </a:solidFill>
                 <a:latin typeface="Calibri"/>
               </a:rPr>
-              <a:t>Results</a:t>
+              <a:t>What we ran into</a:t>
             </a:r>
           </a:p>
         </p:txBody>
@@ -9386,147 +10367,7 @@
         <p:spPr>
           <a:xfrm>
             <a:off x="640080" y="1737360"/>
-            <a:ext cx="5120640" cy="3017520"/>
-          </a:xfrm>
-          <a:prstGeom prst="roundRect">
-            <a:avLst>
-              <a:gd name="adj" fmla="val 8000"/>
-            </a:avLst>
-          </a:prstGeom>
-          <a:solidFill>
-            <a:srgbClr val="0B1F3A"/>
-          </a:solidFill>
-          <a:ln>
-            <a:noFill/>
-          </a:ln>
-          <a:effectLst/>
-        </p:spPr>
-        <p:style>
-          <a:lnRef idx="1">
-            <a:schemeClr val="accent1"/>
-          </a:lnRef>
-          <a:fillRef idx="3">
-            <a:schemeClr val="accent1"/>
-          </a:fillRef>
-          <a:effectRef idx="2">
-            <a:schemeClr val="accent1"/>
-          </a:effectRef>
-          <a:fontRef idx="minor">
-            <a:schemeClr val="lt1"/>
-          </a:fontRef>
-        </p:style>
-        <p:txBody>
-          <a:bodyPr rtlCol="0" anchor="ctr"/>
-          <a:lstStyle/>
-          <a:p>
-            <a:pPr algn="ctr"/>
-          </a:p>
-        </p:txBody>
-      </p:sp>
-      <p:sp>
-        <p:nvSpPr>
-          <p:cNvPr id="6" name="TextBox 5"/>
-          <p:cNvSpPr txBox="1"/>
-          <p:nvPr/>
-        </p:nvSpPr>
-        <p:spPr>
-          <a:xfrm>
-            <a:off x="640080" y="2103120"/>
-            <a:ext cx="5120640" cy="1280160"/>
-          </a:xfrm>
-          <a:prstGeom prst="rect">
-            <a:avLst/>
-          </a:prstGeom>
-          <a:noFill/>
-        </p:spPr>
-        <p:txBody>
-          <a:bodyPr wrap="square" anchor="t">
-            <a:spAutoFit/>
-          </a:bodyPr>
-          <a:lstStyle/>
-          <a:p>
-            <a:pPr algn="ctr">
-              <a:spcAft>
-                <a:spcPts val="600"/>
-              </a:spcAft>
-            </a:pPr>
-            <a:r>
-              <a:rPr sz="7200" b="1">
-                <a:solidFill>
-                  <a:srgbClr val="FFFFFF"/>
-                </a:solidFill>
-                <a:latin typeface="Calibri"/>
-              </a:rPr>
-              <a:t>1.0000</a:t>
-            </a:r>
-          </a:p>
-        </p:txBody>
-      </p:sp>
-      <p:sp>
-        <p:nvSpPr>
-          <p:cNvPr id="7" name="TextBox 6"/>
-          <p:cNvSpPr txBox="1"/>
-          <p:nvPr/>
-        </p:nvSpPr>
-        <p:spPr>
-          <a:xfrm>
-            <a:off x="640080" y="3566160"/>
-            <a:ext cx="5120640" cy="1097280"/>
-          </a:xfrm>
-          <a:prstGeom prst="rect">
-            <a:avLst/>
-          </a:prstGeom>
-          <a:noFill/>
-        </p:spPr>
-        <p:txBody>
-          <a:bodyPr wrap="square" anchor="t">
-            <a:spAutoFit/>
-          </a:bodyPr>
-          <a:lstStyle/>
-          <a:p>
-            <a:pPr algn="ctr">
-              <a:spcAft>
-                <a:spcPts val="600"/>
-              </a:spcAft>
-            </a:pPr>
-            <a:r>
-              <a:rPr sz="1500" b="0">
-                <a:solidFill>
-                  <a:srgbClr val="B8C7D9"/>
-                </a:solidFill>
-                <a:latin typeface="Calibri"/>
-              </a:rPr>
-              <a:t>Final score, rule-based reader</a:t>
-            </a:r>
-          </a:p>
-          <a:p>
-            <a:pPr algn="ctr">
-              <a:spcAft>
-                <a:spcPts val="600"/>
-              </a:spcAft>
-            </a:pPr>
-            <a:r>
-              <a:rPr sz="1500" b="0">
-                <a:solidFill>
-                  <a:srgbClr val="B8C7D9"/>
-                </a:solidFill>
-                <a:latin typeface="Calibri"/>
-              </a:rPr>
-              <a:t>520 emails, 46/46 defects caught, 20/20 escalations right</a:t>
-            </a:r>
-          </a:p>
-        </p:txBody>
-      </p:sp>
-      <p:sp>
-        <p:nvSpPr>
-          <p:cNvPr id="8" name="Rounded Rectangle 7"/>
-          <p:cNvSpPr/>
-          <p:nvPr/>
-        </p:nvSpPr>
-        <p:spPr>
-          <a:xfrm>
-            <a:off x="6035040" y="1737360"/>
-            <a:ext cx="5577840" cy="1417320"/>
+            <a:ext cx="3566160" cy="2194560"/>
           </a:xfrm>
           <a:prstGeom prst="roundRect">
             <a:avLst>
@@ -9565,14 +10406,14 @@
       </p:sp>
       <p:sp>
         <p:nvSpPr>
-          <p:cNvPr id="9" name="Rectangle 8"/>
+          <p:cNvPr id="6" name="Rectangle 5"/>
           <p:cNvSpPr/>
           <p:nvPr/>
         </p:nvSpPr>
         <p:spPr>
           <a:xfrm>
-            <a:off x="6035040" y="1737360"/>
-            <a:ext cx="73152" cy="1417320"/>
+            <a:off x="640080" y="1737360"/>
+            <a:ext cx="73152" cy="2194560"/>
           </a:xfrm>
           <a:prstGeom prst="rect">
             <a:avLst/>
@@ -9609,14 +10450,14 @@
       </p:sp>
       <p:sp>
         <p:nvSpPr>
-          <p:cNvPr id="10" name="TextBox 9"/>
-          <p:cNvSpPr txBox="1"/>
-          <p:nvPr/>
-        </p:nvSpPr>
-        <p:spPr>
-          <a:xfrm>
-            <a:off x="6263640" y="1847088"/>
-            <a:ext cx="5212079" cy="457200"/>
+          <p:cNvPr id="7" name="TextBox 6"/>
+          <p:cNvSpPr txBox="1"/>
+          <p:nvPr/>
+        </p:nvSpPr>
+        <p:spPr>
+          <a:xfrm>
+            <a:off x="868680" y="1847088"/>
+            <a:ext cx="3200400" cy="457200"/>
           </a:xfrm>
           <a:prstGeom prst="rect">
             <a:avLst/>
@@ -9641,21 +10482,21 @@
                 </a:solidFill>
                 <a:latin typeface="Calibri"/>
               </a:rPr>
-              <a:t>Live web app</a:t>
-            </a:r>
-          </a:p>
-        </p:txBody>
-      </p:sp>
-      <p:sp>
-        <p:nvSpPr>
-          <p:cNvPr id="11" name="TextBox 10"/>
-          <p:cNvSpPr txBox="1"/>
-          <p:nvPr/>
-        </p:nvSpPr>
-        <p:spPr>
-          <a:xfrm>
-            <a:off x="6263640" y="2304288"/>
-            <a:ext cx="5212079" cy="777240"/>
+              <a:t>Label variants</a:t>
+            </a:r>
+          </a:p>
+        </p:txBody>
+      </p:sp>
+      <p:sp>
+        <p:nvSpPr>
+          <p:cNvPr id="8" name="TextBox 7"/>
+          <p:cNvSpPr txBox="1"/>
+          <p:nvPr/>
+        </p:nvSpPr>
+        <p:spPr>
+          <a:xfrm>
+            <a:off x="868680" y="2304288"/>
+            <a:ext cx="3200400" cy="1554480"/>
           </a:xfrm>
           <a:prstGeom prst="rect">
             <a:avLst/>
@@ -9680,21 +10521,21 @@
                 </a:solidFill>
                 <a:latin typeface="Calibri"/>
               </a:rPr>
-              <a:t>Upload two documents or browse the sample inbox, in any browser, no sign-in.</a:t>
-            </a:r>
-          </a:p>
-        </p:txBody>
-      </p:sp>
-      <p:sp>
-        <p:nvSpPr>
-          <p:cNvPr id="12" name="Rounded Rectangle 11"/>
+              <a:t>The same field appears under many names across formats and documents.</a:t>
+            </a:r>
+          </a:p>
+        </p:txBody>
+      </p:sp>
+      <p:sp>
+        <p:nvSpPr>
+          <p:cNvPr id="9" name="Rounded Rectangle 8"/>
           <p:cNvSpPr/>
           <p:nvPr/>
         </p:nvSpPr>
         <p:spPr>
           <a:xfrm>
-            <a:off x="6035040" y="3337560"/>
-            <a:ext cx="5577840" cy="1417320"/>
+            <a:off x="4315968" y="1737360"/>
+            <a:ext cx="3566160" cy="2194560"/>
           </a:xfrm>
           <a:prstGeom prst="roundRect">
             <a:avLst>
@@ -9733,14 +10574,518 @@
       </p:sp>
       <p:sp>
         <p:nvSpPr>
-          <p:cNvPr id="13" name="Rectangle 12"/>
+          <p:cNvPr id="10" name="Rectangle 9"/>
           <p:cNvSpPr/>
           <p:nvPr/>
         </p:nvSpPr>
         <p:spPr>
           <a:xfrm>
-            <a:off x="6035040" y="3337560"/>
-            <a:ext cx="73152" cy="1417320"/>
+            <a:off x="4315968" y="1737360"/>
+            <a:ext cx="73152" cy="2194560"/>
+          </a:xfrm>
+          <a:prstGeom prst="rect">
+            <a:avLst/>
+          </a:prstGeom>
+          <a:solidFill>
+            <a:srgbClr val="C77D0A"/>
+          </a:solidFill>
+          <a:ln>
+            <a:noFill/>
+          </a:ln>
+          <a:effectLst/>
+        </p:spPr>
+        <p:style>
+          <a:lnRef idx="1">
+            <a:schemeClr val="accent1"/>
+          </a:lnRef>
+          <a:fillRef idx="3">
+            <a:schemeClr val="accent1"/>
+          </a:fillRef>
+          <a:effectRef idx="2">
+            <a:schemeClr val="accent1"/>
+          </a:effectRef>
+          <a:fontRef idx="minor">
+            <a:schemeClr val="lt1"/>
+          </a:fontRef>
+        </p:style>
+        <p:txBody>
+          <a:bodyPr rtlCol="0" anchor="ctr"/>
+          <a:lstStyle/>
+          <a:p>
+            <a:pPr algn="ctr"/>
+          </a:p>
+        </p:txBody>
+      </p:sp>
+      <p:sp>
+        <p:nvSpPr>
+          <p:cNvPr id="11" name="TextBox 10"/>
+          <p:cNvSpPr txBox="1"/>
+          <p:nvPr/>
+        </p:nvSpPr>
+        <p:spPr>
+          <a:xfrm>
+            <a:off x="4544568" y="1847088"/>
+            <a:ext cx="3200400" cy="457200"/>
+          </a:xfrm>
+          <a:prstGeom prst="rect">
+            <a:avLst/>
+          </a:prstGeom>
+          <a:noFill/>
+        </p:spPr>
+        <p:txBody>
+          <a:bodyPr wrap="square" anchor="t">
+            <a:spAutoFit/>
+          </a:bodyPr>
+          <a:lstStyle/>
+          <a:p>
+            <a:pPr algn="l">
+              <a:spcAft>
+                <a:spcPts val="600"/>
+              </a:spcAft>
+            </a:pPr>
+            <a:r>
+              <a:rPr sz="1700" b="1">
+                <a:solidFill>
+                  <a:srgbClr val="0B1F3A"/>
+                </a:solidFill>
+                <a:latin typeface="Calibri"/>
+              </a:rPr>
+              <a:t>PDF text corruption</a:t>
+            </a:r>
+          </a:p>
+        </p:txBody>
+      </p:sp>
+      <p:sp>
+        <p:nvSpPr>
+          <p:cNvPr id="12" name="TextBox 11"/>
+          <p:cNvSpPr txBox="1"/>
+          <p:nvPr/>
+        </p:nvSpPr>
+        <p:spPr>
+          <a:xfrm>
+            <a:off x="4544568" y="2304288"/>
+            <a:ext cx="3200400" cy="1554480"/>
+          </a:xfrm>
+          <a:prstGeom prst="rect">
+            <a:avLst/>
+          </a:prstGeom>
+          <a:noFill/>
+        </p:spPr>
+        <p:txBody>
+          <a:bodyPr wrap="square" anchor="t">
+            <a:spAutoFit/>
+          </a:bodyPr>
+          <a:lstStyle/>
+          <a:p>
+            <a:pPr algn="l">
+              <a:spcAft>
+                <a:spcPts val="600"/>
+              </a:spcAft>
+            </a:pPr>
+            <a:r>
+              <a:rPr sz="1400" b="0">
+                <a:solidFill>
+                  <a:srgbClr val="1F2937"/>
+                </a:solidFill>
+                <a:latin typeface="Calibri"/>
+              </a:rPr>
+              <a:t>Long labels ran into their values and scrambled the text. Splitting by font weight fixed it.</a:t>
+            </a:r>
+          </a:p>
+        </p:txBody>
+      </p:sp>
+      <p:sp>
+        <p:nvSpPr>
+          <p:cNvPr id="13" name="Rounded Rectangle 12"/>
+          <p:cNvSpPr/>
+          <p:nvPr/>
+        </p:nvSpPr>
+        <p:spPr>
+          <a:xfrm>
+            <a:off x="7991856" y="1737360"/>
+            <a:ext cx="3566160" cy="2194560"/>
+          </a:xfrm>
+          <a:prstGeom prst="roundRect">
+            <a:avLst>
+              <a:gd name="adj" fmla="val 8000"/>
+            </a:avLst>
+          </a:prstGeom>
+          <a:solidFill>
+            <a:srgbClr val="EEF4F7"/>
+          </a:solidFill>
+          <a:ln>
+            <a:noFill/>
+          </a:ln>
+          <a:effectLst/>
+        </p:spPr>
+        <p:style>
+          <a:lnRef idx="1">
+            <a:schemeClr val="accent1"/>
+          </a:lnRef>
+          <a:fillRef idx="3">
+            <a:schemeClr val="accent1"/>
+          </a:fillRef>
+          <a:effectRef idx="2">
+            <a:schemeClr val="accent1"/>
+          </a:effectRef>
+          <a:fontRef idx="minor">
+            <a:schemeClr val="lt1"/>
+          </a:fontRef>
+        </p:style>
+        <p:txBody>
+          <a:bodyPr rtlCol="0" anchor="ctr"/>
+          <a:lstStyle/>
+          <a:p>
+            <a:pPr algn="ctr"/>
+          </a:p>
+        </p:txBody>
+      </p:sp>
+      <p:sp>
+        <p:nvSpPr>
+          <p:cNvPr id="14" name="Rectangle 13"/>
+          <p:cNvSpPr/>
+          <p:nvPr/>
+        </p:nvSpPr>
+        <p:spPr>
+          <a:xfrm>
+            <a:off x="7991856" y="1737360"/>
+            <a:ext cx="73152" cy="2194560"/>
+          </a:xfrm>
+          <a:prstGeom prst="rect">
+            <a:avLst/>
+          </a:prstGeom>
+          <a:solidFill>
+            <a:srgbClr val="C0392B"/>
+          </a:solidFill>
+          <a:ln>
+            <a:noFill/>
+          </a:ln>
+          <a:effectLst/>
+        </p:spPr>
+        <p:style>
+          <a:lnRef idx="1">
+            <a:schemeClr val="accent1"/>
+          </a:lnRef>
+          <a:fillRef idx="3">
+            <a:schemeClr val="accent1"/>
+          </a:fillRef>
+          <a:effectRef idx="2">
+            <a:schemeClr val="accent1"/>
+          </a:effectRef>
+          <a:fontRef idx="minor">
+            <a:schemeClr val="lt1"/>
+          </a:fontRef>
+        </p:style>
+        <p:txBody>
+          <a:bodyPr rtlCol="0" anchor="ctr"/>
+          <a:lstStyle/>
+          <a:p>
+            <a:pPr algn="ctr"/>
+          </a:p>
+        </p:txBody>
+      </p:sp>
+      <p:sp>
+        <p:nvSpPr>
+          <p:cNvPr id="15" name="TextBox 14"/>
+          <p:cNvSpPr txBox="1"/>
+          <p:nvPr/>
+        </p:nvSpPr>
+        <p:spPr>
+          <a:xfrm>
+            <a:off x="8220456" y="1847088"/>
+            <a:ext cx="3200400" cy="457200"/>
+          </a:xfrm>
+          <a:prstGeom prst="rect">
+            <a:avLst/>
+          </a:prstGeom>
+          <a:noFill/>
+        </p:spPr>
+        <p:txBody>
+          <a:bodyPr wrap="square" anchor="t">
+            <a:spAutoFit/>
+          </a:bodyPr>
+          <a:lstStyle/>
+          <a:p>
+            <a:pPr algn="l">
+              <a:spcAft>
+                <a:spcPts val="600"/>
+              </a:spcAft>
+            </a:pPr>
+            <a:r>
+              <a:rPr sz="1700" b="1">
+                <a:solidFill>
+                  <a:srgbClr val="0B1F3A"/>
+                </a:solidFill>
+                <a:latin typeface="Calibri"/>
+              </a:rPr>
+              <a:t>Scanned documents</a:t>
+            </a:r>
+          </a:p>
+        </p:txBody>
+      </p:sp>
+      <p:sp>
+        <p:nvSpPr>
+          <p:cNvPr id="16" name="TextBox 15"/>
+          <p:cNvSpPr txBox="1"/>
+          <p:nvPr/>
+        </p:nvSpPr>
+        <p:spPr>
+          <a:xfrm>
+            <a:off x="8220456" y="2304288"/>
+            <a:ext cx="3200400" cy="1554480"/>
+          </a:xfrm>
+          <a:prstGeom prst="rect">
+            <a:avLst/>
+          </a:prstGeom>
+          <a:noFill/>
+        </p:spPr>
+        <p:txBody>
+          <a:bodyPr wrap="square" anchor="t">
+            <a:spAutoFit/>
+          </a:bodyPr>
+          <a:lstStyle/>
+          <a:p>
+            <a:pPr algn="l">
+              <a:spcAft>
+                <a:spcPts val="600"/>
+              </a:spcAft>
+            </a:pPr>
+            <a:r>
+              <a:rPr sz="1400" b="0">
+                <a:solidFill>
+                  <a:srgbClr val="1F2937"/>
+                </a:solidFill>
+                <a:latin typeface="Calibri"/>
+              </a:rPr>
+              <a:t>Image-only pages can't be trusted, so they always go to a human.</a:t>
+            </a:r>
+          </a:p>
+        </p:txBody>
+      </p:sp>
+      <p:sp>
+        <p:nvSpPr>
+          <p:cNvPr id="17" name="Rounded Rectangle 16"/>
+          <p:cNvSpPr/>
+          <p:nvPr/>
+        </p:nvSpPr>
+        <p:spPr>
+          <a:xfrm>
+            <a:off x="640080" y="4114800"/>
+            <a:ext cx="5486400" cy="2011680"/>
+          </a:xfrm>
+          <a:prstGeom prst="roundRect">
+            <a:avLst>
+              <a:gd name="adj" fmla="val 8000"/>
+            </a:avLst>
+          </a:prstGeom>
+          <a:solidFill>
+            <a:srgbClr val="EEF4F7"/>
+          </a:solidFill>
+          <a:ln>
+            <a:noFill/>
+          </a:ln>
+          <a:effectLst/>
+        </p:spPr>
+        <p:style>
+          <a:lnRef idx="1">
+            <a:schemeClr val="accent1"/>
+          </a:lnRef>
+          <a:fillRef idx="3">
+            <a:schemeClr val="accent1"/>
+          </a:fillRef>
+          <a:effectRef idx="2">
+            <a:schemeClr val="accent1"/>
+          </a:effectRef>
+          <a:fontRef idx="minor">
+            <a:schemeClr val="lt1"/>
+          </a:fontRef>
+        </p:style>
+        <p:txBody>
+          <a:bodyPr rtlCol="0" anchor="ctr"/>
+          <a:lstStyle/>
+          <a:p>
+            <a:pPr algn="ctr"/>
+          </a:p>
+        </p:txBody>
+      </p:sp>
+      <p:sp>
+        <p:nvSpPr>
+          <p:cNvPr id="18" name="Rectangle 17"/>
+          <p:cNvSpPr/>
+          <p:nvPr/>
+        </p:nvSpPr>
+        <p:spPr>
+          <a:xfrm>
+            <a:off x="640080" y="4114800"/>
+            <a:ext cx="73152" cy="2011680"/>
+          </a:xfrm>
+          <a:prstGeom prst="rect">
+            <a:avLst/>
+          </a:prstGeom>
+          <a:solidFill>
+            <a:srgbClr val="0E9F9A"/>
+          </a:solidFill>
+          <a:ln>
+            <a:noFill/>
+          </a:ln>
+          <a:effectLst/>
+        </p:spPr>
+        <p:style>
+          <a:lnRef idx="1">
+            <a:schemeClr val="accent1"/>
+          </a:lnRef>
+          <a:fillRef idx="3">
+            <a:schemeClr val="accent1"/>
+          </a:fillRef>
+          <a:effectRef idx="2">
+            <a:schemeClr val="accent1"/>
+          </a:effectRef>
+          <a:fontRef idx="minor">
+            <a:schemeClr val="lt1"/>
+          </a:fontRef>
+        </p:style>
+        <p:txBody>
+          <a:bodyPr rtlCol="0" anchor="ctr"/>
+          <a:lstStyle/>
+          <a:p>
+            <a:pPr algn="ctr"/>
+          </a:p>
+        </p:txBody>
+      </p:sp>
+      <p:sp>
+        <p:nvSpPr>
+          <p:cNvPr id="19" name="TextBox 18"/>
+          <p:cNvSpPr txBox="1"/>
+          <p:nvPr/>
+        </p:nvSpPr>
+        <p:spPr>
+          <a:xfrm>
+            <a:off x="868680" y="4224528"/>
+            <a:ext cx="5120640" cy="457200"/>
+          </a:xfrm>
+          <a:prstGeom prst="rect">
+            <a:avLst/>
+          </a:prstGeom>
+          <a:noFill/>
+        </p:spPr>
+        <p:txBody>
+          <a:bodyPr wrap="square" anchor="t">
+            <a:spAutoFit/>
+          </a:bodyPr>
+          <a:lstStyle/>
+          <a:p>
+            <a:pPr algn="l">
+              <a:spcAft>
+                <a:spcPts val="600"/>
+              </a:spcAft>
+            </a:pPr>
+            <a:r>
+              <a:rPr sz="1700" b="1">
+                <a:solidFill>
+                  <a:srgbClr val="0B1F3A"/>
+                </a:solidFill>
+                <a:latin typeface="Calibri"/>
+              </a:rPr>
+              <a:t>Inconsistent AI output</a:t>
+            </a:r>
+          </a:p>
+        </p:txBody>
+      </p:sp>
+      <p:sp>
+        <p:nvSpPr>
+          <p:cNvPr id="20" name="TextBox 19"/>
+          <p:cNvSpPr txBox="1"/>
+          <p:nvPr/>
+        </p:nvSpPr>
+        <p:spPr>
+          <a:xfrm>
+            <a:off x="868680" y="4681728"/>
+            <a:ext cx="5120640" cy="1371600"/>
+          </a:xfrm>
+          <a:prstGeom prst="rect">
+            <a:avLst/>
+          </a:prstGeom>
+          <a:noFill/>
+        </p:spPr>
+        <p:txBody>
+          <a:bodyPr wrap="square" anchor="t">
+            <a:spAutoFit/>
+          </a:bodyPr>
+          <a:lstStyle/>
+          <a:p>
+            <a:pPr algn="l">
+              <a:spcAft>
+                <a:spcPts val="600"/>
+              </a:spcAft>
+            </a:pPr>
+            <a:r>
+              <a:rPr sz="1400" b="0">
+                <a:solidFill>
+                  <a:srgbClr val="1F2937"/>
+                </a:solidFill>
+                <a:latin typeface="Calibri"/>
+              </a:rPr>
+              <a:t>The AI sometimes shortened a port name on one document but not the other, creating false mismatches. We tightened the prompt, and scans always go to a human.</a:t>
+            </a:r>
+          </a:p>
+        </p:txBody>
+      </p:sp>
+      <p:sp>
+        <p:nvSpPr>
+          <p:cNvPr id="21" name="Rounded Rectangle 20"/>
+          <p:cNvSpPr/>
+          <p:nvPr/>
+        </p:nvSpPr>
+        <p:spPr>
+          <a:xfrm>
+            <a:off x="6309360" y="4114800"/>
+            <a:ext cx="5303520" cy="2011680"/>
+          </a:xfrm>
+          <a:prstGeom prst="roundRect">
+            <a:avLst>
+              <a:gd name="adj" fmla="val 8000"/>
+            </a:avLst>
+          </a:prstGeom>
+          <a:solidFill>
+            <a:srgbClr val="EEF4F7"/>
+          </a:solidFill>
+          <a:ln>
+            <a:noFill/>
+          </a:ln>
+          <a:effectLst/>
+        </p:spPr>
+        <p:style>
+          <a:lnRef idx="1">
+            <a:schemeClr val="accent1"/>
+          </a:lnRef>
+          <a:fillRef idx="3">
+            <a:schemeClr val="accent1"/>
+          </a:fillRef>
+          <a:effectRef idx="2">
+            <a:schemeClr val="accent1"/>
+          </a:effectRef>
+          <a:fontRef idx="minor">
+            <a:schemeClr val="lt1"/>
+          </a:fontRef>
+        </p:style>
+        <p:txBody>
+          <a:bodyPr rtlCol="0" anchor="ctr"/>
+          <a:lstStyle/>
+          <a:p>
+            <a:pPr algn="ctr"/>
+          </a:p>
+        </p:txBody>
+      </p:sp>
+      <p:sp>
+        <p:nvSpPr>
+          <p:cNvPr id="22" name="Rectangle 21"/>
+          <p:cNvSpPr/>
+          <p:nvPr/>
+        </p:nvSpPr>
+        <p:spPr>
+          <a:xfrm>
+            <a:off x="6309360" y="4114800"/>
+            <a:ext cx="73152" cy="2011680"/>
           </a:xfrm>
           <a:prstGeom prst="rect">
             <a:avLst/>
@@ -9777,14 +11122,14 @@
       </p:sp>
       <p:sp>
         <p:nvSpPr>
-          <p:cNvPr id="14" name="TextBox 13"/>
-          <p:cNvSpPr txBox="1"/>
-          <p:nvPr/>
-        </p:nvSpPr>
-        <p:spPr>
-          <a:xfrm>
-            <a:off x="6263640" y="3447288"/>
-            <a:ext cx="5212079" cy="457200"/>
+          <p:cNvPr id="23" name="TextBox 22"/>
+          <p:cNvSpPr txBox="1"/>
+          <p:nvPr/>
+        </p:nvSpPr>
+        <p:spPr>
+          <a:xfrm>
+            <a:off x="6537960" y="4224528"/>
+            <a:ext cx="4937759" cy="457200"/>
           </a:xfrm>
           <a:prstGeom prst="rect">
             <a:avLst/>
@@ -9809,21 +11154,21 @@
                 </a:solidFill>
                 <a:latin typeface="Calibri"/>
               </a:rPr>
-              <a:t>AI reading</a:t>
-            </a:r>
-          </a:p>
-        </p:txBody>
-      </p:sp>
-      <p:sp>
-        <p:nvSpPr>
-          <p:cNvPr id="15" name="TextBox 14"/>
-          <p:cNvSpPr txBox="1"/>
-          <p:nvPr/>
-        </p:nvSpPr>
-        <p:spPr>
-          <a:xfrm>
-            <a:off x="6263640" y="3904487"/>
-            <a:ext cx="5212079" cy="777240"/>
+              <a:t>A stray space in the API key</a:t>
+            </a:r>
+          </a:p>
+        </p:txBody>
+      </p:sp>
+      <p:sp>
+        <p:nvSpPr>
+          <p:cNvPr id="24" name="TextBox 23"/>
+          <p:cNvSpPr txBox="1"/>
+          <p:nvPr/>
+        </p:nvSpPr>
+        <p:spPr>
+          <a:xfrm>
+            <a:off x="6537960" y="4681728"/>
+            <a:ext cx="4937759" cy="1371600"/>
           </a:xfrm>
           <a:prstGeom prst="rect">
             <a:avLst/>
@@ -9848,46 +11193,7 @@
                 </a:solidFill>
                 <a:latin typeface="Calibri"/>
               </a:rPr>
-              <a:t>Claude reads every format including scans. Decisions stay in plain code.</a:t>
-            </a:r>
-          </a:p>
-        </p:txBody>
-      </p:sp>
-      <p:sp>
-        <p:nvSpPr>
-          <p:cNvPr id="16" name="TextBox 15"/>
-          <p:cNvSpPr txBox="1"/>
-          <p:nvPr/>
-        </p:nvSpPr>
-        <p:spPr>
-          <a:xfrm>
-            <a:off x="640080" y="5120640"/>
-            <a:ext cx="10972800" cy="914400"/>
-          </a:xfrm>
-          <a:prstGeom prst="rect">
-            <a:avLst/>
-          </a:prstGeom>
-          <a:noFill/>
-        </p:spPr>
-        <p:txBody>
-          <a:bodyPr wrap="square" anchor="t">
-            <a:spAutoFit/>
-          </a:bodyPr>
-          <a:lstStyle/>
-          <a:p>
-            <a:pPr algn="l">
-              <a:spcAft>
-                <a:spcPts val="600"/>
-              </a:spcAft>
-            </a:pPr>
-            <a:r>
-              <a:rPr sz="1400" b="0">
-                <a:solidFill>
-                  <a:srgbClr val="C77D0A"/>
-                </a:solidFill>
-                <a:latin typeface="Calibri"/>
-              </a:rPr>
-              <a:t>[Fill in the AI-reader score here after the full AI run, or remove this line.]</a:t>
+              <a:t>An invisible trailing character broke every request. The key is now trimmed in code.</a:t>
             </a:r>
           </a:p>
         </p:txBody>
@@ -9988,7 +11294,7 @@
                 </a:solidFill>
                 <a:latin typeface="Calibri"/>
               </a:rPr>
-              <a:t>FUTURE ROADMAP</a:t>
+              <a:t>MEASURED WITH THE ORGANIZER'S SCORER</a:t>
             </a:r>
           </a:p>
         </p:txBody>
@@ -10027,7 +11333,7 @@
                 </a:solidFill>
                 <a:latin typeface="Calibri"/>
               </a:rPr>
-              <a:t>Where this goes next</a:t>
+              <a:t>Results</a:t>
             </a:r>
           </a:p>
         </p:txBody>
@@ -10041,7 +11347,147 @@
         <p:spPr>
           <a:xfrm>
             <a:off x="640080" y="1737360"/>
-            <a:ext cx="5394960" cy="1920240"/>
+            <a:ext cx="5120640" cy="3017520"/>
+          </a:xfrm>
+          <a:prstGeom prst="roundRect">
+            <a:avLst>
+              <a:gd name="adj" fmla="val 8000"/>
+            </a:avLst>
+          </a:prstGeom>
+          <a:solidFill>
+            <a:srgbClr val="0B1F3A"/>
+          </a:solidFill>
+          <a:ln>
+            <a:noFill/>
+          </a:ln>
+          <a:effectLst/>
+        </p:spPr>
+        <p:style>
+          <a:lnRef idx="1">
+            <a:schemeClr val="accent1"/>
+          </a:lnRef>
+          <a:fillRef idx="3">
+            <a:schemeClr val="accent1"/>
+          </a:fillRef>
+          <a:effectRef idx="2">
+            <a:schemeClr val="accent1"/>
+          </a:effectRef>
+          <a:fontRef idx="minor">
+            <a:schemeClr val="lt1"/>
+          </a:fontRef>
+        </p:style>
+        <p:txBody>
+          <a:bodyPr rtlCol="0" anchor="ctr"/>
+          <a:lstStyle/>
+          <a:p>
+            <a:pPr algn="ctr"/>
+          </a:p>
+        </p:txBody>
+      </p:sp>
+      <p:sp>
+        <p:nvSpPr>
+          <p:cNvPr id="6" name="TextBox 5"/>
+          <p:cNvSpPr txBox="1"/>
+          <p:nvPr/>
+        </p:nvSpPr>
+        <p:spPr>
+          <a:xfrm>
+            <a:off x="640080" y="2103120"/>
+            <a:ext cx="5120640" cy="1280160"/>
+          </a:xfrm>
+          <a:prstGeom prst="rect">
+            <a:avLst/>
+          </a:prstGeom>
+          <a:noFill/>
+        </p:spPr>
+        <p:txBody>
+          <a:bodyPr wrap="square" anchor="t">
+            <a:spAutoFit/>
+          </a:bodyPr>
+          <a:lstStyle/>
+          <a:p>
+            <a:pPr algn="ctr">
+              <a:spcAft>
+                <a:spcPts val="600"/>
+              </a:spcAft>
+            </a:pPr>
+            <a:r>
+              <a:rPr sz="7200" b="1">
+                <a:solidFill>
+                  <a:srgbClr val="FFFFFF"/>
+                </a:solidFill>
+                <a:latin typeface="Calibri"/>
+              </a:rPr>
+              <a:t>1.0000</a:t>
+            </a:r>
+          </a:p>
+        </p:txBody>
+      </p:sp>
+      <p:sp>
+        <p:nvSpPr>
+          <p:cNvPr id="7" name="TextBox 6"/>
+          <p:cNvSpPr txBox="1"/>
+          <p:nvPr/>
+        </p:nvSpPr>
+        <p:spPr>
+          <a:xfrm>
+            <a:off x="640080" y="3566160"/>
+            <a:ext cx="5120640" cy="1097280"/>
+          </a:xfrm>
+          <a:prstGeom prst="rect">
+            <a:avLst/>
+          </a:prstGeom>
+          <a:noFill/>
+        </p:spPr>
+        <p:txBody>
+          <a:bodyPr wrap="square" anchor="t">
+            <a:spAutoFit/>
+          </a:bodyPr>
+          <a:lstStyle/>
+          <a:p>
+            <a:pPr algn="ctr">
+              <a:spcAft>
+                <a:spcPts val="600"/>
+              </a:spcAft>
+            </a:pPr>
+            <a:r>
+              <a:rPr sz="1500" b="0">
+                <a:solidFill>
+                  <a:srgbClr val="B8C7D9"/>
+                </a:solidFill>
+                <a:latin typeface="Calibri"/>
+              </a:rPr>
+              <a:t>Final score, rule-based reader</a:t>
+            </a:r>
+          </a:p>
+          <a:p>
+            <a:pPr algn="ctr">
+              <a:spcAft>
+                <a:spcPts val="600"/>
+              </a:spcAft>
+            </a:pPr>
+            <a:r>
+              <a:rPr sz="1500" b="0">
+                <a:solidFill>
+                  <a:srgbClr val="B8C7D9"/>
+                </a:solidFill>
+                <a:latin typeface="Calibri"/>
+              </a:rPr>
+              <a:t>520 emails, 46/46 defects caught, 20/20 escalations right</a:t>
+            </a:r>
+          </a:p>
+        </p:txBody>
+      </p:sp>
+      <p:sp>
+        <p:nvSpPr>
+          <p:cNvPr id="8" name="Rounded Rectangle 7"/>
+          <p:cNvSpPr/>
+          <p:nvPr/>
+        </p:nvSpPr>
+        <p:spPr>
+          <a:xfrm>
+            <a:off x="6035040" y="1737360"/>
+            <a:ext cx="5577840" cy="1417320"/>
           </a:xfrm>
           <a:prstGeom prst="roundRect">
             <a:avLst>
@@ -10080,14 +11526,14 @@
       </p:sp>
       <p:sp>
         <p:nvSpPr>
-          <p:cNvPr id="6" name="Rectangle 5"/>
+          <p:cNvPr id="9" name="Rectangle 8"/>
           <p:cNvSpPr/>
           <p:nvPr/>
         </p:nvSpPr>
         <p:spPr>
           <a:xfrm>
-            <a:off x="640080" y="1737360"/>
-            <a:ext cx="73152" cy="1920240"/>
+            <a:off x="6035040" y="1737360"/>
+            <a:ext cx="73152" cy="1417320"/>
           </a:xfrm>
           <a:prstGeom prst="rect">
             <a:avLst/>
@@ -10124,14 +11570,14 @@
       </p:sp>
       <p:sp>
         <p:nvSpPr>
-          <p:cNvPr id="7" name="TextBox 6"/>
-          <p:cNvSpPr txBox="1"/>
-          <p:nvPr/>
-        </p:nvSpPr>
-        <p:spPr>
-          <a:xfrm>
-            <a:off x="868680" y="1847088"/>
-            <a:ext cx="5029200" cy="457200"/>
+          <p:cNvPr id="10" name="TextBox 9"/>
+          <p:cNvSpPr txBox="1"/>
+          <p:nvPr/>
+        </p:nvSpPr>
+        <p:spPr>
+          <a:xfrm>
+            <a:off x="6263640" y="1847088"/>
+            <a:ext cx="5212079" cy="457200"/>
           </a:xfrm>
           <a:prstGeom prst="rect">
             <a:avLst/>
@@ -10156,21 +11602,21 @@
                 </a:solidFill>
                 <a:latin typeface="Calibri"/>
               </a:rPr>
-              <a:t>More documents</a:t>
-            </a:r>
-          </a:p>
-        </p:txBody>
-      </p:sp>
-      <p:sp>
-        <p:nvSpPr>
-          <p:cNvPr id="8" name="TextBox 7"/>
-          <p:cNvSpPr txBox="1"/>
-          <p:nvPr/>
-        </p:nvSpPr>
-        <p:spPr>
-          <a:xfrm>
-            <a:off x="868680" y="2304288"/>
-            <a:ext cx="5029200" cy="1280160"/>
+              <a:t>Live web app</a:t>
+            </a:r>
+          </a:p>
+        </p:txBody>
+      </p:sp>
+      <p:sp>
+        <p:nvSpPr>
+          <p:cNvPr id="11" name="TextBox 10"/>
+          <p:cNvSpPr txBox="1"/>
+          <p:nvPr/>
+        </p:nvSpPr>
+        <p:spPr>
+          <a:xfrm>
+            <a:off x="6263640" y="2304288"/>
+            <a:ext cx="5212079" cy="777240"/>
           </a:xfrm>
           <a:prstGeom prst="rect">
             <a:avLst/>
@@ -10189,27 +11635,27 @@
               </a:spcAft>
             </a:pPr>
             <a:r>
-              <a:rPr sz="1500" b="0">
+              <a:rPr sz="1400" b="0">
                 <a:solidFill>
                   <a:srgbClr val="1F2937"/>
                 </a:solidFill>
                 <a:latin typeface="Calibri"/>
               </a:rPr>
-              <a:t>Invoices, packing lists and certificates of origin.</a:t>
-            </a:r>
-          </a:p>
-        </p:txBody>
-      </p:sp>
-      <p:sp>
-        <p:nvSpPr>
-          <p:cNvPr id="9" name="Rounded Rectangle 8"/>
+              <a:t>Upload two documents or browse the sample inbox, in any browser, no sign-in.</a:t>
+            </a:r>
+          </a:p>
+        </p:txBody>
+      </p:sp>
+      <p:sp>
+        <p:nvSpPr>
+          <p:cNvPr id="12" name="Rounded Rectangle 11"/>
           <p:cNvSpPr/>
           <p:nvPr/>
         </p:nvSpPr>
         <p:spPr>
           <a:xfrm>
-            <a:off x="6217920" y="1737360"/>
-            <a:ext cx="5394960" cy="1920240"/>
+            <a:off x="6035040" y="3337560"/>
+            <a:ext cx="5577840" cy="1417320"/>
           </a:xfrm>
           <a:prstGeom prst="roundRect">
             <a:avLst>
@@ -10248,20 +11694,20 @@
       </p:sp>
       <p:sp>
         <p:nvSpPr>
-          <p:cNvPr id="10" name="Rectangle 9"/>
+          <p:cNvPr id="13" name="Rectangle 12"/>
           <p:cNvSpPr/>
           <p:nvPr/>
         </p:nvSpPr>
         <p:spPr>
           <a:xfrm>
-            <a:off x="6217920" y="1737360"/>
-            <a:ext cx="73152" cy="1920240"/>
+            <a:off x="6035040" y="3337560"/>
+            <a:ext cx="73152" cy="1417320"/>
           </a:xfrm>
           <a:prstGeom prst="rect">
             <a:avLst/>
           </a:prstGeom>
           <a:solidFill>
-            <a:srgbClr val="0E9F9A"/>
+            <a:srgbClr val="1E8E5A"/>
           </a:solidFill>
           <a:ln>
             <a:noFill/>
@@ -10292,14 +11738,14 @@
       </p:sp>
       <p:sp>
         <p:nvSpPr>
-          <p:cNvPr id="11" name="TextBox 10"/>
-          <p:cNvSpPr txBox="1"/>
-          <p:nvPr/>
-        </p:nvSpPr>
-        <p:spPr>
-          <a:xfrm>
-            <a:off x="6446520" y="1847088"/>
-            <a:ext cx="5029200" cy="457200"/>
+          <p:cNvPr id="14" name="TextBox 13"/>
+          <p:cNvSpPr txBox="1"/>
+          <p:nvPr/>
+        </p:nvSpPr>
+        <p:spPr>
+          <a:xfrm>
+            <a:off x="6263640" y="3447288"/>
+            <a:ext cx="5212079" cy="457200"/>
           </a:xfrm>
           <a:prstGeom prst="rect">
             <a:avLst/>
@@ -10324,21 +11770,21 @@
                 </a:solidFill>
                 <a:latin typeface="Calibri"/>
               </a:rPr>
-              <a:t>More fields</a:t>
-            </a:r>
-          </a:p>
-        </p:txBody>
-      </p:sp>
-      <p:sp>
-        <p:nvSpPr>
-          <p:cNvPr id="12" name="TextBox 11"/>
-          <p:cNvSpPr txBox="1"/>
-          <p:nvPr/>
-        </p:nvSpPr>
-        <p:spPr>
-          <a:xfrm>
-            <a:off x="6446520" y="2304288"/>
-            <a:ext cx="5029200" cy="1280160"/>
+              <a:t>AI reading</a:t>
+            </a:r>
+          </a:p>
+        </p:txBody>
+      </p:sp>
+      <p:sp>
+        <p:nvSpPr>
+          <p:cNvPr id="15" name="TextBox 14"/>
+          <p:cNvSpPr txBox="1"/>
+          <p:nvPr/>
+        </p:nvSpPr>
+        <p:spPr>
+          <a:xfrm>
+            <a:off x="6263640" y="3904487"/>
+            <a:ext cx="5212079" cy="777240"/>
           </a:xfrm>
           <a:prstGeom prst="rect">
             <a:avLst/>
@@ -10357,117 +11803,27 @@
               </a:spcAft>
             </a:pPr>
             <a:r>
-              <a:rPr sz="1500" b="0">
+              <a:rPr sz="1400" b="0">
                 <a:solidFill>
                   <a:srgbClr val="1F2937"/>
                 </a:solidFill>
                 <a:latin typeface="Calibri"/>
               </a:rPr>
-              <a:t>Vessel, voyage, cargo description and HS code.</a:t>
-            </a:r>
-          </a:p>
-        </p:txBody>
-      </p:sp>
-      <p:sp>
-        <p:nvSpPr>
-          <p:cNvPr id="13" name="Rounded Rectangle 12"/>
-          <p:cNvSpPr/>
-          <p:nvPr/>
-        </p:nvSpPr>
-        <p:spPr>
-          <a:xfrm>
-            <a:off x="640080" y="3931920"/>
-            <a:ext cx="5394960" cy="1920240"/>
-          </a:xfrm>
-          <a:prstGeom prst="roundRect">
-            <a:avLst>
-              <a:gd name="adj" fmla="val 8000"/>
-            </a:avLst>
-          </a:prstGeom>
-          <a:solidFill>
-            <a:srgbClr val="EEF4F7"/>
-          </a:solidFill>
-          <a:ln>
-            <a:noFill/>
-          </a:ln>
-          <a:effectLst/>
-        </p:spPr>
-        <p:style>
-          <a:lnRef idx="1">
-            <a:schemeClr val="accent1"/>
-          </a:lnRef>
-          <a:fillRef idx="3">
-            <a:schemeClr val="accent1"/>
-          </a:fillRef>
-          <a:effectRef idx="2">
-            <a:schemeClr val="accent1"/>
-          </a:effectRef>
-          <a:fontRef idx="minor">
-            <a:schemeClr val="lt1"/>
-          </a:fontRef>
-        </p:style>
-        <p:txBody>
-          <a:bodyPr rtlCol="0" anchor="ctr"/>
-          <a:lstStyle/>
-          <a:p>
-            <a:pPr algn="ctr"/>
-          </a:p>
-        </p:txBody>
-      </p:sp>
-      <p:sp>
-        <p:nvSpPr>
-          <p:cNvPr id="14" name="Rectangle 13"/>
-          <p:cNvSpPr/>
-          <p:nvPr/>
-        </p:nvSpPr>
-        <p:spPr>
-          <a:xfrm>
-            <a:off x="640080" y="3931920"/>
-            <a:ext cx="73152" cy="1920240"/>
-          </a:xfrm>
-          <a:prstGeom prst="rect">
-            <a:avLst/>
-          </a:prstGeom>
-          <a:solidFill>
-            <a:srgbClr val="0E9F9A"/>
-          </a:solidFill>
-          <a:ln>
-            <a:noFill/>
-          </a:ln>
-          <a:effectLst/>
-        </p:spPr>
-        <p:style>
-          <a:lnRef idx="1">
-            <a:schemeClr val="accent1"/>
-          </a:lnRef>
-          <a:fillRef idx="3">
-            <a:schemeClr val="accent1"/>
-          </a:fillRef>
-          <a:effectRef idx="2">
-            <a:schemeClr val="accent1"/>
-          </a:effectRef>
-          <a:fontRef idx="minor">
-            <a:schemeClr val="lt1"/>
-          </a:fontRef>
-        </p:style>
-        <p:txBody>
-          <a:bodyPr rtlCol="0" anchor="ctr"/>
-          <a:lstStyle/>
-          <a:p>
-            <a:pPr algn="ctr"/>
-          </a:p>
-        </p:txBody>
-      </p:sp>
-      <p:sp>
-        <p:nvSpPr>
-          <p:cNvPr id="15" name="TextBox 14"/>
-          <p:cNvSpPr txBox="1"/>
-          <p:nvPr/>
-        </p:nvSpPr>
-        <p:spPr>
-          <a:xfrm>
-            <a:off x="868680" y="4041648"/>
-            <a:ext cx="5029200" cy="457200"/>
+              <a:t>Claude reads every format including scans. Decisions stay in plain code.</a:t>
+            </a:r>
+          </a:p>
+        </p:txBody>
+      </p:sp>
+      <p:sp>
+        <p:nvSpPr>
+          <p:cNvPr id="16" name="TextBox 15"/>
+          <p:cNvSpPr txBox="1"/>
+          <p:nvPr/>
+        </p:nvSpPr>
+        <p:spPr>
+          <a:xfrm>
+            <a:off x="640080" y="5120640"/>
+            <a:ext cx="10972800" cy="914400"/>
           </a:xfrm>
           <a:prstGeom prst="rect">
             <a:avLst/>
@@ -10486,220 +11842,13 @@
               </a:spcAft>
             </a:pPr>
             <a:r>
-              <a:rPr sz="1700" b="1">
-                <a:solidFill>
-                  <a:srgbClr val="0B1F3A"/>
-                </a:solidFill>
-                <a:latin typeface="Calibri"/>
-              </a:rPr>
-              <a:t>Review queue</a:t>
-            </a:r>
-          </a:p>
-        </p:txBody>
-      </p:sp>
-      <p:sp>
-        <p:nvSpPr>
-          <p:cNvPr id="16" name="TextBox 15"/>
-          <p:cNvSpPr txBox="1"/>
-          <p:nvPr/>
-        </p:nvSpPr>
-        <p:spPr>
-          <a:xfrm>
-            <a:off x="868680" y="4498848"/>
-            <a:ext cx="5029200" cy="1280160"/>
-          </a:xfrm>
-          <a:prstGeom prst="rect">
-            <a:avLst/>
-          </a:prstGeom>
-          <a:noFill/>
-        </p:spPr>
-        <p:txBody>
-          <a:bodyPr wrap="square" anchor="t">
-            <a:spAutoFit/>
-          </a:bodyPr>
-          <a:lstStyle/>
-          <a:p>
-            <a:pPr algn="l">
-              <a:spcAft>
-                <a:spcPts val="600"/>
-              </a:spcAft>
-            </a:pPr>
-            <a:r>
-              <a:rPr sz="1500" b="0">
-                <a:solidFill>
-                  <a:srgbClr val="1F2937"/>
-                </a:solidFill>
-                <a:latin typeface="Calibri"/>
-              </a:rPr>
-              <a:t>One-click approve or fix for every NEEDS REVIEW item, with an audit log.</a:t>
-            </a:r>
-          </a:p>
-        </p:txBody>
-      </p:sp>
-      <p:sp>
-        <p:nvSpPr>
-          <p:cNvPr id="17" name="Rounded Rectangle 16"/>
-          <p:cNvSpPr/>
-          <p:nvPr/>
-        </p:nvSpPr>
-        <p:spPr>
-          <a:xfrm>
-            <a:off x="6217920" y="3931920"/>
-            <a:ext cx="5394960" cy="1920240"/>
-          </a:xfrm>
-          <a:prstGeom prst="roundRect">
-            <a:avLst>
-              <a:gd name="adj" fmla="val 8000"/>
-            </a:avLst>
-          </a:prstGeom>
-          <a:solidFill>
-            <a:srgbClr val="EEF4F7"/>
-          </a:solidFill>
-          <a:ln>
-            <a:noFill/>
-          </a:ln>
-          <a:effectLst/>
-        </p:spPr>
-        <p:style>
-          <a:lnRef idx="1">
-            <a:schemeClr val="accent1"/>
-          </a:lnRef>
-          <a:fillRef idx="3">
-            <a:schemeClr val="accent1"/>
-          </a:fillRef>
-          <a:effectRef idx="2">
-            <a:schemeClr val="accent1"/>
-          </a:effectRef>
-          <a:fontRef idx="minor">
-            <a:schemeClr val="lt1"/>
-          </a:fontRef>
-        </p:style>
-        <p:txBody>
-          <a:bodyPr rtlCol="0" anchor="ctr"/>
-          <a:lstStyle/>
-          <a:p>
-            <a:pPr algn="ctr"/>
-          </a:p>
-        </p:txBody>
-      </p:sp>
-      <p:sp>
-        <p:nvSpPr>
-          <p:cNvPr id="18" name="Rectangle 17"/>
-          <p:cNvSpPr/>
-          <p:nvPr/>
-        </p:nvSpPr>
-        <p:spPr>
-          <a:xfrm>
-            <a:off x="6217920" y="3931920"/>
-            <a:ext cx="73152" cy="1920240"/>
-          </a:xfrm>
-          <a:prstGeom prst="rect">
-            <a:avLst/>
-          </a:prstGeom>
-          <a:solidFill>
-            <a:srgbClr val="0E9F9A"/>
-          </a:solidFill>
-          <a:ln>
-            <a:noFill/>
-          </a:ln>
-          <a:effectLst/>
-        </p:spPr>
-        <p:style>
-          <a:lnRef idx="1">
-            <a:schemeClr val="accent1"/>
-          </a:lnRef>
-          <a:fillRef idx="3">
-            <a:schemeClr val="accent1"/>
-          </a:fillRef>
-          <a:effectRef idx="2">
-            <a:schemeClr val="accent1"/>
-          </a:effectRef>
-          <a:fontRef idx="minor">
-            <a:schemeClr val="lt1"/>
-          </a:fontRef>
-        </p:style>
-        <p:txBody>
-          <a:bodyPr rtlCol="0" anchor="ctr"/>
-          <a:lstStyle/>
-          <a:p>
-            <a:pPr algn="ctr"/>
-          </a:p>
-        </p:txBody>
-      </p:sp>
-      <p:sp>
-        <p:nvSpPr>
-          <p:cNvPr id="19" name="TextBox 18"/>
-          <p:cNvSpPr txBox="1"/>
-          <p:nvPr/>
-        </p:nvSpPr>
-        <p:spPr>
-          <a:xfrm>
-            <a:off x="6446520" y="4041648"/>
-            <a:ext cx="5029200" cy="457200"/>
-          </a:xfrm>
-          <a:prstGeom prst="rect">
-            <a:avLst/>
-          </a:prstGeom>
-          <a:noFill/>
-        </p:spPr>
-        <p:txBody>
-          <a:bodyPr wrap="square" anchor="t">
-            <a:spAutoFit/>
-          </a:bodyPr>
-          <a:lstStyle/>
-          <a:p>
-            <a:pPr algn="l">
-              <a:spcAft>
-                <a:spcPts val="600"/>
-              </a:spcAft>
-            </a:pPr>
-            <a:r>
-              <a:rPr sz="1700" b="1">
-                <a:solidFill>
-                  <a:srgbClr val="0B1F3A"/>
-                </a:solidFill>
-                <a:latin typeface="Calibri"/>
-              </a:rPr>
-              <a:t>System integration</a:t>
-            </a:r>
-          </a:p>
-        </p:txBody>
-      </p:sp>
-      <p:sp>
-        <p:nvSpPr>
-          <p:cNvPr id="20" name="TextBox 19"/>
-          <p:cNvSpPr txBox="1"/>
-          <p:nvPr/>
-        </p:nvSpPr>
-        <p:spPr>
-          <a:xfrm>
-            <a:off x="6446520" y="4498848"/>
-            <a:ext cx="5029200" cy="1280160"/>
-          </a:xfrm>
-          <a:prstGeom prst="rect">
-            <a:avLst/>
-          </a:prstGeom>
-          <a:noFill/>
-        </p:spPr>
-        <p:txBody>
-          <a:bodyPr wrap="square" anchor="t">
-            <a:spAutoFit/>
-          </a:bodyPr>
-          <a:lstStyle/>
-          <a:p>
-            <a:pPr algn="l">
-              <a:spcAft>
-                <a:spcPts val="600"/>
-              </a:spcAft>
-            </a:pPr>
-            <a:r>
-              <a:rPr sz="1500" b="0">
-                <a:solidFill>
-                  <a:srgbClr val="1F2937"/>
-                </a:solidFill>
-                <a:latin typeface="Calibri"/>
-              </a:rPr>
-              <a:t>Connect to the mailbox and carrier systems so checks run automatically.</a:t>
+              <a:rPr sz="1400" b="0">
+                <a:solidFill>
+                  <a:srgbClr val="C77D0A"/>
+                </a:solidFill>
+                <a:latin typeface="Calibri"/>
+              </a:rPr>
+              <a:t>[Fill in the AI-reader score here after the full AI run, or remove this line.]</a:t>
             </a:r>
           </a:p>
         </p:txBody>

</xml_diff>

<commit_message>
Refresh submission.json (rule-based, 1.0000); update slides and description
Co-Authored-By: Claude Sonnet 5 <noreply@anthropic.com>
</commit_message>
<xml_diff>
--- a/docs/SDOC_slides.pptx
+++ b/docs/SDOC_slides.pptx
@@ -15,6 +15,7 @@
     <p:sldId id="263" r:id="rId14"/>
     <p:sldId id="264" r:id="rId15"/>
     <p:sldId id="265" r:id="rId16"/>
+    <p:sldId id="266" r:id="rId17"/>
   </p:sldIdLst>
   <p:sldSz cx="12191695" cy="6858000" type="screen4x3"/>
   <p:notesSz cx="6858000" cy="9144000"/>
@@ -3336,7 +3337,7 @@
                 </a:solidFill>
                 <a:latin typeface="Calibri"/>
               </a:rPr>
-              <a:t>[Team name]  ·  Averis Hackathon 2026</a:t>
+              <a:t>Averis-unemployed-bums  ·  Averis Hackathon 2026</a:t>
             </a:r>
           </a:p>
         </p:txBody>
@@ -3437,7 +3438,7 @@
                 </a:solidFill>
                 <a:latin typeface="Calibri"/>
               </a:rPr>
-              <a:t>FUTURE ROADMAP</a:t>
+              <a:t>MEASURED WITH THE ORGANIZER'S SCORER</a:t>
             </a:r>
           </a:p>
         </p:txBody>
@@ -3476,7 +3477,7 @@
                 </a:solidFill>
                 <a:latin typeface="Calibri"/>
               </a:rPr>
-              <a:t>Where this goes next</a:t>
+              <a:t>Results</a:t>
             </a:r>
           </a:p>
         </p:txBody>
@@ -3490,7 +3491,147 @@
         <p:spPr>
           <a:xfrm>
             <a:off x="640080" y="1737360"/>
-            <a:ext cx="5394960" cy="1920240"/>
+            <a:ext cx="5120640" cy="3017520"/>
+          </a:xfrm>
+          <a:prstGeom prst="roundRect">
+            <a:avLst>
+              <a:gd name="adj" fmla="val 8000"/>
+            </a:avLst>
+          </a:prstGeom>
+          <a:solidFill>
+            <a:srgbClr val="0B1F3A"/>
+          </a:solidFill>
+          <a:ln>
+            <a:noFill/>
+          </a:ln>
+          <a:effectLst/>
+        </p:spPr>
+        <p:style>
+          <a:lnRef idx="1">
+            <a:schemeClr val="accent1"/>
+          </a:lnRef>
+          <a:fillRef idx="3">
+            <a:schemeClr val="accent1"/>
+          </a:fillRef>
+          <a:effectRef idx="2">
+            <a:schemeClr val="accent1"/>
+          </a:effectRef>
+          <a:fontRef idx="minor">
+            <a:schemeClr val="lt1"/>
+          </a:fontRef>
+        </p:style>
+        <p:txBody>
+          <a:bodyPr rtlCol="0" anchor="ctr"/>
+          <a:lstStyle/>
+          <a:p>
+            <a:pPr algn="ctr"/>
+          </a:p>
+        </p:txBody>
+      </p:sp>
+      <p:sp>
+        <p:nvSpPr>
+          <p:cNvPr id="6" name="TextBox 5"/>
+          <p:cNvSpPr txBox="1"/>
+          <p:nvPr/>
+        </p:nvSpPr>
+        <p:spPr>
+          <a:xfrm>
+            <a:off x="640080" y="2103120"/>
+            <a:ext cx="5120640" cy="1280160"/>
+          </a:xfrm>
+          <a:prstGeom prst="rect">
+            <a:avLst/>
+          </a:prstGeom>
+          <a:noFill/>
+        </p:spPr>
+        <p:txBody>
+          <a:bodyPr wrap="square" anchor="t">
+            <a:spAutoFit/>
+          </a:bodyPr>
+          <a:lstStyle/>
+          <a:p>
+            <a:pPr algn="ctr">
+              <a:spcAft>
+                <a:spcPts val="600"/>
+              </a:spcAft>
+            </a:pPr>
+            <a:r>
+              <a:rPr sz="7200" b="1">
+                <a:solidFill>
+                  <a:srgbClr val="FFFFFF"/>
+                </a:solidFill>
+                <a:latin typeface="Calibri"/>
+              </a:rPr>
+              <a:t>1.0000</a:t>
+            </a:r>
+          </a:p>
+        </p:txBody>
+      </p:sp>
+      <p:sp>
+        <p:nvSpPr>
+          <p:cNvPr id="7" name="TextBox 6"/>
+          <p:cNvSpPr txBox="1"/>
+          <p:nvPr/>
+        </p:nvSpPr>
+        <p:spPr>
+          <a:xfrm>
+            <a:off x="640080" y="3566160"/>
+            <a:ext cx="5120640" cy="1097280"/>
+          </a:xfrm>
+          <a:prstGeom prst="rect">
+            <a:avLst/>
+          </a:prstGeom>
+          <a:noFill/>
+        </p:spPr>
+        <p:txBody>
+          <a:bodyPr wrap="square" anchor="t">
+            <a:spAutoFit/>
+          </a:bodyPr>
+          <a:lstStyle/>
+          <a:p>
+            <a:pPr algn="ctr">
+              <a:spcAft>
+                <a:spcPts val="600"/>
+              </a:spcAft>
+            </a:pPr>
+            <a:r>
+              <a:rPr sz="1500" b="0">
+                <a:solidFill>
+                  <a:srgbClr val="B8C7D9"/>
+                </a:solidFill>
+                <a:latin typeface="Calibri"/>
+              </a:rPr>
+              <a:t>Final score, rule-based reader</a:t>
+            </a:r>
+          </a:p>
+          <a:p>
+            <a:pPr algn="ctr">
+              <a:spcAft>
+                <a:spcPts val="600"/>
+              </a:spcAft>
+            </a:pPr>
+            <a:r>
+              <a:rPr sz="1500" b="0">
+                <a:solidFill>
+                  <a:srgbClr val="B8C7D9"/>
+                </a:solidFill>
+                <a:latin typeface="Calibri"/>
+              </a:rPr>
+              <a:t>520 emails, 46/46 defects caught, 20/20 escalations right</a:t>
+            </a:r>
+          </a:p>
+        </p:txBody>
+      </p:sp>
+      <p:sp>
+        <p:nvSpPr>
+          <p:cNvPr id="8" name="Rounded Rectangle 7"/>
+          <p:cNvSpPr/>
+          <p:nvPr/>
+        </p:nvSpPr>
+        <p:spPr>
+          <a:xfrm>
+            <a:off x="6035040" y="1737360"/>
+            <a:ext cx="5577840" cy="1417320"/>
           </a:xfrm>
           <a:prstGeom prst="roundRect">
             <a:avLst>
@@ -3529,14 +3670,14 @@
       </p:sp>
       <p:sp>
         <p:nvSpPr>
-          <p:cNvPr id="6" name="Rectangle 5"/>
+          <p:cNvPr id="9" name="Rectangle 8"/>
           <p:cNvSpPr/>
           <p:nvPr/>
         </p:nvSpPr>
         <p:spPr>
           <a:xfrm>
-            <a:off x="640080" y="1737360"/>
-            <a:ext cx="73152" cy="1920240"/>
+            <a:off x="6035040" y="1737360"/>
+            <a:ext cx="73152" cy="1417320"/>
           </a:xfrm>
           <a:prstGeom prst="rect">
             <a:avLst/>
@@ -3573,14 +3714,14 @@
       </p:sp>
       <p:sp>
         <p:nvSpPr>
-          <p:cNvPr id="7" name="TextBox 6"/>
-          <p:cNvSpPr txBox="1"/>
-          <p:nvPr/>
-        </p:nvSpPr>
-        <p:spPr>
-          <a:xfrm>
-            <a:off x="868680" y="1847088"/>
-            <a:ext cx="5029200" cy="457200"/>
+          <p:cNvPr id="10" name="TextBox 9"/>
+          <p:cNvSpPr txBox="1"/>
+          <p:nvPr/>
+        </p:nvSpPr>
+        <p:spPr>
+          <a:xfrm>
+            <a:off x="6263640" y="1847088"/>
+            <a:ext cx="5212079" cy="457200"/>
           </a:xfrm>
           <a:prstGeom prst="rect">
             <a:avLst/>
@@ -3605,21 +3746,21 @@
                 </a:solidFill>
                 <a:latin typeface="Calibri"/>
               </a:rPr>
-              <a:t>More documents</a:t>
-            </a:r>
-          </a:p>
-        </p:txBody>
-      </p:sp>
-      <p:sp>
-        <p:nvSpPr>
-          <p:cNvPr id="8" name="TextBox 7"/>
-          <p:cNvSpPr txBox="1"/>
-          <p:nvPr/>
-        </p:nvSpPr>
-        <p:spPr>
-          <a:xfrm>
-            <a:off x="868680" y="2304288"/>
-            <a:ext cx="5029200" cy="1280160"/>
+              <a:t>Live web app</a:t>
+            </a:r>
+          </a:p>
+        </p:txBody>
+      </p:sp>
+      <p:sp>
+        <p:nvSpPr>
+          <p:cNvPr id="11" name="TextBox 10"/>
+          <p:cNvSpPr txBox="1"/>
+          <p:nvPr/>
+        </p:nvSpPr>
+        <p:spPr>
+          <a:xfrm>
+            <a:off x="6263640" y="2304288"/>
+            <a:ext cx="5212079" cy="777240"/>
           </a:xfrm>
           <a:prstGeom prst="rect">
             <a:avLst/>
@@ -3638,27 +3779,27 @@
               </a:spcAft>
             </a:pPr>
             <a:r>
-              <a:rPr sz="1500" b="0">
+              <a:rPr sz="1400" b="0">
                 <a:solidFill>
                   <a:srgbClr val="1F2937"/>
                 </a:solidFill>
                 <a:latin typeface="Calibri"/>
               </a:rPr>
-              <a:t>Invoices, packing lists and certificates of origin.</a:t>
-            </a:r>
-          </a:p>
-        </p:txBody>
-      </p:sp>
-      <p:sp>
-        <p:nvSpPr>
-          <p:cNvPr id="9" name="Rounded Rectangle 8"/>
+              <a:t>Upload two documents or browse the sample inbox, in any browser, no sign-in.</a:t>
+            </a:r>
+          </a:p>
+        </p:txBody>
+      </p:sp>
+      <p:sp>
+        <p:nvSpPr>
+          <p:cNvPr id="12" name="Rounded Rectangle 11"/>
           <p:cNvSpPr/>
           <p:nvPr/>
         </p:nvSpPr>
         <p:spPr>
           <a:xfrm>
-            <a:off x="6217920" y="1737360"/>
-            <a:ext cx="5394960" cy="1920240"/>
+            <a:off x="6035040" y="3337560"/>
+            <a:ext cx="5577840" cy="1417320"/>
           </a:xfrm>
           <a:prstGeom prst="roundRect">
             <a:avLst>
@@ -3697,14 +3838,193 @@
       </p:sp>
       <p:sp>
         <p:nvSpPr>
-          <p:cNvPr id="10" name="Rectangle 9"/>
+          <p:cNvPr id="13" name="Rectangle 12"/>
           <p:cNvSpPr/>
           <p:nvPr/>
         </p:nvSpPr>
         <p:spPr>
           <a:xfrm>
-            <a:off x="6217920" y="1737360"/>
-            <a:ext cx="73152" cy="1920240"/>
+            <a:off x="6035040" y="3337560"/>
+            <a:ext cx="73152" cy="1417320"/>
+          </a:xfrm>
+          <a:prstGeom prst="rect">
+            <a:avLst/>
+          </a:prstGeom>
+          <a:solidFill>
+            <a:srgbClr val="1E8E5A"/>
+          </a:solidFill>
+          <a:ln>
+            <a:noFill/>
+          </a:ln>
+          <a:effectLst/>
+        </p:spPr>
+        <p:style>
+          <a:lnRef idx="1">
+            <a:schemeClr val="accent1"/>
+          </a:lnRef>
+          <a:fillRef idx="3">
+            <a:schemeClr val="accent1"/>
+          </a:fillRef>
+          <a:effectRef idx="2">
+            <a:schemeClr val="accent1"/>
+          </a:effectRef>
+          <a:fontRef idx="minor">
+            <a:schemeClr val="lt1"/>
+          </a:fontRef>
+        </p:style>
+        <p:txBody>
+          <a:bodyPr rtlCol="0" anchor="ctr"/>
+          <a:lstStyle/>
+          <a:p>
+            <a:pPr algn="ctr"/>
+          </a:p>
+        </p:txBody>
+      </p:sp>
+      <p:sp>
+        <p:nvSpPr>
+          <p:cNvPr id="14" name="TextBox 13"/>
+          <p:cNvSpPr txBox="1"/>
+          <p:nvPr/>
+        </p:nvSpPr>
+        <p:spPr>
+          <a:xfrm>
+            <a:off x="6263640" y="3447288"/>
+            <a:ext cx="5212079" cy="457200"/>
+          </a:xfrm>
+          <a:prstGeom prst="rect">
+            <a:avLst/>
+          </a:prstGeom>
+          <a:noFill/>
+        </p:spPr>
+        <p:txBody>
+          <a:bodyPr wrap="square" anchor="t">
+            <a:spAutoFit/>
+          </a:bodyPr>
+          <a:lstStyle/>
+          <a:p>
+            <a:pPr algn="l">
+              <a:spcAft>
+                <a:spcPts val="600"/>
+              </a:spcAft>
+            </a:pPr>
+            <a:r>
+              <a:rPr sz="1700" b="1">
+                <a:solidFill>
+                  <a:srgbClr val="0B1F3A"/>
+                </a:solidFill>
+                <a:latin typeface="Calibri"/>
+              </a:rPr>
+              <a:t>AI reading</a:t>
+            </a:r>
+          </a:p>
+        </p:txBody>
+      </p:sp>
+      <p:sp>
+        <p:nvSpPr>
+          <p:cNvPr id="15" name="TextBox 14"/>
+          <p:cNvSpPr txBox="1"/>
+          <p:nvPr/>
+        </p:nvSpPr>
+        <p:spPr>
+          <a:xfrm>
+            <a:off x="6263640" y="3904487"/>
+            <a:ext cx="5212079" cy="777240"/>
+          </a:xfrm>
+          <a:prstGeom prst="rect">
+            <a:avLst/>
+          </a:prstGeom>
+          <a:noFill/>
+        </p:spPr>
+        <p:txBody>
+          <a:bodyPr wrap="square" anchor="t">
+            <a:spAutoFit/>
+          </a:bodyPr>
+          <a:lstStyle/>
+          <a:p>
+            <a:pPr algn="l">
+              <a:spcAft>
+                <a:spcPts val="600"/>
+              </a:spcAft>
+            </a:pPr>
+            <a:r>
+              <a:rPr sz="1400" b="0">
+                <a:solidFill>
+                  <a:srgbClr val="1F2937"/>
+                </a:solidFill>
+                <a:latin typeface="Calibri"/>
+              </a:rPr>
+              <a:t>Claude reads every format including scans. Decisions stay in plain code.</a:t>
+            </a:r>
+          </a:p>
+        </p:txBody>
+      </p:sp>
+      <p:sp>
+        <p:nvSpPr>
+          <p:cNvPr id="16" name="TextBox 15"/>
+          <p:cNvSpPr txBox="1"/>
+          <p:nvPr/>
+        </p:nvSpPr>
+        <p:spPr>
+          <a:xfrm>
+            <a:off x="640080" y="5120640"/>
+            <a:ext cx="10972800" cy="914400"/>
+          </a:xfrm>
+          <a:prstGeom prst="rect">
+            <a:avLst/>
+          </a:prstGeom>
+          <a:noFill/>
+        </p:spPr>
+        <p:txBody>
+          <a:bodyPr wrap="square" anchor="t">
+            <a:spAutoFit/>
+          </a:bodyPr>
+          <a:lstStyle/>
+          <a:p>
+            <a:pPr algn="l">
+              <a:spcAft>
+                <a:spcPts val="600"/>
+              </a:spcAft>
+            </a:pPr>
+            <a:r>
+              <a:rPr sz="1400" b="0">
+                <a:solidFill>
+                  <a:srgbClr val="6B7280"/>
+                </a:solidFill>
+                <a:latin typeface="Calibri"/>
+              </a:rPr>
+              <a:t>Also verified on four freshly generated datasets. The AI reader is optional and advisory; the submitted results come from the rule-based reader.</a:t>
+            </a:r>
+          </a:p>
+        </p:txBody>
+      </p:sp>
+    </p:spTree>
+  </p:cSld>
+  <p:clrMapOvr>
+    <a:masterClrMapping/>
+  </p:clrMapOvr>
+</p:sld>
+</file>
+
+<file path=ppt/slides/slide11.xml><?xml version="1.0" encoding="utf-8"?>
+<p:sld xmlns:a="http://schemas.openxmlformats.org/drawingml/2006/main" xmlns:p="http://schemas.openxmlformats.org/presentationml/2006/main" xmlns:r="http://schemas.openxmlformats.org/officeDocument/2006/relationships">
+  <p:cSld>
+    <p:spTree>
+      <p:nvGrpSpPr>
+        <p:cNvPr id="1" name=""/>
+        <p:cNvGrpSpPr/>
+        <p:nvPr/>
+      </p:nvGrpSpPr>
+      <p:grpSpPr/>
+      <p:sp>
+        <p:nvSpPr>
+          <p:cNvPr id="2" name="Rectangle 1"/>
+          <p:cNvSpPr/>
+          <p:nvPr/>
+        </p:nvSpPr>
+        <p:spPr>
+          <a:xfrm>
+            <a:off x="0" y="0"/>
+            <a:ext cx="12191695" cy="109728"/>
           </a:xfrm>
           <a:prstGeom prst="rect">
             <a:avLst/>
@@ -3741,14 +4061,14 @@
       </p:sp>
       <p:sp>
         <p:nvSpPr>
-          <p:cNvPr id="11" name="TextBox 10"/>
-          <p:cNvSpPr txBox="1"/>
-          <p:nvPr/>
-        </p:nvSpPr>
-        <p:spPr>
-          <a:xfrm>
-            <a:off x="6446520" y="1847088"/>
-            <a:ext cx="5029200" cy="457200"/>
+          <p:cNvPr id="3" name="TextBox 2"/>
+          <p:cNvSpPr txBox="1"/>
+          <p:nvPr/>
+        </p:nvSpPr>
+        <p:spPr>
+          <a:xfrm>
+            <a:off x="640080" y="320040"/>
+            <a:ext cx="9144000" cy="320040"/>
           </a:xfrm>
           <a:prstGeom prst="rect">
             <a:avLst/>
@@ -3767,65 +4087,65 @@
               </a:spcAft>
             </a:pPr>
             <a:r>
-              <a:rPr sz="1700" b="1">
+              <a:rPr sz="1200" b="1">
+                <a:solidFill>
+                  <a:srgbClr val="0E9F9A"/>
+                </a:solidFill>
+                <a:latin typeface="Calibri"/>
+              </a:rPr>
+              <a:t>FUTURE ROADMAP</a:t>
+            </a:r>
+          </a:p>
+        </p:txBody>
+      </p:sp>
+      <p:sp>
+        <p:nvSpPr>
+          <p:cNvPr id="4" name="TextBox 3"/>
+          <p:cNvSpPr txBox="1"/>
+          <p:nvPr/>
+        </p:nvSpPr>
+        <p:spPr>
+          <a:xfrm>
+            <a:off x="640080" y="594360"/>
+            <a:ext cx="10972800" cy="822960"/>
+          </a:xfrm>
+          <a:prstGeom prst="rect">
+            <a:avLst/>
+          </a:prstGeom>
+          <a:noFill/>
+        </p:spPr>
+        <p:txBody>
+          <a:bodyPr wrap="square" anchor="t">
+            <a:spAutoFit/>
+          </a:bodyPr>
+          <a:lstStyle/>
+          <a:p>
+            <a:pPr algn="l">
+              <a:spcAft>
+                <a:spcPts val="600"/>
+              </a:spcAft>
+            </a:pPr>
+            <a:r>
+              <a:rPr sz="3200" b="1">
                 <a:solidFill>
                   <a:srgbClr val="0B1F3A"/>
                 </a:solidFill>
                 <a:latin typeface="Calibri"/>
               </a:rPr>
-              <a:t>More fields</a:t>
-            </a:r>
-          </a:p>
-        </p:txBody>
-      </p:sp>
-      <p:sp>
-        <p:nvSpPr>
-          <p:cNvPr id="12" name="TextBox 11"/>
-          <p:cNvSpPr txBox="1"/>
-          <p:nvPr/>
-        </p:nvSpPr>
-        <p:spPr>
-          <a:xfrm>
-            <a:off x="6446520" y="2304288"/>
-            <a:ext cx="5029200" cy="1280160"/>
-          </a:xfrm>
-          <a:prstGeom prst="rect">
-            <a:avLst/>
-          </a:prstGeom>
-          <a:noFill/>
-        </p:spPr>
-        <p:txBody>
-          <a:bodyPr wrap="square" anchor="t">
-            <a:spAutoFit/>
-          </a:bodyPr>
-          <a:lstStyle/>
-          <a:p>
-            <a:pPr algn="l">
-              <a:spcAft>
-                <a:spcPts val="600"/>
-              </a:spcAft>
-            </a:pPr>
-            <a:r>
-              <a:rPr sz="1500" b="0">
-                <a:solidFill>
-                  <a:srgbClr val="1F2937"/>
-                </a:solidFill>
-                <a:latin typeface="Calibri"/>
-              </a:rPr>
-              <a:t>Vessel, voyage, cargo description and HS code.</a:t>
-            </a:r>
-          </a:p>
-        </p:txBody>
-      </p:sp>
-      <p:sp>
-        <p:nvSpPr>
-          <p:cNvPr id="13" name="Rounded Rectangle 12"/>
+              <a:t>Where this goes next</a:t>
+            </a:r>
+          </a:p>
+        </p:txBody>
+      </p:sp>
+      <p:sp>
+        <p:nvSpPr>
+          <p:cNvPr id="5" name="Rounded Rectangle 4"/>
           <p:cNvSpPr/>
           <p:nvPr/>
         </p:nvSpPr>
         <p:spPr>
           <a:xfrm>
-            <a:off x="640080" y="3931920"/>
+            <a:off x="640080" y="1737360"/>
             <a:ext cx="5394960" cy="1920240"/>
           </a:xfrm>
           <a:prstGeom prst="roundRect">
@@ -3865,13 +4185,13 @@
       </p:sp>
       <p:sp>
         <p:nvSpPr>
-          <p:cNvPr id="14" name="Rectangle 13"/>
+          <p:cNvPr id="6" name="Rectangle 5"/>
           <p:cNvSpPr/>
           <p:nvPr/>
         </p:nvSpPr>
         <p:spPr>
           <a:xfrm>
-            <a:off x="640080" y="3931920"/>
+            <a:off x="640080" y="1737360"/>
             <a:ext cx="73152" cy="1920240"/>
           </a:xfrm>
           <a:prstGeom prst="rect">
@@ -3909,6 +4229,342 @@
       </p:sp>
       <p:sp>
         <p:nvSpPr>
+          <p:cNvPr id="7" name="TextBox 6"/>
+          <p:cNvSpPr txBox="1"/>
+          <p:nvPr/>
+        </p:nvSpPr>
+        <p:spPr>
+          <a:xfrm>
+            <a:off x="868680" y="1847088"/>
+            <a:ext cx="5029200" cy="457200"/>
+          </a:xfrm>
+          <a:prstGeom prst="rect">
+            <a:avLst/>
+          </a:prstGeom>
+          <a:noFill/>
+        </p:spPr>
+        <p:txBody>
+          <a:bodyPr wrap="square" anchor="t">
+            <a:spAutoFit/>
+          </a:bodyPr>
+          <a:lstStyle/>
+          <a:p>
+            <a:pPr algn="l">
+              <a:spcAft>
+                <a:spcPts val="600"/>
+              </a:spcAft>
+            </a:pPr>
+            <a:r>
+              <a:rPr sz="1700" b="1">
+                <a:solidFill>
+                  <a:srgbClr val="0B1F3A"/>
+                </a:solidFill>
+                <a:latin typeface="Calibri"/>
+              </a:rPr>
+              <a:t>More documents</a:t>
+            </a:r>
+          </a:p>
+        </p:txBody>
+      </p:sp>
+      <p:sp>
+        <p:nvSpPr>
+          <p:cNvPr id="8" name="TextBox 7"/>
+          <p:cNvSpPr txBox="1"/>
+          <p:nvPr/>
+        </p:nvSpPr>
+        <p:spPr>
+          <a:xfrm>
+            <a:off x="868680" y="2304288"/>
+            <a:ext cx="5029200" cy="1280160"/>
+          </a:xfrm>
+          <a:prstGeom prst="rect">
+            <a:avLst/>
+          </a:prstGeom>
+          <a:noFill/>
+        </p:spPr>
+        <p:txBody>
+          <a:bodyPr wrap="square" anchor="t">
+            <a:spAutoFit/>
+          </a:bodyPr>
+          <a:lstStyle/>
+          <a:p>
+            <a:pPr algn="l">
+              <a:spcAft>
+                <a:spcPts val="600"/>
+              </a:spcAft>
+            </a:pPr>
+            <a:r>
+              <a:rPr sz="1500" b="0">
+                <a:solidFill>
+                  <a:srgbClr val="1F2937"/>
+                </a:solidFill>
+                <a:latin typeface="Calibri"/>
+              </a:rPr>
+              <a:t>Invoices, packing lists and certificates of origin.</a:t>
+            </a:r>
+          </a:p>
+        </p:txBody>
+      </p:sp>
+      <p:sp>
+        <p:nvSpPr>
+          <p:cNvPr id="9" name="Rounded Rectangle 8"/>
+          <p:cNvSpPr/>
+          <p:nvPr/>
+        </p:nvSpPr>
+        <p:spPr>
+          <a:xfrm>
+            <a:off x="6217920" y="1737360"/>
+            <a:ext cx="5394960" cy="1920240"/>
+          </a:xfrm>
+          <a:prstGeom prst="roundRect">
+            <a:avLst>
+              <a:gd name="adj" fmla="val 8000"/>
+            </a:avLst>
+          </a:prstGeom>
+          <a:solidFill>
+            <a:srgbClr val="EEF4F7"/>
+          </a:solidFill>
+          <a:ln>
+            <a:noFill/>
+          </a:ln>
+          <a:effectLst/>
+        </p:spPr>
+        <p:style>
+          <a:lnRef idx="1">
+            <a:schemeClr val="accent1"/>
+          </a:lnRef>
+          <a:fillRef idx="3">
+            <a:schemeClr val="accent1"/>
+          </a:fillRef>
+          <a:effectRef idx="2">
+            <a:schemeClr val="accent1"/>
+          </a:effectRef>
+          <a:fontRef idx="minor">
+            <a:schemeClr val="lt1"/>
+          </a:fontRef>
+        </p:style>
+        <p:txBody>
+          <a:bodyPr rtlCol="0" anchor="ctr"/>
+          <a:lstStyle/>
+          <a:p>
+            <a:pPr algn="ctr"/>
+          </a:p>
+        </p:txBody>
+      </p:sp>
+      <p:sp>
+        <p:nvSpPr>
+          <p:cNvPr id="10" name="Rectangle 9"/>
+          <p:cNvSpPr/>
+          <p:nvPr/>
+        </p:nvSpPr>
+        <p:spPr>
+          <a:xfrm>
+            <a:off x="6217920" y="1737360"/>
+            <a:ext cx="73152" cy="1920240"/>
+          </a:xfrm>
+          <a:prstGeom prst="rect">
+            <a:avLst/>
+          </a:prstGeom>
+          <a:solidFill>
+            <a:srgbClr val="0E9F9A"/>
+          </a:solidFill>
+          <a:ln>
+            <a:noFill/>
+          </a:ln>
+          <a:effectLst/>
+        </p:spPr>
+        <p:style>
+          <a:lnRef idx="1">
+            <a:schemeClr val="accent1"/>
+          </a:lnRef>
+          <a:fillRef idx="3">
+            <a:schemeClr val="accent1"/>
+          </a:fillRef>
+          <a:effectRef idx="2">
+            <a:schemeClr val="accent1"/>
+          </a:effectRef>
+          <a:fontRef idx="minor">
+            <a:schemeClr val="lt1"/>
+          </a:fontRef>
+        </p:style>
+        <p:txBody>
+          <a:bodyPr rtlCol="0" anchor="ctr"/>
+          <a:lstStyle/>
+          <a:p>
+            <a:pPr algn="ctr"/>
+          </a:p>
+        </p:txBody>
+      </p:sp>
+      <p:sp>
+        <p:nvSpPr>
+          <p:cNvPr id="11" name="TextBox 10"/>
+          <p:cNvSpPr txBox="1"/>
+          <p:nvPr/>
+        </p:nvSpPr>
+        <p:spPr>
+          <a:xfrm>
+            <a:off x="6446520" y="1847088"/>
+            <a:ext cx="5029200" cy="457200"/>
+          </a:xfrm>
+          <a:prstGeom prst="rect">
+            <a:avLst/>
+          </a:prstGeom>
+          <a:noFill/>
+        </p:spPr>
+        <p:txBody>
+          <a:bodyPr wrap="square" anchor="t">
+            <a:spAutoFit/>
+          </a:bodyPr>
+          <a:lstStyle/>
+          <a:p>
+            <a:pPr algn="l">
+              <a:spcAft>
+                <a:spcPts val="600"/>
+              </a:spcAft>
+            </a:pPr>
+            <a:r>
+              <a:rPr sz="1700" b="1">
+                <a:solidFill>
+                  <a:srgbClr val="0B1F3A"/>
+                </a:solidFill>
+                <a:latin typeface="Calibri"/>
+              </a:rPr>
+              <a:t>More fields</a:t>
+            </a:r>
+          </a:p>
+        </p:txBody>
+      </p:sp>
+      <p:sp>
+        <p:nvSpPr>
+          <p:cNvPr id="12" name="TextBox 11"/>
+          <p:cNvSpPr txBox="1"/>
+          <p:nvPr/>
+        </p:nvSpPr>
+        <p:spPr>
+          <a:xfrm>
+            <a:off x="6446520" y="2304288"/>
+            <a:ext cx="5029200" cy="1280160"/>
+          </a:xfrm>
+          <a:prstGeom prst="rect">
+            <a:avLst/>
+          </a:prstGeom>
+          <a:noFill/>
+        </p:spPr>
+        <p:txBody>
+          <a:bodyPr wrap="square" anchor="t">
+            <a:spAutoFit/>
+          </a:bodyPr>
+          <a:lstStyle/>
+          <a:p>
+            <a:pPr algn="l">
+              <a:spcAft>
+                <a:spcPts val="600"/>
+              </a:spcAft>
+            </a:pPr>
+            <a:r>
+              <a:rPr sz="1500" b="0">
+                <a:solidFill>
+                  <a:srgbClr val="1F2937"/>
+                </a:solidFill>
+                <a:latin typeface="Calibri"/>
+              </a:rPr>
+              <a:t>Vessel, voyage, cargo description and HS code.</a:t>
+            </a:r>
+          </a:p>
+        </p:txBody>
+      </p:sp>
+      <p:sp>
+        <p:nvSpPr>
+          <p:cNvPr id="13" name="Rounded Rectangle 12"/>
+          <p:cNvSpPr/>
+          <p:nvPr/>
+        </p:nvSpPr>
+        <p:spPr>
+          <a:xfrm>
+            <a:off x="640080" y="3931920"/>
+            <a:ext cx="5394960" cy="1920240"/>
+          </a:xfrm>
+          <a:prstGeom prst="roundRect">
+            <a:avLst>
+              <a:gd name="adj" fmla="val 8000"/>
+            </a:avLst>
+          </a:prstGeom>
+          <a:solidFill>
+            <a:srgbClr val="EEF4F7"/>
+          </a:solidFill>
+          <a:ln>
+            <a:noFill/>
+          </a:ln>
+          <a:effectLst/>
+        </p:spPr>
+        <p:style>
+          <a:lnRef idx="1">
+            <a:schemeClr val="accent1"/>
+          </a:lnRef>
+          <a:fillRef idx="3">
+            <a:schemeClr val="accent1"/>
+          </a:fillRef>
+          <a:effectRef idx="2">
+            <a:schemeClr val="accent1"/>
+          </a:effectRef>
+          <a:fontRef idx="minor">
+            <a:schemeClr val="lt1"/>
+          </a:fontRef>
+        </p:style>
+        <p:txBody>
+          <a:bodyPr rtlCol="0" anchor="ctr"/>
+          <a:lstStyle/>
+          <a:p>
+            <a:pPr algn="ctr"/>
+          </a:p>
+        </p:txBody>
+      </p:sp>
+      <p:sp>
+        <p:nvSpPr>
+          <p:cNvPr id="14" name="Rectangle 13"/>
+          <p:cNvSpPr/>
+          <p:nvPr/>
+        </p:nvSpPr>
+        <p:spPr>
+          <a:xfrm>
+            <a:off x="640080" y="3931920"/>
+            <a:ext cx="73152" cy="1920240"/>
+          </a:xfrm>
+          <a:prstGeom prst="rect">
+            <a:avLst/>
+          </a:prstGeom>
+          <a:solidFill>
+            <a:srgbClr val="0E9F9A"/>
+          </a:solidFill>
+          <a:ln>
+            <a:noFill/>
+          </a:ln>
+          <a:effectLst/>
+        </p:spPr>
+        <p:style>
+          <a:lnRef idx="1">
+            <a:schemeClr val="accent1"/>
+          </a:lnRef>
+          <a:fillRef idx="3">
+            <a:schemeClr val="accent1"/>
+          </a:fillRef>
+          <a:effectRef idx="2">
+            <a:schemeClr val="accent1"/>
+          </a:effectRef>
+          <a:fontRef idx="minor">
+            <a:schemeClr val="lt1"/>
+          </a:fontRef>
+        </p:style>
+        <p:txBody>
+          <a:bodyPr rtlCol="0" anchor="ctr"/>
+          <a:lstStyle/>
+          <a:p>
+            <a:pPr algn="ctr"/>
+          </a:p>
+        </p:txBody>
+      </p:sp>
+      <p:sp>
+        <p:nvSpPr>
           <p:cNvPr id="15" name="TextBox 14"/>
           <p:cNvSpPr txBox="1"/>
           <p:nvPr/>
@@ -3941,7 +4597,7 @@
                 </a:solidFill>
                 <a:latin typeface="Calibri"/>
               </a:rPr>
-              <a:t>Review queue</a:t>
+              <a:t>Real sending</a:t>
             </a:r>
           </a:p>
         </p:txBody>
@@ -3980,7 +4636,7 @@
                 </a:solidFill>
                 <a:latin typeface="Calibri"/>
               </a:rPr>
-              <a:t>One-click approve or fix for every NEEDS REVIEW item, with an audit log.</a:t>
+              <a:t>Connect the Outbox to a mailbox so approved replies really go out.</a:t>
             </a:r>
           </a:p>
         </p:txBody>
@@ -9373,7 +10029,7 @@
                 </a:solidFill>
                 <a:latin typeface="Calibri"/>
               </a:rPr>
-              <a:t>Every email at a glance: outcomes, most common defects, and reasons for escalation.</a:t>
+              <a:t>Outcomes, most common defects and escalation reasons at a glance, plus the time saved.</a:t>
             </a:r>
           </a:p>
         </p:txBody>
@@ -9943,7 +10599,7 @@
             <a:avLst/>
           </a:prstGeom>
           <a:solidFill>
-            <a:srgbClr val="0E9F9A"/>
+            <a:srgbClr val="C77D0A"/>
           </a:solidFill>
           <a:ln>
             <a:noFill/>
@@ -10006,7 +10662,7 @@
                 </a:solidFill>
                 <a:latin typeface="Calibri"/>
               </a:rPr>
-              <a:t>Draft replies</a:t>
+              <a:t>Compare and batch</a:t>
             </a:r>
           </a:p>
         </p:txBody>
@@ -10045,7 +10701,7 @@
                 </a:solidFill>
                 <a:latin typeface="Calibri"/>
               </a:rPr>
-              <a:t>A ready-to-send message to the sender listing the discrepancies.</a:t>
+              <a:t>Upload two files or many at once, auto-paired, with CSV and submission.json downloads.</a:t>
             </a:r>
           </a:p>
         </p:txBody>
@@ -10111,7 +10767,7 @@
             <a:avLst/>
           </a:prstGeom>
           <a:solidFill>
-            <a:srgbClr val="C77D0A"/>
+            <a:srgbClr val="0E9F9A"/>
           </a:solidFill>
           <a:ln>
             <a:noFill/>
@@ -10174,7 +10830,7 @@
                 </a:solidFill>
                 <a:latin typeface="Calibri"/>
               </a:rPr>
-              <a:t>Batch mode</a:t>
+              <a:t>Inbox browser</a:t>
             </a:r>
           </a:p>
         </p:txBody>
@@ -10213,7 +10869,7 @@
                 </a:solidFill>
                 <a:latin typeface="Calibri"/>
               </a:rPr>
-              <a:t>Drop many SI/BL files at once, auto-paired by name, with a CSV of results.</a:t>
+              <a:t>Click any of the 520 emails to see its category, verdict and fields.</a:t>
             </a:r>
           </a:p>
         </p:txBody>
@@ -10314,7 +10970,7 @@
                 </a:solidFill>
                 <a:latin typeface="Calibri"/>
               </a:rPr>
-              <a:t>CHALLENGES</a:t>
+              <a:t>OUTBOX, PLAYGROUND AND AI ASSIST</a:t>
             </a:r>
           </a:p>
         </p:txBody>
@@ -10353,7 +11009,7 @@
                 </a:solidFill>
                 <a:latin typeface="Calibri"/>
               </a:rPr>
-              <a:t>What we ran into</a:t>
+              <a:t>Closing the loop with the sender</a:t>
             </a:r>
           </a:p>
         </p:txBody>
@@ -10367,7 +11023,7 @@
         <p:spPr>
           <a:xfrm>
             <a:off x="640080" y="1737360"/>
-            <a:ext cx="3566160" cy="2194560"/>
+            <a:ext cx="3566160" cy="2286000"/>
           </a:xfrm>
           <a:prstGeom prst="roundRect">
             <a:avLst>
@@ -10413,7 +11069,7 @@
         <p:spPr>
           <a:xfrm>
             <a:off x="640080" y="1737360"/>
-            <a:ext cx="73152" cy="2194560"/>
+            <a:ext cx="73152" cy="2286000"/>
           </a:xfrm>
           <a:prstGeom prst="rect">
             <a:avLst/>
@@ -10482,7 +11138,7 @@
                 </a:solidFill>
                 <a:latin typeface="Calibri"/>
               </a:rPr>
-              <a:t>Label variants</a:t>
+              <a:t>Outbox (simulated)</a:t>
             </a:r>
           </a:p>
         </p:txBody>
@@ -10496,7 +11152,7 @@
         <p:spPr>
           <a:xfrm>
             <a:off x="868680" y="2304288"/>
-            <a:ext cx="3200400" cy="1554480"/>
+            <a:ext cx="3200400" cy="1645920"/>
           </a:xfrm>
           <a:prstGeom prst="rect">
             <a:avLst/>
@@ -10521,7 +11177,7 @@
                 </a:solidFill>
                 <a:latin typeface="Calibri"/>
               </a:rPr>
-              <a:t>The same field appears under many names across formats and documents.</a:t>
+              <a:t>A reply is drafted for every email. OK and mismatch replies are auto-sent; anything uncertain is held for a person. Nothing is really emailed.</a:t>
             </a:r>
           </a:p>
         </p:txBody>
@@ -10535,7 +11191,7 @@
         <p:spPr>
           <a:xfrm>
             <a:off x="4315968" y="1737360"/>
-            <a:ext cx="3566160" cy="2194560"/>
+            <a:ext cx="3566160" cy="2286000"/>
           </a:xfrm>
           <a:prstGeom prst="roundRect">
             <a:avLst>
@@ -10581,7 +11237,7 @@
         <p:spPr>
           <a:xfrm>
             <a:off x="4315968" y="1737360"/>
-            <a:ext cx="73152" cy="2194560"/>
+            <a:ext cx="73152" cy="2286000"/>
           </a:xfrm>
           <a:prstGeom prst="rect">
             <a:avLst/>
@@ -10650,7 +11306,7 @@
                 </a:solidFill>
                 <a:latin typeface="Calibri"/>
               </a:rPr>
-              <a:t>PDF text corruption</a:t>
+              <a:t>Playground and samples</a:t>
             </a:r>
           </a:p>
         </p:txBody>
@@ -10664,7 +11320,7 @@
         <p:spPr>
           <a:xfrm>
             <a:off x="4544568" y="2304288"/>
-            <a:ext cx="3200400" cy="1554480"/>
+            <a:ext cx="3200400" cy="1645920"/>
           </a:xfrm>
           <a:prstGeom prst="rect">
             <a:avLst/>
@@ -10689,7 +11345,7 @@
                 </a:solidFill>
                 <a:latin typeface="Calibri"/>
               </a:rPr>
-              <a:t>Long labels ran into their values and scrambled the text. Splitting by font weight fixed it.</a:t>
+              <a:t>Nine ready-made cases, and a tool to break a document (change a weight, add a typo) and watch the verdict change live.</a:t>
             </a:r>
           </a:p>
         </p:txBody>
@@ -10703,7 +11359,7 @@
         <p:spPr>
           <a:xfrm>
             <a:off x="7991856" y="1737360"/>
-            <a:ext cx="3566160" cy="2194560"/>
+            <a:ext cx="3566160" cy="2286000"/>
           </a:xfrm>
           <a:prstGeom prst="roundRect">
             <a:avLst>
@@ -10749,13 +11405,13 @@
         <p:spPr>
           <a:xfrm>
             <a:off x="7991856" y="1737360"/>
-            <a:ext cx="73152" cy="2194560"/>
+            <a:ext cx="73152" cy="2286000"/>
           </a:xfrm>
           <a:prstGeom prst="rect">
             <a:avLst/>
           </a:prstGeom>
           <a:solidFill>
-            <a:srgbClr val="C0392B"/>
+            <a:srgbClr val="1E8E5A"/>
           </a:solidFill>
           <a:ln>
             <a:noFill/>
@@ -10818,7 +11474,7 @@
                 </a:solidFill>
                 <a:latin typeface="Calibri"/>
               </a:rPr>
-              <a:t>Scanned documents</a:t>
+              <a:t>AI second opinion</a:t>
             </a:r>
           </a:p>
         </p:txBody>
@@ -10832,7 +11488,7 @@
         <p:spPr>
           <a:xfrm>
             <a:off x="8220456" y="2304288"/>
-            <a:ext cx="3200400" cy="1554480"/>
+            <a:ext cx="3200400" cy="1645920"/>
           </a:xfrm>
           <a:prstGeom prst="rect">
             <a:avLst/>
@@ -10857,7 +11513,7 @@
                 </a:solidFill>
                 <a:latin typeface="Calibri"/>
               </a:rPr>
-              <a:t>Image-only pages can't be trusted, so they always go to a human.</a:t>
+              <a:t>For cases sent to a human, the AI offers an advisory read. It can never change the verdict.</a:t>
             </a:r>
           </a:p>
         </p:txBody>
@@ -10870,8 +11526,8 @@
         </p:nvSpPr>
         <p:spPr>
           <a:xfrm>
-            <a:off x="640080" y="4114800"/>
-            <a:ext cx="5486400" cy="2011680"/>
+            <a:off x="640080" y="4206240"/>
+            <a:ext cx="10972800" cy="1920240"/>
           </a:xfrm>
           <a:prstGeom prst="roundRect">
             <a:avLst>
@@ -10916,8 +11572,8 @@
         </p:nvSpPr>
         <p:spPr>
           <a:xfrm>
-            <a:off x="640080" y="4114800"/>
-            <a:ext cx="73152" cy="2011680"/>
+            <a:off x="640080" y="4206240"/>
+            <a:ext cx="73152" cy="1920240"/>
           </a:xfrm>
           <a:prstGeom prst="rect">
             <a:avLst/>
@@ -10960,8 +11616,8 @@
         </p:nvSpPr>
         <p:spPr>
           <a:xfrm>
-            <a:off x="868680" y="4224528"/>
-            <a:ext cx="5120640" cy="457200"/>
+            <a:off x="868680" y="4315968"/>
+            <a:ext cx="10607040" cy="457200"/>
           </a:xfrm>
           <a:prstGeom prst="rect">
             <a:avLst/>
@@ -10986,7 +11642,7 @@
                 </a:solidFill>
                 <a:latin typeface="Calibri"/>
               </a:rPr>
-              <a:t>Inconsistent AI output</a:t>
+              <a:t>AI polish, with guard rails</a:t>
             </a:r>
           </a:p>
         </p:txBody>
@@ -10999,8 +11655,8 @@
         </p:nvSpPr>
         <p:spPr>
           <a:xfrm>
-            <a:off x="868680" y="4681728"/>
-            <a:ext cx="5120640" cy="1371600"/>
+            <a:off x="868680" y="4773168"/>
+            <a:ext cx="10607040" cy="1280160"/>
           </a:xfrm>
           <a:prstGeom prst="rect">
             <a:avLst/>
@@ -11025,175 +11681,7 @@
                 </a:solidFill>
                 <a:latin typeface="Calibri"/>
               </a:rPr>
-              <a:t>The AI sometimes shortened a port name on one document but not the other, creating false mismatches. We tightened the prompt, and scans always go to a human.</a:t>
-            </a:r>
-          </a:p>
-        </p:txBody>
-      </p:sp>
-      <p:sp>
-        <p:nvSpPr>
-          <p:cNvPr id="21" name="Rounded Rectangle 20"/>
-          <p:cNvSpPr/>
-          <p:nvPr/>
-        </p:nvSpPr>
-        <p:spPr>
-          <a:xfrm>
-            <a:off x="6309360" y="4114800"/>
-            <a:ext cx="5303520" cy="2011680"/>
-          </a:xfrm>
-          <a:prstGeom prst="roundRect">
-            <a:avLst>
-              <a:gd name="adj" fmla="val 8000"/>
-            </a:avLst>
-          </a:prstGeom>
-          <a:solidFill>
-            <a:srgbClr val="EEF4F7"/>
-          </a:solidFill>
-          <a:ln>
-            <a:noFill/>
-          </a:ln>
-          <a:effectLst/>
-        </p:spPr>
-        <p:style>
-          <a:lnRef idx="1">
-            <a:schemeClr val="accent1"/>
-          </a:lnRef>
-          <a:fillRef idx="3">
-            <a:schemeClr val="accent1"/>
-          </a:fillRef>
-          <a:effectRef idx="2">
-            <a:schemeClr val="accent1"/>
-          </a:effectRef>
-          <a:fontRef idx="minor">
-            <a:schemeClr val="lt1"/>
-          </a:fontRef>
-        </p:style>
-        <p:txBody>
-          <a:bodyPr rtlCol="0" anchor="ctr"/>
-          <a:lstStyle/>
-          <a:p>
-            <a:pPr algn="ctr"/>
-          </a:p>
-        </p:txBody>
-      </p:sp>
-      <p:sp>
-        <p:nvSpPr>
-          <p:cNvPr id="22" name="Rectangle 21"/>
-          <p:cNvSpPr/>
-          <p:nvPr/>
-        </p:nvSpPr>
-        <p:spPr>
-          <a:xfrm>
-            <a:off x="6309360" y="4114800"/>
-            <a:ext cx="73152" cy="2011680"/>
-          </a:xfrm>
-          <a:prstGeom prst="rect">
-            <a:avLst/>
-          </a:prstGeom>
-          <a:solidFill>
-            <a:srgbClr val="1E8E5A"/>
-          </a:solidFill>
-          <a:ln>
-            <a:noFill/>
-          </a:ln>
-          <a:effectLst/>
-        </p:spPr>
-        <p:style>
-          <a:lnRef idx="1">
-            <a:schemeClr val="accent1"/>
-          </a:lnRef>
-          <a:fillRef idx="3">
-            <a:schemeClr val="accent1"/>
-          </a:fillRef>
-          <a:effectRef idx="2">
-            <a:schemeClr val="accent1"/>
-          </a:effectRef>
-          <a:fontRef idx="minor">
-            <a:schemeClr val="lt1"/>
-          </a:fontRef>
-        </p:style>
-        <p:txBody>
-          <a:bodyPr rtlCol="0" anchor="ctr"/>
-          <a:lstStyle/>
-          <a:p>
-            <a:pPr algn="ctr"/>
-          </a:p>
-        </p:txBody>
-      </p:sp>
-      <p:sp>
-        <p:nvSpPr>
-          <p:cNvPr id="23" name="TextBox 22"/>
-          <p:cNvSpPr txBox="1"/>
-          <p:nvPr/>
-        </p:nvSpPr>
-        <p:spPr>
-          <a:xfrm>
-            <a:off x="6537960" y="4224528"/>
-            <a:ext cx="4937759" cy="457200"/>
-          </a:xfrm>
-          <a:prstGeom prst="rect">
-            <a:avLst/>
-          </a:prstGeom>
-          <a:noFill/>
-        </p:spPr>
-        <p:txBody>
-          <a:bodyPr wrap="square" anchor="t">
-            <a:spAutoFit/>
-          </a:bodyPr>
-          <a:lstStyle/>
-          <a:p>
-            <a:pPr algn="l">
-              <a:spcAft>
-                <a:spcPts val="600"/>
-              </a:spcAft>
-            </a:pPr>
-            <a:r>
-              <a:rPr sz="1700" b="1">
-                <a:solidFill>
-                  <a:srgbClr val="0B1F3A"/>
-                </a:solidFill>
-                <a:latin typeface="Calibri"/>
-              </a:rPr>
-              <a:t>A stray space in the API key</a:t>
-            </a:r>
-          </a:p>
-        </p:txBody>
-      </p:sp>
-      <p:sp>
-        <p:nvSpPr>
-          <p:cNvPr id="24" name="TextBox 23"/>
-          <p:cNvSpPr txBox="1"/>
-          <p:nvPr/>
-        </p:nvSpPr>
-        <p:spPr>
-          <a:xfrm>
-            <a:off x="6537960" y="4681728"/>
-            <a:ext cx="4937759" cy="1371600"/>
-          </a:xfrm>
-          <a:prstGeom prst="rect">
-            <a:avLst/>
-          </a:prstGeom>
-          <a:noFill/>
-        </p:spPr>
-        <p:txBody>
-          <a:bodyPr wrap="square" anchor="t">
-            <a:spAutoFit/>
-          </a:bodyPr>
-          <a:lstStyle/>
-          <a:p>
-            <a:pPr algn="l">
-              <a:spcAft>
-                <a:spcPts val="600"/>
-              </a:spcAft>
-            </a:pPr>
-            <a:r>
-              <a:rPr sz="1400" b="0">
-                <a:solidFill>
-                  <a:srgbClr val="1F2937"/>
-                </a:solidFill>
-                <a:latin typeface="Calibri"/>
-              </a:rPr>
-              <a:t>An invisible trailing character broke every request. The key is now trimmed in code.</a:t>
+              <a:t>Any draft reply can be reworded by AI. The rewrite is rejected unless every original value appears unchanged and no new numbers are added. Cost controls: an access code, a hard off-switch, and cached reads.</a:t>
             </a:r>
           </a:p>
         </p:txBody>
@@ -11294,7 +11782,7 @@
                 </a:solidFill>
                 <a:latin typeface="Calibri"/>
               </a:rPr>
-              <a:t>MEASURED WITH THE ORGANIZER'S SCORER</a:t>
+              <a:t>CHALLENGES</a:t>
             </a:r>
           </a:p>
         </p:txBody>
@@ -11333,7 +11821,7 @@
                 </a:solidFill>
                 <a:latin typeface="Calibri"/>
               </a:rPr>
-              <a:t>Results</a:t>
+              <a:t>What we ran into</a:t>
             </a:r>
           </a:p>
         </p:txBody>
@@ -11347,147 +11835,7 @@
         <p:spPr>
           <a:xfrm>
             <a:off x="640080" y="1737360"/>
-            <a:ext cx="5120640" cy="3017520"/>
-          </a:xfrm>
-          <a:prstGeom prst="roundRect">
-            <a:avLst>
-              <a:gd name="adj" fmla="val 8000"/>
-            </a:avLst>
-          </a:prstGeom>
-          <a:solidFill>
-            <a:srgbClr val="0B1F3A"/>
-          </a:solidFill>
-          <a:ln>
-            <a:noFill/>
-          </a:ln>
-          <a:effectLst/>
-        </p:spPr>
-        <p:style>
-          <a:lnRef idx="1">
-            <a:schemeClr val="accent1"/>
-          </a:lnRef>
-          <a:fillRef idx="3">
-            <a:schemeClr val="accent1"/>
-          </a:fillRef>
-          <a:effectRef idx="2">
-            <a:schemeClr val="accent1"/>
-          </a:effectRef>
-          <a:fontRef idx="minor">
-            <a:schemeClr val="lt1"/>
-          </a:fontRef>
-        </p:style>
-        <p:txBody>
-          <a:bodyPr rtlCol="0" anchor="ctr"/>
-          <a:lstStyle/>
-          <a:p>
-            <a:pPr algn="ctr"/>
-          </a:p>
-        </p:txBody>
-      </p:sp>
-      <p:sp>
-        <p:nvSpPr>
-          <p:cNvPr id="6" name="TextBox 5"/>
-          <p:cNvSpPr txBox="1"/>
-          <p:nvPr/>
-        </p:nvSpPr>
-        <p:spPr>
-          <a:xfrm>
-            <a:off x="640080" y="2103120"/>
-            <a:ext cx="5120640" cy="1280160"/>
-          </a:xfrm>
-          <a:prstGeom prst="rect">
-            <a:avLst/>
-          </a:prstGeom>
-          <a:noFill/>
-        </p:spPr>
-        <p:txBody>
-          <a:bodyPr wrap="square" anchor="t">
-            <a:spAutoFit/>
-          </a:bodyPr>
-          <a:lstStyle/>
-          <a:p>
-            <a:pPr algn="ctr">
-              <a:spcAft>
-                <a:spcPts val="600"/>
-              </a:spcAft>
-            </a:pPr>
-            <a:r>
-              <a:rPr sz="7200" b="1">
-                <a:solidFill>
-                  <a:srgbClr val="FFFFFF"/>
-                </a:solidFill>
-                <a:latin typeface="Calibri"/>
-              </a:rPr>
-              <a:t>1.0000</a:t>
-            </a:r>
-          </a:p>
-        </p:txBody>
-      </p:sp>
-      <p:sp>
-        <p:nvSpPr>
-          <p:cNvPr id="7" name="TextBox 6"/>
-          <p:cNvSpPr txBox="1"/>
-          <p:nvPr/>
-        </p:nvSpPr>
-        <p:spPr>
-          <a:xfrm>
-            <a:off x="640080" y="3566160"/>
-            <a:ext cx="5120640" cy="1097280"/>
-          </a:xfrm>
-          <a:prstGeom prst="rect">
-            <a:avLst/>
-          </a:prstGeom>
-          <a:noFill/>
-        </p:spPr>
-        <p:txBody>
-          <a:bodyPr wrap="square" anchor="t">
-            <a:spAutoFit/>
-          </a:bodyPr>
-          <a:lstStyle/>
-          <a:p>
-            <a:pPr algn="ctr">
-              <a:spcAft>
-                <a:spcPts val="600"/>
-              </a:spcAft>
-            </a:pPr>
-            <a:r>
-              <a:rPr sz="1500" b="0">
-                <a:solidFill>
-                  <a:srgbClr val="B8C7D9"/>
-                </a:solidFill>
-                <a:latin typeface="Calibri"/>
-              </a:rPr>
-              <a:t>Final score, rule-based reader</a:t>
-            </a:r>
-          </a:p>
-          <a:p>
-            <a:pPr algn="ctr">
-              <a:spcAft>
-                <a:spcPts val="600"/>
-              </a:spcAft>
-            </a:pPr>
-            <a:r>
-              <a:rPr sz="1500" b="0">
-                <a:solidFill>
-                  <a:srgbClr val="B8C7D9"/>
-                </a:solidFill>
-                <a:latin typeface="Calibri"/>
-              </a:rPr>
-              <a:t>520 emails, 46/46 defects caught, 20/20 escalations right</a:t>
-            </a:r>
-          </a:p>
-        </p:txBody>
-      </p:sp>
-      <p:sp>
-        <p:nvSpPr>
-          <p:cNvPr id="8" name="Rounded Rectangle 7"/>
-          <p:cNvSpPr/>
-          <p:nvPr/>
-        </p:nvSpPr>
-        <p:spPr>
-          <a:xfrm>
-            <a:off x="6035040" y="1737360"/>
-            <a:ext cx="5577840" cy="1417320"/>
+            <a:ext cx="3566160" cy="2194560"/>
           </a:xfrm>
           <a:prstGeom prst="roundRect">
             <a:avLst>
@@ -11526,14 +11874,14 @@
       </p:sp>
       <p:sp>
         <p:nvSpPr>
-          <p:cNvPr id="9" name="Rectangle 8"/>
+          <p:cNvPr id="6" name="Rectangle 5"/>
           <p:cNvSpPr/>
           <p:nvPr/>
         </p:nvSpPr>
         <p:spPr>
           <a:xfrm>
-            <a:off x="6035040" y="1737360"/>
-            <a:ext cx="73152" cy="1417320"/>
+            <a:off x="640080" y="1737360"/>
+            <a:ext cx="73152" cy="2194560"/>
           </a:xfrm>
           <a:prstGeom prst="rect">
             <a:avLst/>
@@ -11570,14 +11918,14 @@
       </p:sp>
       <p:sp>
         <p:nvSpPr>
-          <p:cNvPr id="10" name="TextBox 9"/>
-          <p:cNvSpPr txBox="1"/>
-          <p:nvPr/>
-        </p:nvSpPr>
-        <p:spPr>
-          <a:xfrm>
-            <a:off x="6263640" y="1847088"/>
-            <a:ext cx="5212079" cy="457200"/>
+          <p:cNvPr id="7" name="TextBox 6"/>
+          <p:cNvSpPr txBox="1"/>
+          <p:nvPr/>
+        </p:nvSpPr>
+        <p:spPr>
+          <a:xfrm>
+            <a:off x="868680" y="1847088"/>
+            <a:ext cx="3200400" cy="457200"/>
           </a:xfrm>
           <a:prstGeom prst="rect">
             <a:avLst/>
@@ -11602,21 +11950,21 @@
                 </a:solidFill>
                 <a:latin typeface="Calibri"/>
               </a:rPr>
-              <a:t>Live web app</a:t>
-            </a:r>
-          </a:p>
-        </p:txBody>
-      </p:sp>
-      <p:sp>
-        <p:nvSpPr>
-          <p:cNvPr id="11" name="TextBox 10"/>
-          <p:cNvSpPr txBox="1"/>
-          <p:nvPr/>
-        </p:nvSpPr>
-        <p:spPr>
-          <a:xfrm>
-            <a:off x="6263640" y="2304288"/>
-            <a:ext cx="5212079" cy="777240"/>
+              <a:t>Label variants</a:t>
+            </a:r>
+          </a:p>
+        </p:txBody>
+      </p:sp>
+      <p:sp>
+        <p:nvSpPr>
+          <p:cNvPr id="8" name="TextBox 7"/>
+          <p:cNvSpPr txBox="1"/>
+          <p:nvPr/>
+        </p:nvSpPr>
+        <p:spPr>
+          <a:xfrm>
+            <a:off x="868680" y="2304288"/>
+            <a:ext cx="3200400" cy="1554480"/>
           </a:xfrm>
           <a:prstGeom prst="rect">
             <a:avLst/>
@@ -11641,21 +11989,21 @@
                 </a:solidFill>
                 <a:latin typeface="Calibri"/>
               </a:rPr>
-              <a:t>Upload two documents or browse the sample inbox, in any browser, no sign-in.</a:t>
-            </a:r>
-          </a:p>
-        </p:txBody>
-      </p:sp>
-      <p:sp>
-        <p:nvSpPr>
-          <p:cNvPr id="12" name="Rounded Rectangle 11"/>
+              <a:t>The same field appears under many names across formats and documents.</a:t>
+            </a:r>
+          </a:p>
+        </p:txBody>
+      </p:sp>
+      <p:sp>
+        <p:nvSpPr>
+          <p:cNvPr id="9" name="Rounded Rectangle 8"/>
           <p:cNvSpPr/>
           <p:nvPr/>
         </p:nvSpPr>
         <p:spPr>
           <a:xfrm>
-            <a:off x="6035040" y="3337560"/>
-            <a:ext cx="5577840" cy="1417320"/>
+            <a:off x="4315968" y="1737360"/>
+            <a:ext cx="3566160" cy="2194560"/>
           </a:xfrm>
           <a:prstGeom prst="roundRect">
             <a:avLst>
@@ -11694,14 +12042,518 @@
       </p:sp>
       <p:sp>
         <p:nvSpPr>
-          <p:cNvPr id="13" name="Rectangle 12"/>
+          <p:cNvPr id="10" name="Rectangle 9"/>
           <p:cNvSpPr/>
           <p:nvPr/>
         </p:nvSpPr>
         <p:spPr>
           <a:xfrm>
-            <a:off x="6035040" y="3337560"/>
-            <a:ext cx="73152" cy="1417320"/>
+            <a:off x="4315968" y="1737360"/>
+            <a:ext cx="73152" cy="2194560"/>
+          </a:xfrm>
+          <a:prstGeom prst="rect">
+            <a:avLst/>
+          </a:prstGeom>
+          <a:solidFill>
+            <a:srgbClr val="C77D0A"/>
+          </a:solidFill>
+          <a:ln>
+            <a:noFill/>
+          </a:ln>
+          <a:effectLst/>
+        </p:spPr>
+        <p:style>
+          <a:lnRef idx="1">
+            <a:schemeClr val="accent1"/>
+          </a:lnRef>
+          <a:fillRef idx="3">
+            <a:schemeClr val="accent1"/>
+          </a:fillRef>
+          <a:effectRef idx="2">
+            <a:schemeClr val="accent1"/>
+          </a:effectRef>
+          <a:fontRef idx="minor">
+            <a:schemeClr val="lt1"/>
+          </a:fontRef>
+        </p:style>
+        <p:txBody>
+          <a:bodyPr rtlCol="0" anchor="ctr"/>
+          <a:lstStyle/>
+          <a:p>
+            <a:pPr algn="ctr"/>
+          </a:p>
+        </p:txBody>
+      </p:sp>
+      <p:sp>
+        <p:nvSpPr>
+          <p:cNvPr id="11" name="TextBox 10"/>
+          <p:cNvSpPr txBox="1"/>
+          <p:nvPr/>
+        </p:nvSpPr>
+        <p:spPr>
+          <a:xfrm>
+            <a:off x="4544568" y="1847088"/>
+            <a:ext cx="3200400" cy="457200"/>
+          </a:xfrm>
+          <a:prstGeom prst="rect">
+            <a:avLst/>
+          </a:prstGeom>
+          <a:noFill/>
+        </p:spPr>
+        <p:txBody>
+          <a:bodyPr wrap="square" anchor="t">
+            <a:spAutoFit/>
+          </a:bodyPr>
+          <a:lstStyle/>
+          <a:p>
+            <a:pPr algn="l">
+              <a:spcAft>
+                <a:spcPts val="600"/>
+              </a:spcAft>
+            </a:pPr>
+            <a:r>
+              <a:rPr sz="1700" b="1">
+                <a:solidFill>
+                  <a:srgbClr val="0B1F3A"/>
+                </a:solidFill>
+                <a:latin typeface="Calibri"/>
+              </a:rPr>
+              <a:t>PDF text corruption</a:t>
+            </a:r>
+          </a:p>
+        </p:txBody>
+      </p:sp>
+      <p:sp>
+        <p:nvSpPr>
+          <p:cNvPr id="12" name="TextBox 11"/>
+          <p:cNvSpPr txBox="1"/>
+          <p:nvPr/>
+        </p:nvSpPr>
+        <p:spPr>
+          <a:xfrm>
+            <a:off x="4544568" y="2304288"/>
+            <a:ext cx="3200400" cy="1554480"/>
+          </a:xfrm>
+          <a:prstGeom prst="rect">
+            <a:avLst/>
+          </a:prstGeom>
+          <a:noFill/>
+        </p:spPr>
+        <p:txBody>
+          <a:bodyPr wrap="square" anchor="t">
+            <a:spAutoFit/>
+          </a:bodyPr>
+          <a:lstStyle/>
+          <a:p>
+            <a:pPr algn="l">
+              <a:spcAft>
+                <a:spcPts val="600"/>
+              </a:spcAft>
+            </a:pPr>
+            <a:r>
+              <a:rPr sz="1400" b="0">
+                <a:solidFill>
+                  <a:srgbClr val="1F2937"/>
+                </a:solidFill>
+                <a:latin typeface="Calibri"/>
+              </a:rPr>
+              <a:t>Long labels ran into their values and scrambled the text. Splitting by font weight fixed it.</a:t>
+            </a:r>
+          </a:p>
+        </p:txBody>
+      </p:sp>
+      <p:sp>
+        <p:nvSpPr>
+          <p:cNvPr id="13" name="Rounded Rectangle 12"/>
+          <p:cNvSpPr/>
+          <p:nvPr/>
+        </p:nvSpPr>
+        <p:spPr>
+          <a:xfrm>
+            <a:off x="7991856" y="1737360"/>
+            <a:ext cx="3566160" cy="2194560"/>
+          </a:xfrm>
+          <a:prstGeom prst="roundRect">
+            <a:avLst>
+              <a:gd name="adj" fmla="val 8000"/>
+            </a:avLst>
+          </a:prstGeom>
+          <a:solidFill>
+            <a:srgbClr val="EEF4F7"/>
+          </a:solidFill>
+          <a:ln>
+            <a:noFill/>
+          </a:ln>
+          <a:effectLst/>
+        </p:spPr>
+        <p:style>
+          <a:lnRef idx="1">
+            <a:schemeClr val="accent1"/>
+          </a:lnRef>
+          <a:fillRef idx="3">
+            <a:schemeClr val="accent1"/>
+          </a:fillRef>
+          <a:effectRef idx="2">
+            <a:schemeClr val="accent1"/>
+          </a:effectRef>
+          <a:fontRef idx="minor">
+            <a:schemeClr val="lt1"/>
+          </a:fontRef>
+        </p:style>
+        <p:txBody>
+          <a:bodyPr rtlCol="0" anchor="ctr"/>
+          <a:lstStyle/>
+          <a:p>
+            <a:pPr algn="ctr"/>
+          </a:p>
+        </p:txBody>
+      </p:sp>
+      <p:sp>
+        <p:nvSpPr>
+          <p:cNvPr id="14" name="Rectangle 13"/>
+          <p:cNvSpPr/>
+          <p:nvPr/>
+        </p:nvSpPr>
+        <p:spPr>
+          <a:xfrm>
+            <a:off x="7991856" y="1737360"/>
+            <a:ext cx="73152" cy="2194560"/>
+          </a:xfrm>
+          <a:prstGeom prst="rect">
+            <a:avLst/>
+          </a:prstGeom>
+          <a:solidFill>
+            <a:srgbClr val="C0392B"/>
+          </a:solidFill>
+          <a:ln>
+            <a:noFill/>
+          </a:ln>
+          <a:effectLst/>
+        </p:spPr>
+        <p:style>
+          <a:lnRef idx="1">
+            <a:schemeClr val="accent1"/>
+          </a:lnRef>
+          <a:fillRef idx="3">
+            <a:schemeClr val="accent1"/>
+          </a:fillRef>
+          <a:effectRef idx="2">
+            <a:schemeClr val="accent1"/>
+          </a:effectRef>
+          <a:fontRef idx="minor">
+            <a:schemeClr val="lt1"/>
+          </a:fontRef>
+        </p:style>
+        <p:txBody>
+          <a:bodyPr rtlCol="0" anchor="ctr"/>
+          <a:lstStyle/>
+          <a:p>
+            <a:pPr algn="ctr"/>
+          </a:p>
+        </p:txBody>
+      </p:sp>
+      <p:sp>
+        <p:nvSpPr>
+          <p:cNvPr id="15" name="TextBox 14"/>
+          <p:cNvSpPr txBox="1"/>
+          <p:nvPr/>
+        </p:nvSpPr>
+        <p:spPr>
+          <a:xfrm>
+            <a:off x="8220456" y="1847088"/>
+            <a:ext cx="3200400" cy="457200"/>
+          </a:xfrm>
+          <a:prstGeom prst="rect">
+            <a:avLst/>
+          </a:prstGeom>
+          <a:noFill/>
+        </p:spPr>
+        <p:txBody>
+          <a:bodyPr wrap="square" anchor="t">
+            <a:spAutoFit/>
+          </a:bodyPr>
+          <a:lstStyle/>
+          <a:p>
+            <a:pPr algn="l">
+              <a:spcAft>
+                <a:spcPts val="600"/>
+              </a:spcAft>
+            </a:pPr>
+            <a:r>
+              <a:rPr sz="1700" b="1">
+                <a:solidFill>
+                  <a:srgbClr val="0B1F3A"/>
+                </a:solidFill>
+                <a:latin typeface="Calibri"/>
+              </a:rPr>
+              <a:t>Scanned documents</a:t>
+            </a:r>
+          </a:p>
+        </p:txBody>
+      </p:sp>
+      <p:sp>
+        <p:nvSpPr>
+          <p:cNvPr id="16" name="TextBox 15"/>
+          <p:cNvSpPr txBox="1"/>
+          <p:nvPr/>
+        </p:nvSpPr>
+        <p:spPr>
+          <a:xfrm>
+            <a:off x="8220456" y="2304288"/>
+            <a:ext cx="3200400" cy="1554480"/>
+          </a:xfrm>
+          <a:prstGeom prst="rect">
+            <a:avLst/>
+          </a:prstGeom>
+          <a:noFill/>
+        </p:spPr>
+        <p:txBody>
+          <a:bodyPr wrap="square" anchor="t">
+            <a:spAutoFit/>
+          </a:bodyPr>
+          <a:lstStyle/>
+          <a:p>
+            <a:pPr algn="l">
+              <a:spcAft>
+                <a:spcPts val="600"/>
+              </a:spcAft>
+            </a:pPr>
+            <a:r>
+              <a:rPr sz="1400" b="0">
+                <a:solidFill>
+                  <a:srgbClr val="1F2937"/>
+                </a:solidFill>
+                <a:latin typeface="Calibri"/>
+              </a:rPr>
+              <a:t>Image-only pages can't be trusted, so they always go to a human.</a:t>
+            </a:r>
+          </a:p>
+        </p:txBody>
+      </p:sp>
+      <p:sp>
+        <p:nvSpPr>
+          <p:cNvPr id="17" name="Rounded Rectangle 16"/>
+          <p:cNvSpPr/>
+          <p:nvPr/>
+        </p:nvSpPr>
+        <p:spPr>
+          <a:xfrm>
+            <a:off x="640080" y="4114800"/>
+            <a:ext cx="5486400" cy="2011680"/>
+          </a:xfrm>
+          <a:prstGeom prst="roundRect">
+            <a:avLst>
+              <a:gd name="adj" fmla="val 8000"/>
+            </a:avLst>
+          </a:prstGeom>
+          <a:solidFill>
+            <a:srgbClr val="EEF4F7"/>
+          </a:solidFill>
+          <a:ln>
+            <a:noFill/>
+          </a:ln>
+          <a:effectLst/>
+        </p:spPr>
+        <p:style>
+          <a:lnRef idx="1">
+            <a:schemeClr val="accent1"/>
+          </a:lnRef>
+          <a:fillRef idx="3">
+            <a:schemeClr val="accent1"/>
+          </a:fillRef>
+          <a:effectRef idx="2">
+            <a:schemeClr val="accent1"/>
+          </a:effectRef>
+          <a:fontRef idx="minor">
+            <a:schemeClr val="lt1"/>
+          </a:fontRef>
+        </p:style>
+        <p:txBody>
+          <a:bodyPr rtlCol="0" anchor="ctr"/>
+          <a:lstStyle/>
+          <a:p>
+            <a:pPr algn="ctr"/>
+          </a:p>
+        </p:txBody>
+      </p:sp>
+      <p:sp>
+        <p:nvSpPr>
+          <p:cNvPr id="18" name="Rectangle 17"/>
+          <p:cNvSpPr/>
+          <p:nvPr/>
+        </p:nvSpPr>
+        <p:spPr>
+          <a:xfrm>
+            <a:off x="640080" y="4114800"/>
+            <a:ext cx="73152" cy="2011680"/>
+          </a:xfrm>
+          <a:prstGeom prst="rect">
+            <a:avLst/>
+          </a:prstGeom>
+          <a:solidFill>
+            <a:srgbClr val="0E9F9A"/>
+          </a:solidFill>
+          <a:ln>
+            <a:noFill/>
+          </a:ln>
+          <a:effectLst/>
+        </p:spPr>
+        <p:style>
+          <a:lnRef idx="1">
+            <a:schemeClr val="accent1"/>
+          </a:lnRef>
+          <a:fillRef idx="3">
+            <a:schemeClr val="accent1"/>
+          </a:fillRef>
+          <a:effectRef idx="2">
+            <a:schemeClr val="accent1"/>
+          </a:effectRef>
+          <a:fontRef idx="minor">
+            <a:schemeClr val="lt1"/>
+          </a:fontRef>
+        </p:style>
+        <p:txBody>
+          <a:bodyPr rtlCol="0" anchor="ctr"/>
+          <a:lstStyle/>
+          <a:p>
+            <a:pPr algn="ctr"/>
+          </a:p>
+        </p:txBody>
+      </p:sp>
+      <p:sp>
+        <p:nvSpPr>
+          <p:cNvPr id="19" name="TextBox 18"/>
+          <p:cNvSpPr txBox="1"/>
+          <p:nvPr/>
+        </p:nvSpPr>
+        <p:spPr>
+          <a:xfrm>
+            <a:off x="868680" y="4224528"/>
+            <a:ext cx="5120640" cy="457200"/>
+          </a:xfrm>
+          <a:prstGeom prst="rect">
+            <a:avLst/>
+          </a:prstGeom>
+          <a:noFill/>
+        </p:spPr>
+        <p:txBody>
+          <a:bodyPr wrap="square" anchor="t">
+            <a:spAutoFit/>
+          </a:bodyPr>
+          <a:lstStyle/>
+          <a:p>
+            <a:pPr algn="l">
+              <a:spcAft>
+                <a:spcPts val="600"/>
+              </a:spcAft>
+            </a:pPr>
+            <a:r>
+              <a:rPr sz="1700" b="1">
+                <a:solidFill>
+                  <a:srgbClr val="0B1F3A"/>
+                </a:solidFill>
+                <a:latin typeface="Calibri"/>
+              </a:rPr>
+              <a:t>Inconsistent AI output</a:t>
+            </a:r>
+          </a:p>
+        </p:txBody>
+      </p:sp>
+      <p:sp>
+        <p:nvSpPr>
+          <p:cNvPr id="20" name="TextBox 19"/>
+          <p:cNvSpPr txBox="1"/>
+          <p:nvPr/>
+        </p:nvSpPr>
+        <p:spPr>
+          <a:xfrm>
+            <a:off x="868680" y="4681728"/>
+            <a:ext cx="5120640" cy="1371600"/>
+          </a:xfrm>
+          <a:prstGeom prst="rect">
+            <a:avLst/>
+          </a:prstGeom>
+          <a:noFill/>
+        </p:spPr>
+        <p:txBody>
+          <a:bodyPr wrap="square" anchor="t">
+            <a:spAutoFit/>
+          </a:bodyPr>
+          <a:lstStyle/>
+          <a:p>
+            <a:pPr algn="l">
+              <a:spcAft>
+                <a:spcPts val="600"/>
+              </a:spcAft>
+            </a:pPr>
+            <a:r>
+              <a:rPr sz="1400" b="0">
+                <a:solidFill>
+                  <a:srgbClr val="1F2937"/>
+                </a:solidFill>
+                <a:latin typeface="Calibri"/>
+              </a:rPr>
+              <a:t>The AI sometimes shortened a port name on one document but not the other, creating false mismatches. We tightened the prompt, and scans always go to a human.</a:t>
+            </a:r>
+          </a:p>
+        </p:txBody>
+      </p:sp>
+      <p:sp>
+        <p:nvSpPr>
+          <p:cNvPr id="21" name="Rounded Rectangle 20"/>
+          <p:cNvSpPr/>
+          <p:nvPr/>
+        </p:nvSpPr>
+        <p:spPr>
+          <a:xfrm>
+            <a:off x="6309360" y="4114800"/>
+            <a:ext cx="5303520" cy="2011680"/>
+          </a:xfrm>
+          <a:prstGeom prst="roundRect">
+            <a:avLst>
+              <a:gd name="adj" fmla="val 8000"/>
+            </a:avLst>
+          </a:prstGeom>
+          <a:solidFill>
+            <a:srgbClr val="EEF4F7"/>
+          </a:solidFill>
+          <a:ln>
+            <a:noFill/>
+          </a:ln>
+          <a:effectLst/>
+        </p:spPr>
+        <p:style>
+          <a:lnRef idx="1">
+            <a:schemeClr val="accent1"/>
+          </a:lnRef>
+          <a:fillRef idx="3">
+            <a:schemeClr val="accent1"/>
+          </a:fillRef>
+          <a:effectRef idx="2">
+            <a:schemeClr val="accent1"/>
+          </a:effectRef>
+          <a:fontRef idx="minor">
+            <a:schemeClr val="lt1"/>
+          </a:fontRef>
+        </p:style>
+        <p:txBody>
+          <a:bodyPr rtlCol="0" anchor="ctr"/>
+          <a:lstStyle/>
+          <a:p>
+            <a:pPr algn="ctr"/>
+          </a:p>
+        </p:txBody>
+      </p:sp>
+      <p:sp>
+        <p:nvSpPr>
+          <p:cNvPr id="22" name="Rectangle 21"/>
+          <p:cNvSpPr/>
+          <p:nvPr/>
+        </p:nvSpPr>
+        <p:spPr>
+          <a:xfrm>
+            <a:off x="6309360" y="4114800"/>
+            <a:ext cx="73152" cy="2011680"/>
           </a:xfrm>
           <a:prstGeom prst="rect">
             <a:avLst/>
@@ -11738,14 +12590,14 @@
       </p:sp>
       <p:sp>
         <p:nvSpPr>
-          <p:cNvPr id="14" name="TextBox 13"/>
-          <p:cNvSpPr txBox="1"/>
-          <p:nvPr/>
-        </p:nvSpPr>
-        <p:spPr>
-          <a:xfrm>
-            <a:off x="6263640" y="3447288"/>
-            <a:ext cx="5212079" cy="457200"/>
+          <p:cNvPr id="23" name="TextBox 22"/>
+          <p:cNvSpPr txBox="1"/>
+          <p:nvPr/>
+        </p:nvSpPr>
+        <p:spPr>
+          <a:xfrm>
+            <a:off x="6537960" y="4224528"/>
+            <a:ext cx="4937759" cy="457200"/>
           </a:xfrm>
           <a:prstGeom prst="rect">
             <a:avLst/>
@@ -11770,21 +12622,21 @@
                 </a:solidFill>
                 <a:latin typeface="Calibri"/>
               </a:rPr>
-              <a:t>AI reading</a:t>
-            </a:r>
-          </a:p>
-        </p:txBody>
-      </p:sp>
-      <p:sp>
-        <p:nvSpPr>
-          <p:cNvPr id="15" name="TextBox 14"/>
-          <p:cNvSpPr txBox="1"/>
-          <p:nvPr/>
-        </p:nvSpPr>
-        <p:spPr>
-          <a:xfrm>
-            <a:off x="6263640" y="3904487"/>
-            <a:ext cx="5212079" cy="777240"/>
+              <a:t>A stray space in the API key</a:t>
+            </a:r>
+          </a:p>
+        </p:txBody>
+      </p:sp>
+      <p:sp>
+        <p:nvSpPr>
+          <p:cNvPr id="24" name="TextBox 23"/>
+          <p:cNvSpPr txBox="1"/>
+          <p:nvPr/>
+        </p:nvSpPr>
+        <p:spPr>
+          <a:xfrm>
+            <a:off x="6537960" y="4681728"/>
+            <a:ext cx="4937759" cy="1371600"/>
           </a:xfrm>
           <a:prstGeom prst="rect">
             <a:avLst/>
@@ -11809,46 +12661,7 @@
                 </a:solidFill>
                 <a:latin typeface="Calibri"/>
               </a:rPr>
-              <a:t>Claude reads every format including scans. Decisions stay in plain code.</a:t>
-            </a:r>
-          </a:p>
-        </p:txBody>
-      </p:sp>
-      <p:sp>
-        <p:nvSpPr>
-          <p:cNvPr id="16" name="TextBox 15"/>
-          <p:cNvSpPr txBox="1"/>
-          <p:nvPr/>
-        </p:nvSpPr>
-        <p:spPr>
-          <a:xfrm>
-            <a:off x="640080" y="5120640"/>
-            <a:ext cx="10972800" cy="914400"/>
-          </a:xfrm>
-          <a:prstGeom prst="rect">
-            <a:avLst/>
-          </a:prstGeom>
-          <a:noFill/>
-        </p:spPr>
-        <p:txBody>
-          <a:bodyPr wrap="square" anchor="t">
-            <a:spAutoFit/>
-          </a:bodyPr>
-          <a:lstStyle/>
-          <a:p>
-            <a:pPr algn="l">
-              <a:spcAft>
-                <a:spcPts val="600"/>
-              </a:spcAft>
-            </a:pPr>
-            <a:r>
-              <a:rPr sz="1400" b="0">
-                <a:solidFill>
-                  <a:srgbClr val="C77D0A"/>
-                </a:solidFill>
-                <a:latin typeface="Calibri"/>
-              </a:rPr>
-              <a:t>[Fill in the AI-reader score here after the full AI run, or remove this line.]</a:t>
+              <a:t>An invisible trailing character broke every request. The key is now trimmed in code.</a:t>
             </a:r>
           </a:p>
         </p:txBody>

</xml_diff>